<commit_message>
Replace agenda slide with leadership narrative 3-box layout
New slide 02 drops the 5-item card list in favour of a concise
story-driven layout: hero statement bar (~$609M / $207M hook),
three connected boxes (The Asset → The Problem → The Plan) with
short titles, one-sentence bodies, and slide-reference tags at the
bottom of each box. Connector arrows link the boxes left to right.

https://claude.ai/code/session_01KWybSEC2vfMTAERCxx1Z2W
</commit_message>
<xml_diff>
--- a/public/Inventory-at-Asurion.pptx
+++ b/public/Inventory-at-Asurion.pptx
@@ -2119,7 +2119,7 @@
         </p:nvSpPr>
         <p:spPr>
           <a:xfrm>
-            <a:off x="365760" y="320040"/>
+            <a:off x="365760" y="292608"/>
             <a:ext cx="7315200" cy="182880"/>
           </a:xfrm>
           <a:prstGeom prst="rect">
@@ -2158,8 +2158,8 @@
         </p:nvSpPr>
         <p:spPr>
           <a:xfrm>
-            <a:off x="365760" y="548640"/>
-            <a:ext cx="7315200" cy="914400"/>
+            <a:off x="365760" y="502920"/>
+            <a:ext cx="11457432" cy="640080"/>
           </a:xfrm>
           <a:prstGeom prst="rect">
             <a:avLst/>
@@ -2175,7 +2175,7 @@
               <a:buNone/>
             </a:pPr>
             <a:r>
-              <a:rPr lang="en-US" sz="4400" dirty="0">
+              <a:rPr lang="en-US" sz="3000" dirty="0">
                 <a:solidFill>
                   <a:srgbClr val="111111"/>
                 </a:solidFill>
@@ -2183,9 +2183,9 @@
                 <a:ea typeface="Calibri Light" pitchFamily="34" charset="-122"/>
                 <a:cs typeface="Calibri Light" pitchFamily="34" charset="-120"/>
               </a:rPr>
-              <a:t>Agenda</a:t>
-            </a:r>
-            <a:endParaRPr lang="en-US" sz="4400" dirty="0"/>
+              <a:t>What we're covering — and why it matters</a:t>
+            </a:r>
+            <a:endParaRPr lang="en-US" sz="3000" dirty="0"/>
           </a:p>
         </p:txBody>
       </p:sp>
@@ -2197,12 +2197,162 @@
         </p:nvSpPr>
         <p:spPr>
           <a:xfrm>
-            <a:off x="365760" y="1664208"/>
-            <a:ext cx="5591556" cy="768096"/>
+            <a:off x="365760" y="1261872"/>
+            <a:ext cx="11457432" cy="658368"/>
           </a:xfrm>
           <a:prstGeom prst="roundRect">
             <a:avLst>
-              <a:gd name="adj" fmla="val 7143"/>
+              <a:gd name="adj" fmla="val 8333"/>
+            </a:avLst>
+          </a:prstGeom>
+          <a:solidFill>
+            <a:srgbClr val="EDE8F5"/>
+          </a:solidFill>
+          <a:ln w="9525">
+            <a:solidFill>
+              <a:srgbClr val="C4AEED"/>
+            </a:solidFill>
+            <a:prstDash val="solid"/>
+          </a:ln>
+        </p:spPr>
+      </p:sp>
+      <p:sp>
+        <p:nvSpPr>
+          <p:cNvPr id="5" name="Text 3"/>
+          <p:cNvSpPr/>
+          <p:nvPr/>
+        </p:nvSpPr>
+        <p:spPr>
+          <a:xfrm>
+            <a:off x="640080" y="1316736"/>
+            <a:ext cx="10908792" cy="548640"/>
+          </a:xfrm>
+          <a:prstGeom prst="rect">
+            <a:avLst/>
+          </a:prstGeom>
+          <a:noFill/>
+          <a:ln/>
+        </p:spPr>
+        <p:txBody>
+          <a:bodyPr wrap="square" rtlCol="0" anchor="ctr"/>
+          <a:lstStyle/>
+          <a:p>
+            <a:pPr indent="0" marL="0">
+              <a:buNone/>
+            </a:pPr>
+            <a:r>
+              <a:rPr lang="en-US" sz="1100" dirty="0">
+                <a:solidFill>
+                  <a:srgbClr val="333333"/>
+                </a:solidFill>
+                <a:latin typeface="Calibri" pitchFamily="34" charset="0"/>
+                <a:ea typeface="Calibri" pitchFamily="34" charset="-122"/>
+                <a:cs typeface="Calibri" pitchFamily="34" charset="-120"/>
+              </a:rPr>
+              <a:t>Inventory is a </a:t>
+            </a:r>
+            <a:pPr indent="0" marL="0">
+              <a:buNone/>
+            </a:pPr>
+            <a:r>
+              <a:rPr lang="en-US" sz="1100" b="1" dirty="0">
+                <a:solidFill>
+                  <a:srgbClr val="5B2C8D"/>
+                </a:solidFill>
+                <a:latin typeface="Calibri" pitchFamily="34" charset="0"/>
+                <a:ea typeface="Calibri" pitchFamily="34" charset="-122"/>
+                <a:cs typeface="Calibri" pitchFamily="34" charset="-120"/>
+              </a:rPr>
+              <a:t>~$609M asset</a:t>
+            </a:r>
+            <a:pPr indent="0" marL="0">
+              <a:buNone/>
+            </a:pPr>
+            <a:r>
+              <a:rPr lang="en-US" sz="1100" dirty="0">
+                <a:solidFill>
+                  <a:srgbClr val="333333"/>
+                </a:solidFill>
+                <a:latin typeface="Calibri" pitchFamily="34" charset="0"/>
+                <a:ea typeface="Calibri" pitchFamily="34" charset="-122"/>
+                <a:cs typeface="Calibri" pitchFamily="34" charset="-120"/>
+              </a:rPr>
+              <a:t> moving across </a:t>
+            </a:r>
+            <a:pPr indent="0" marL="0">
+              <a:buNone/>
+            </a:pPr>
+            <a:r>
+              <a:rPr lang="en-US" sz="1100" b="1" dirty="0">
+                <a:solidFill>
+                  <a:srgbClr val="5B2C8D"/>
+                </a:solidFill>
+                <a:latin typeface="Calibri" pitchFamily="34" charset="0"/>
+                <a:ea typeface="Calibri" pitchFamily="34" charset="-122"/>
+                <a:cs typeface="Calibri" pitchFamily="34" charset="-120"/>
+              </a:rPr>
+              <a:t>~890 locations</a:t>
+            </a:r>
+            <a:pPr indent="0" marL="0">
+              <a:buNone/>
+            </a:pPr>
+            <a:r>
+              <a:rPr lang="en-US" sz="1100" dirty="0">
+                <a:solidFill>
+                  <a:srgbClr val="333333"/>
+                </a:solidFill>
+                <a:latin typeface="Calibri" pitchFamily="34" charset="0"/>
+                <a:ea typeface="Calibri" pitchFamily="34" charset="-122"/>
+                <a:cs typeface="Calibri" pitchFamily="34" charset="-120"/>
+              </a:rPr>
+              <a:t> every day. Today, </a:t>
+            </a:r>
+            <a:pPr indent="0" marL="0">
+              <a:buNone/>
+            </a:pPr>
+            <a:r>
+              <a:rPr lang="en-US" sz="1100" b="1" dirty="0">
+                <a:solidFill>
+                  <a:srgbClr val="5B2C8D"/>
+                </a:solidFill>
+                <a:latin typeface="Calibri" pitchFamily="34" charset="0"/>
+                <a:ea typeface="Calibri" pitchFamily="34" charset="-122"/>
+                <a:cs typeface="Calibri" pitchFamily="34" charset="-120"/>
+              </a:rPr>
+              <a:t>$207M of it lives outside our ERP</a:t>
+            </a:r>
+            <a:pPr indent="0" marL="0">
+              <a:buNone/>
+            </a:pPr>
+            <a:r>
+              <a:rPr lang="en-US" sz="1100" dirty="0">
+                <a:solidFill>
+                  <a:srgbClr val="333333"/>
+                </a:solidFill>
+                <a:latin typeface="Calibri" pitchFamily="34" charset="0"/>
+                <a:ea typeface="Calibri" pitchFamily="34" charset="-122"/>
+                <a:cs typeface="Calibri" pitchFamily="34" charset="-120"/>
+              </a:rPr>
+              <a:t> — creating financial blind spots, reconciliation gaps, and operational risk. This session explains what we have, what's broken, and the plan to fix it.</a:t>
+            </a:r>
+            <a:endParaRPr lang="en-US" sz="1100" dirty="0"/>
+          </a:p>
+        </p:txBody>
+      </p:sp>
+      <p:sp>
+        <p:nvSpPr>
+          <p:cNvPr id="6" name="Shape 4"/>
+          <p:cNvSpPr/>
+          <p:nvPr/>
+        </p:nvSpPr>
+        <p:spPr>
+          <a:xfrm>
+            <a:off x="365760" y="2103120"/>
+            <a:ext cx="3697224" cy="3474720"/>
+          </a:xfrm>
+          <a:prstGeom prst="roundRect">
+            <a:avLst>
+              <a:gd name="adj" fmla="val 1842"/>
             </a:avLst>
           </a:prstGeom>
           <a:solidFill>
@@ -2218,19 +2368,69 @@
       </p:sp>
       <p:sp>
         <p:nvSpPr>
-          <p:cNvPr id="5" name="Shape 3"/>
-          <p:cNvSpPr/>
-          <p:nvPr/>
-        </p:nvSpPr>
-        <p:spPr>
-          <a:xfrm>
-            <a:off x="512064" y="1792224"/>
-            <a:ext cx="457200" cy="457200"/>
+          <p:cNvPr id="7" name="Shape 5"/>
+          <p:cNvSpPr/>
+          <p:nvPr/>
+        </p:nvSpPr>
+        <p:spPr>
+          <a:xfrm>
+            <a:off x="365760" y="2103120"/>
+            <a:ext cx="3697224" cy="658368"/>
           </a:xfrm>
           <a:prstGeom prst="roundRect">
             <a:avLst>
-              <a:gd name="adj" fmla="val 16000"/>
+              <a:gd name="adj" fmla="val 9722"/>
             </a:avLst>
+          </a:prstGeom>
+          <a:solidFill>
+            <a:srgbClr val="F5F4F8"/>
+          </a:solidFill>
+          <a:ln w="12700">
+            <a:solidFill>
+              <a:srgbClr val="F5F4F8"/>
+            </a:solidFill>
+            <a:prstDash val="solid"/>
+          </a:ln>
+        </p:spPr>
+      </p:sp>
+      <p:sp>
+        <p:nvSpPr>
+          <p:cNvPr id="8" name="Shape 6"/>
+          <p:cNvSpPr/>
+          <p:nvPr/>
+        </p:nvSpPr>
+        <p:spPr>
+          <a:xfrm>
+            <a:off x="365760" y="2578608"/>
+            <a:ext cx="3697224" cy="182880"/>
+          </a:xfrm>
+          <a:prstGeom prst="rect">
+            <a:avLst/>
+          </a:prstGeom>
+          <a:solidFill>
+            <a:srgbClr val="F5F4F8"/>
+          </a:solidFill>
+          <a:ln w="12700">
+            <a:solidFill>
+              <a:srgbClr val="F5F4F8"/>
+            </a:solidFill>
+            <a:prstDash val="solid"/>
+          </a:ln>
+        </p:spPr>
+      </p:sp>
+      <p:sp>
+        <p:nvSpPr>
+          <p:cNvPr id="9" name="Shape 7"/>
+          <p:cNvSpPr/>
+          <p:nvPr/>
+        </p:nvSpPr>
+        <p:spPr>
+          <a:xfrm>
+            <a:off x="548640" y="2194560"/>
+            <a:ext cx="384048" cy="384048"/>
+          </a:xfrm>
+          <a:prstGeom prst="ellipse">
+            <a:avLst/>
           </a:prstGeom>
           <a:solidFill>
             <a:srgbClr val="5B2C8D"/>
@@ -2245,14 +2445,14 @@
       </p:sp>
       <p:sp>
         <p:nvSpPr>
-          <p:cNvPr id="6" name="Text 4"/>
-          <p:cNvSpPr/>
-          <p:nvPr/>
-        </p:nvSpPr>
-        <p:spPr>
-          <a:xfrm>
-            <a:off x="512064" y="1792224"/>
-            <a:ext cx="457200" cy="457200"/>
+          <p:cNvPr id="10" name="Text 8"/>
+          <p:cNvSpPr/>
+          <p:nvPr/>
+        </p:nvSpPr>
+        <p:spPr>
+          <a:xfrm>
+            <a:off x="548640" y="2194560"/>
+            <a:ext cx="384048" cy="384048"/>
           </a:xfrm>
           <a:prstGeom prst="rect">
             <a:avLst/>
@@ -2268,30 +2468,148 @@
               <a:buNone/>
             </a:pPr>
             <a:r>
+              <a:rPr lang="en-US" sz="1100" b="1" dirty="0">
+                <a:solidFill>
+                  <a:srgbClr val="FFFFFF"/>
+                </a:solidFill>
+                <a:latin typeface="Calibri" pitchFamily="34" charset="0"/>
+                <a:ea typeface="Calibri" pitchFamily="34" charset="-122"/>
+                <a:cs typeface="Calibri" pitchFamily="34" charset="-120"/>
+              </a:rPr>
+              <a:t>01</a:t>
+            </a:r>
+            <a:endParaRPr lang="en-US" sz="1100" dirty="0"/>
+          </a:p>
+        </p:txBody>
+      </p:sp>
+      <p:sp>
+        <p:nvSpPr>
+          <p:cNvPr id="11" name="Text 9"/>
+          <p:cNvSpPr/>
+          <p:nvPr/>
+        </p:nvSpPr>
+        <p:spPr>
+          <a:xfrm>
+            <a:off x="1060704" y="2267712"/>
+            <a:ext cx="2874264" cy="237744"/>
+          </a:xfrm>
+          <a:prstGeom prst="rect">
+            <a:avLst/>
+          </a:prstGeom>
+          <a:noFill/>
+          <a:ln/>
+        </p:spPr>
+        <p:txBody>
+          <a:bodyPr wrap="square" rtlCol="0" anchor="ctr"/>
+          <a:lstStyle/>
+          <a:p>
+            <a:pPr indent="0" marL="0">
+              <a:buNone/>
+            </a:pPr>
+            <a:r>
+              <a:rPr lang="en-US" sz="800" b="1" spc="150" kern="0" dirty="0">
+                <a:solidFill>
+                  <a:srgbClr val="5B2C8D"/>
+                </a:solidFill>
+                <a:latin typeface="Calibri" pitchFamily="34" charset="0"/>
+                <a:ea typeface="Calibri" pitchFamily="34" charset="-122"/>
+                <a:cs typeface="Calibri" pitchFamily="34" charset="-120"/>
+              </a:rPr>
+              <a:t>THE ASSET</a:t>
+            </a:r>
+            <a:endParaRPr lang="en-US" sz="800" dirty="0"/>
+          </a:p>
+        </p:txBody>
+      </p:sp>
+      <p:sp>
+        <p:nvSpPr>
+          <p:cNvPr id="12" name="Shape 10"/>
+          <p:cNvSpPr/>
+          <p:nvPr/>
+        </p:nvSpPr>
+        <p:spPr>
+          <a:xfrm>
+            <a:off x="548640" y="2779776"/>
+            <a:ext cx="3331464" cy="0"/>
+          </a:xfrm>
+          <a:prstGeom prst="line">
+            <a:avLst/>
+          </a:prstGeom>
+          <a:noFill/>
+          <a:ln w="6350">
+            <a:solidFill>
+              <a:srgbClr val="DDDDDD"/>
+            </a:solidFill>
+            <a:prstDash val="solid"/>
+          </a:ln>
+        </p:spPr>
+      </p:sp>
+      <p:sp>
+        <p:nvSpPr>
+          <p:cNvPr id="13" name="Text 11"/>
+          <p:cNvSpPr/>
+          <p:nvPr/>
+        </p:nvSpPr>
+        <p:spPr>
+          <a:xfrm>
+            <a:off x="548640" y="2871216"/>
+            <a:ext cx="3331464" cy="658368"/>
+          </a:xfrm>
+          <a:prstGeom prst="rect">
+            <a:avLst/>
+          </a:prstGeom>
+          <a:noFill/>
+          <a:ln/>
+        </p:spPr>
+        <p:txBody>
+          <a:bodyPr wrap="square" rtlCol="0" anchor="t"/>
+          <a:lstStyle/>
+          <a:p>
+            <a:pPr indent="0" marL="0">
+              <a:buNone/>
+            </a:pPr>
+            <a:r>
               <a:rPr lang="en-US" sz="1300" b="1" dirty="0">
                 <a:solidFill>
-                  <a:srgbClr val="FFFFFF"/>
-                </a:solidFill>
-                <a:latin typeface="Calibri" pitchFamily="34" charset="0"/>
-                <a:ea typeface="Calibri" pitchFamily="34" charset="-122"/>
-                <a:cs typeface="Calibri" pitchFamily="34" charset="-120"/>
-              </a:rPr>
-              <a:t>1</a:t>
+                  <a:srgbClr val="111111"/>
+                </a:solidFill>
+                <a:latin typeface="Calibri Light" pitchFamily="34" charset="0"/>
+                <a:ea typeface="Calibri Light" pitchFamily="34" charset="-122"/>
+                <a:cs typeface="Calibri Light" pitchFamily="34" charset="-120"/>
+              </a:rPr>
+              <a:t>What inventory is</a:t>
             </a:r>
             <a:endParaRPr lang="en-US" sz="1300" dirty="0"/>
           </a:p>
-        </p:txBody>
-      </p:sp>
-      <p:sp>
-        <p:nvSpPr>
-          <p:cNvPr id="7" name="Text 5"/>
-          <p:cNvSpPr/>
-          <p:nvPr/>
-        </p:nvSpPr>
-        <p:spPr>
-          <a:xfrm>
-            <a:off x="1115568" y="1792224"/>
-            <a:ext cx="4695444" cy="368686"/>
+          <a:p>
+            <a:pPr indent="0" marL="0">
+              <a:buNone/>
+            </a:pPr>
+            <a:r>
+              <a:rPr lang="en-US" sz="1300" b="1" dirty="0">
+                <a:solidFill>
+                  <a:srgbClr val="111111"/>
+                </a:solidFill>
+                <a:latin typeface="Calibri Light" pitchFamily="34" charset="0"/>
+                <a:ea typeface="Calibri Light" pitchFamily="34" charset="-122"/>
+                <a:cs typeface="Calibri Light" pitchFamily="34" charset="-120"/>
+              </a:rPr>
+              <a:t>and where it lives</a:t>
+            </a:r>
+            <a:endParaRPr lang="en-US" sz="1300" dirty="0"/>
+          </a:p>
+        </p:txBody>
+      </p:sp>
+      <p:sp>
+        <p:nvSpPr>
+          <p:cNvPr id="14" name="Text 12"/>
+          <p:cNvSpPr/>
+          <p:nvPr/>
+        </p:nvSpPr>
+        <p:spPr>
+          <a:xfrm>
+            <a:off x="548640" y="3621024"/>
+            <a:ext cx="3331464" cy="1508760"/>
           </a:xfrm>
           <a:prstGeom prst="rect">
             <a:avLst/>
@@ -2307,73 +2625,100 @@
               <a:buNone/>
             </a:pPr>
             <a:r>
-              <a:rPr lang="en-US" sz="1100" b="1" dirty="0">
-                <a:solidFill>
-                  <a:srgbClr val="111111"/>
-                </a:solidFill>
-                <a:latin typeface="Calibri" pitchFamily="34" charset="0"/>
-                <a:ea typeface="Calibri" pitchFamily="34" charset="-122"/>
-                <a:cs typeface="Calibri" pitchFamily="34" charset="-120"/>
-              </a:rPr>
-              <a:t>Inventory Supports Every Fulfillment Motion Across Asurion's Service Network</a:t>
-            </a:r>
-            <a:endParaRPr lang="en-US" sz="1100" dirty="0"/>
-          </a:p>
-        </p:txBody>
-      </p:sp>
-      <p:sp>
-        <p:nvSpPr>
-          <p:cNvPr id="8" name="Text 6"/>
-          <p:cNvSpPr/>
-          <p:nvPr/>
-        </p:nvSpPr>
-        <p:spPr>
-          <a:xfrm>
-            <a:off x="1115568" y="2063618"/>
-            <a:ext cx="4695444" cy="307238"/>
-          </a:xfrm>
-          <a:prstGeom prst="rect">
-            <a:avLst/>
-          </a:prstGeom>
-          <a:noFill/>
-          <a:ln/>
-        </p:spPr>
-        <p:txBody>
-          <a:bodyPr wrap="square" rtlCol="0" anchor="t"/>
-          <a:lstStyle/>
-          <a:p>
-            <a:pPr indent="0" marL="0">
-              <a:buNone/>
-            </a:pPr>
-            <a:r>
-              <a:rPr lang="en-US" sz="900" dirty="0">
-                <a:solidFill>
-                  <a:srgbClr val="888888"/>
-                </a:solidFill>
-                <a:latin typeface="Calibri" pitchFamily="34" charset="0"/>
-                <a:ea typeface="Calibri" pitchFamily="34" charset="-122"/>
-                <a:cs typeface="Calibri" pitchFamily="34" charset="-120"/>
-              </a:rPr>
-              <a:t>What inventory is, where it lives, and the service motions it enables</a:t>
-            </a:r>
-            <a:endParaRPr lang="en-US" sz="900" dirty="0"/>
-          </a:p>
-        </p:txBody>
-      </p:sp>
-      <p:sp>
-        <p:nvSpPr>
-          <p:cNvPr id="9" name="Shape 7"/>
-          <p:cNvSpPr/>
-          <p:nvPr/>
-        </p:nvSpPr>
-        <p:spPr>
-          <a:xfrm>
-            <a:off x="365760" y="2523744"/>
-            <a:ext cx="5591556" cy="768096"/>
+              <a:rPr lang="en-US" sz="1050" dirty="0">
+                <a:solidFill>
+                  <a:srgbClr val="555555"/>
+                </a:solidFill>
+                <a:latin typeface="Calibri" pitchFamily="34" charset="0"/>
+                <a:ea typeface="Calibri" pitchFamily="34" charset="-122"/>
+                <a:cs typeface="Calibri" pitchFamily="34" charset="-120"/>
+              </a:rPr>
+              <a:t>~$609M across replacement, repair, and reverse logistics — touching every service motion Asurion runs.</a:t>
+            </a:r>
+            <a:endParaRPr lang="en-US" sz="1050" dirty="0"/>
+          </a:p>
+        </p:txBody>
+      </p:sp>
+      <p:sp>
+        <p:nvSpPr>
+          <p:cNvPr id="15" name="Shape 13"/>
+          <p:cNvSpPr/>
+          <p:nvPr/>
+        </p:nvSpPr>
+        <p:spPr>
+          <a:xfrm>
+            <a:off x="548640" y="5193792"/>
+            <a:ext cx="3331464" cy="256032"/>
           </a:xfrm>
           <a:prstGeom prst="roundRect">
             <a:avLst>
-              <a:gd name="adj" fmla="val 7143"/>
+              <a:gd name="adj" fmla="val 14286"/>
+            </a:avLst>
+          </a:prstGeom>
+          <a:solidFill>
+            <a:srgbClr val="F5F4F8"/>
+          </a:solidFill>
+          <a:ln w="6350">
+            <a:solidFill>
+              <a:srgbClr val="DDDDDD"/>
+            </a:solidFill>
+            <a:prstDash val="solid"/>
+          </a:ln>
+        </p:spPr>
+      </p:sp>
+      <p:sp>
+        <p:nvSpPr>
+          <p:cNvPr id="16" name="Text 14"/>
+          <p:cNvSpPr/>
+          <p:nvPr/>
+        </p:nvSpPr>
+        <p:spPr>
+          <a:xfrm>
+            <a:off x="548640" y="5193792"/>
+            <a:ext cx="3331464" cy="256032"/>
+          </a:xfrm>
+          <a:prstGeom prst="rect">
+            <a:avLst/>
+          </a:prstGeom>
+          <a:noFill/>
+          <a:ln/>
+        </p:spPr>
+        <p:txBody>
+          <a:bodyPr wrap="square" rtlCol="0" anchor="ctr"/>
+          <a:lstStyle/>
+          <a:p>
+            <a:pPr algn="ctr" indent="0" marL="0">
+              <a:buNone/>
+            </a:pPr>
+            <a:r>
+              <a:rPr lang="en-US" sz="800" dirty="0">
+                <a:solidFill>
+                  <a:srgbClr val="888888"/>
+                </a:solidFill>
+                <a:latin typeface="Calibri" pitchFamily="34" charset="0"/>
+                <a:ea typeface="Calibri" pitchFamily="34" charset="-122"/>
+                <a:cs typeface="Calibri" pitchFamily="34" charset="-120"/>
+              </a:rPr>
+              <a:t>Slides 03 – 04</a:t>
+            </a:r>
+            <a:endParaRPr lang="en-US" sz="800" dirty="0"/>
+          </a:p>
+        </p:txBody>
+      </p:sp>
+      <p:sp>
+        <p:nvSpPr>
+          <p:cNvPr id="17" name="Shape 15"/>
+          <p:cNvSpPr/>
+          <p:nvPr/>
+        </p:nvSpPr>
+        <p:spPr>
+          <a:xfrm>
+            <a:off x="4245864" y="2103120"/>
+            <a:ext cx="3697224" cy="3474720"/>
+          </a:xfrm>
+          <a:prstGeom prst="roundRect">
+            <a:avLst>
+              <a:gd name="adj" fmla="val 1842"/>
             </a:avLst>
           </a:prstGeom>
           <a:solidFill>
@@ -2389,19 +2734,69 @@
       </p:sp>
       <p:sp>
         <p:nvSpPr>
-          <p:cNvPr id="10" name="Shape 8"/>
-          <p:cNvSpPr/>
-          <p:nvPr/>
-        </p:nvSpPr>
-        <p:spPr>
-          <a:xfrm>
-            <a:off x="512064" y="2651760"/>
-            <a:ext cx="457200" cy="457200"/>
+          <p:cNvPr id="18" name="Shape 16"/>
+          <p:cNvSpPr/>
+          <p:nvPr/>
+        </p:nvSpPr>
+        <p:spPr>
+          <a:xfrm>
+            <a:off x="4245864" y="2103120"/>
+            <a:ext cx="3697224" cy="658368"/>
           </a:xfrm>
           <a:prstGeom prst="roundRect">
             <a:avLst>
-              <a:gd name="adj" fmla="val 16000"/>
+              <a:gd name="adj" fmla="val 9722"/>
             </a:avLst>
+          </a:prstGeom>
+          <a:solidFill>
+            <a:srgbClr val="F5EEF8"/>
+          </a:solidFill>
+          <a:ln w="12700">
+            <a:solidFill>
+              <a:srgbClr val="F5EEF8"/>
+            </a:solidFill>
+            <a:prstDash val="solid"/>
+          </a:ln>
+        </p:spPr>
+      </p:sp>
+      <p:sp>
+        <p:nvSpPr>
+          <p:cNvPr id="19" name="Shape 17"/>
+          <p:cNvSpPr/>
+          <p:nvPr/>
+        </p:nvSpPr>
+        <p:spPr>
+          <a:xfrm>
+            <a:off x="4245864" y="2578608"/>
+            <a:ext cx="3697224" cy="182880"/>
+          </a:xfrm>
+          <a:prstGeom prst="rect">
+            <a:avLst/>
+          </a:prstGeom>
+          <a:solidFill>
+            <a:srgbClr val="F5EEF8"/>
+          </a:solidFill>
+          <a:ln w="12700">
+            <a:solidFill>
+              <a:srgbClr val="F5EEF8"/>
+            </a:solidFill>
+            <a:prstDash val="solid"/>
+          </a:ln>
+        </p:spPr>
+      </p:sp>
+      <p:sp>
+        <p:nvSpPr>
+          <p:cNvPr id="20" name="Shape 18"/>
+          <p:cNvSpPr/>
+          <p:nvPr/>
+        </p:nvSpPr>
+        <p:spPr>
+          <a:xfrm>
+            <a:off x="4428744" y="2194560"/>
+            <a:ext cx="384048" cy="384048"/>
+          </a:xfrm>
+          <a:prstGeom prst="ellipse">
+            <a:avLst/>
           </a:prstGeom>
           <a:solidFill>
             <a:srgbClr val="5B2C8D"/>
@@ -2416,14 +2811,14 @@
       </p:sp>
       <p:sp>
         <p:nvSpPr>
-          <p:cNvPr id="11" name="Text 9"/>
-          <p:cNvSpPr/>
-          <p:nvPr/>
-        </p:nvSpPr>
-        <p:spPr>
-          <a:xfrm>
-            <a:off x="512064" y="2651760"/>
-            <a:ext cx="457200" cy="457200"/>
+          <p:cNvPr id="21" name="Text 19"/>
+          <p:cNvSpPr/>
+          <p:nvPr/>
+        </p:nvSpPr>
+        <p:spPr>
+          <a:xfrm>
+            <a:off x="4428744" y="2194560"/>
+            <a:ext cx="384048" cy="384048"/>
           </a:xfrm>
           <a:prstGeom prst="rect">
             <a:avLst/>
@@ -2439,30 +2834,148 @@
               <a:buNone/>
             </a:pPr>
             <a:r>
+              <a:rPr lang="en-US" sz="1100" b="1" dirty="0">
+                <a:solidFill>
+                  <a:srgbClr val="FFFFFF"/>
+                </a:solidFill>
+                <a:latin typeface="Calibri" pitchFamily="34" charset="0"/>
+                <a:ea typeface="Calibri" pitchFamily="34" charset="-122"/>
+                <a:cs typeface="Calibri" pitchFamily="34" charset="-120"/>
+              </a:rPr>
+              <a:t>02</a:t>
+            </a:r>
+            <a:endParaRPr lang="en-US" sz="1100" dirty="0"/>
+          </a:p>
+        </p:txBody>
+      </p:sp>
+      <p:sp>
+        <p:nvSpPr>
+          <p:cNvPr id="22" name="Text 20"/>
+          <p:cNvSpPr/>
+          <p:nvPr/>
+        </p:nvSpPr>
+        <p:spPr>
+          <a:xfrm>
+            <a:off x="4940808" y="2267712"/>
+            <a:ext cx="2874264" cy="237744"/>
+          </a:xfrm>
+          <a:prstGeom prst="rect">
+            <a:avLst/>
+          </a:prstGeom>
+          <a:noFill/>
+          <a:ln/>
+        </p:spPr>
+        <p:txBody>
+          <a:bodyPr wrap="square" rtlCol="0" anchor="ctr"/>
+          <a:lstStyle/>
+          <a:p>
+            <a:pPr indent="0" marL="0">
+              <a:buNone/>
+            </a:pPr>
+            <a:r>
+              <a:rPr lang="en-US" sz="800" b="1" spc="150" kern="0" dirty="0">
+                <a:solidFill>
+                  <a:srgbClr val="5B2C8D"/>
+                </a:solidFill>
+                <a:latin typeface="Calibri" pitchFamily="34" charset="0"/>
+                <a:ea typeface="Calibri" pitchFamily="34" charset="-122"/>
+                <a:cs typeface="Calibri" pitchFamily="34" charset="-120"/>
+              </a:rPr>
+              <a:t>THE PROBLEM</a:t>
+            </a:r>
+            <a:endParaRPr lang="en-US" sz="800" dirty="0"/>
+          </a:p>
+        </p:txBody>
+      </p:sp>
+      <p:sp>
+        <p:nvSpPr>
+          <p:cNvPr id="23" name="Shape 21"/>
+          <p:cNvSpPr/>
+          <p:nvPr/>
+        </p:nvSpPr>
+        <p:spPr>
+          <a:xfrm>
+            <a:off x="4428744" y="2779776"/>
+            <a:ext cx="3331464" cy="0"/>
+          </a:xfrm>
+          <a:prstGeom prst="line">
+            <a:avLst/>
+          </a:prstGeom>
+          <a:noFill/>
+          <a:ln w="6350">
+            <a:solidFill>
+              <a:srgbClr val="DDDDDD"/>
+            </a:solidFill>
+            <a:prstDash val="solid"/>
+          </a:ln>
+        </p:spPr>
+      </p:sp>
+      <p:sp>
+        <p:nvSpPr>
+          <p:cNvPr id="24" name="Text 22"/>
+          <p:cNvSpPr/>
+          <p:nvPr/>
+        </p:nvSpPr>
+        <p:spPr>
+          <a:xfrm>
+            <a:off x="4428744" y="2871216"/>
+            <a:ext cx="3331464" cy="658368"/>
+          </a:xfrm>
+          <a:prstGeom prst="rect">
+            <a:avLst/>
+          </a:prstGeom>
+          <a:noFill/>
+          <a:ln/>
+        </p:spPr>
+        <p:txBody>
+          <a:bodyPr wrap="square" rtlCol="0" anchor="t"/>
+          <a:lstStyle/>
+          <a:p>
+            <a:pPr indent="0" marL="0">
+              <a:buNone/>
+            </a:pPr>
+            <a:r>
               <a:rPr lang="en-US" sz="1300" b="1" dirty="0">
                 <a:solidFill>
-                  <a:srgbClr val="FFFFFF"/>
-                </a:solidFill>
-                <a:latin typeface="Calibri" pitchFamily="34" charset="0"/>
-                <a:ea typeface="Calibri" pitchFamily="34" charset="-122"/>
-                <a:cs typeface="Calibri" pitchFamily="34" charset="-120"/>
-              </a:rPr>
-              <a:t>3</a:t>
+                  <a:srgbClr val="111111"/>
+                </a:solidFill>
+                <a:latin typeface="Calibri Light" pitchFamily="34" charset="0"/>
+                <a:ea typeface="Calibri Light" pitchFamily="34" charset="-122"/>
+                <a:cs typeface="Calibri Light" pitchFamily="34" charset="-120"/>
+              </a:rPr>
+              <a:t>Why fragmented systems</a:t>
             </a:r>
             <a:endParaRPr lang="en-US" sz="1300" dirty="0"/>
           </a:p>
-        </p:txBody>
-      </p:sp>
-      <p:sp>
-        <p:nvSpPr>
-          <p:cNvPr id="12" name="Text 10"/>
-          <p:cNvSpPr/>
-          <p:nvPr/>
-        </p:nvSpPr>
-        <p:spPr>
-          <a:xfrm>
-            <a:off x="1115568" y="2651760"/>
-            <a:ext cx="4695444" cy="368686"/>
+          <a:p>
+            <a:pPr indent="0" marL="0">
+              <a:buNone/>
+            </a:pPr>
+            <a:r>
+              <a:rPr lang="en-US" sz="1300" b="1" dirty="0">
+                <a:solidFill>
+                  <a:srgbClr val="111111"/>
+                </a:solidFill>
+                <a:latin typeface="Calibri Light" pitchFamily="34" charset="0"/>
+                <a:ea typeface="Calibri Light" pitchFamily="34" charset="-122"/>
+                <a:cs typeface="Calibri Light" pitchFamily="34" charset="-120"/>
+              </a:rPr>
+              <a:t>create financial risk</a:t>
+            </a:r>
+            <a:endParaRPr lang="en-US" sz="1300" dirty="0"/>
+          </a:p>
+        </p:txBody>
+      </p:sp>
+      <p:sp>
+        <p:nvSpPr>
+          <p:cNvPr id="25" name="Text 23"/>
+          <p:cNvSpPr/>
+          <p:nvPr/>
+        </p:nvSpPr>
+        <p:spPr>
+          <a:xfrm>
+            <a:off x="4428744" y="3621024"/>
+            <a:ext cx="3331464" cy="1508760"/>
           </a:xfrm>
           <a:prstGeom prst="rect">
             <a:avLst/>
@@ -2478,73 +2991,100 @@
               <a:buNone/>
             </a:pPr>
             <a:r>
-              <a:rPr lang="en-US" sz="1100" b="1" dirty="0">
-                <a:solidFill>
-                  <a:srgbClr val="111111"/>
-                </a:solidFill>
-                <a:latin typeface="Calibri" pitchFamily="34" charset="0"/>
-                <a:ea typeface="Calibri" pitchFamily="34" charset="-122"/>
-                <a:cs typeface="Calibri" pitchFamily="34" charset="-120"/>
-              </a:rPr>
-              <a:t>Fulfillment Systems Connect Inventory Movement to Financial Accountability</a:t>
-            </a:r>
-            <a:endParaRPr lang="en-US" sz="1100" dirty="0"/>
-          </a:p>
-        </p:txBody>
-      </p:sp>
-      <p:sp>
-        <p:nvSpPr>
-          <p:cNvPr id="13" name="Text 11"/>
-          <p:cNvSpPr/>
-          <p:nvPr/>
-        </p:nvSpPr>
-        <p:spPr>
-          <a:xfrm>
-            <a:off x="1115568" y="2923154"/>
-            <a:ext cx="4695444" cy="307238"/>
-          </a:xfrm>
-          <a:prstGeom prst="rect">
-            <a:avLst/>
-          </a:prstGeom>
-          <a:noFill/>
-          <a:ln/>
-        </p:spPr>
-        <p:txBody>
-          <a:bodyPr wrap="square" rtlCol="0" anchor="t"/>
-          <a:lstStyle/>
-          <a:p>
-            <a:pPr indent="0" marL="0">
-              <a:buNone/>
-            </a:pPr>
-            <a:r>
-              <a:rPr lang="en-US" sz="900" dirty="0">
-                <a:solidFill>
-                  <a:srgbClr val="888888"/>
-                </a:solidFill>
-                <a:latin typeface="Calibri" pitchFamily="34" charset="0"/>
-                <a:ea typeface="Calibri" pitchFamily="34" charset="-122"/>
-                <a:cs typeface="Calibri" pitchFamily="34" charset="-120"/>
-              </a:rPr>
-              <a:t>How systems tie each physical move to a financial record</a:t>
-            </a:r>
-            <a:endParaRPr lang="en-US" sz="900" dirty="0"/>
-          </a:p>
-        </p:txBody>
-      </p:sp>
-      <p:sp>
-        <p:nvSpPr>
-          <p:cNvPr id="14" name="Shape 12"/>
-          <p:cNvSpPr/>
-          <p:nvPr/>
-        </p:nvSpPr>
-        <p:spPr>
-          <a:xfrm>
-            <a:off x="365760" y="3383280"/>
-            <a:ext cx="5591556" cy="768096"/>
+              <a:rPr lang="en-US" sz="1050" dirty="0">
+                <a:solidFill>
+                  <a:srgbClr val="555555"/>
+                </a:solidFill>
+                <a:latin typeface="Calibri" pitchFamily="34" charset="0"/>
+                <a:ea typeface="Calibri" pitchFamily="34" charset="-122"/>
+                <a:cs typeface="Calibri" pitchFamily="34" charset="-120"/>
+              </a:rPr>
+              <a:t>$207M sits on legacy platforms outside D365 F&amp;O. Every split system is a gap where inventory and dollars go untraced.</a:t>
+            </a:r>
+            <a:endParaRPr lang="en-US" sz="1050" dirty="0"/>
+          </a:p>
+        </p:txBody>
+      </p:sp>
+      <p:sp>
+        <p:nvSpPr>
+          <p:cNvPr id="26" name="Shape 24"/>
+          <p:cNvSpPr/>
+          <p:nvPr/>
+        </p:nvSpPr>
+        <p:spPr>
+          <a:xfrm>
+            <a:off x="4428744" y="5193792"/>
+            <a:ext cx="3331464" cy="256032"/>
           </a:xfrm>
           <a:prstGeom prst="roundRect">
             <a:avLst>
-              <a:gd name="adj" fmla="val 7143"/>
+              <a:gd name="adj" fmla="val 14286"/>
+            </a:avLst>
+          </a:prstGeom>
+          <a:solidFill>
+            <a:srgbClr val="F5F4F8"/>
+          </a:solidFill>
+          <a:ln w="6350">
+            <a:solidFill>
+              <a:srgbClr val="DDDDDD"/>
+            </a:solidFill>
+            <a:prstDash val="solid"/>
+          </a:ln>
+        </p:spPr>
+      </p:sp>
+      <p:sp>
+        <p:nvSpPr>
+          <p:cNvPr id="27" name="Text 25"/>
+          <p:cNvSpPr/>
+          <p:nvPr/>
+        </p:nvSpPr>
+        <p:spPr>
+          <a:xfrm>
+            <a:off x="4428744" y="5193792"/>
+            <a:ext cx="3331464" cy="256032"/>
+          </a:xfrm>
+          <a:prstGeom prst="rect">
+            <a:avLst/>
+          </a:prstGeom>
+          <a:noFill/>
+          <a:ln/>
+        </p:spPr>
+        <p:txBody>
+          <a:bodyPr wrap="square" rtlCol="0" anchor="ctr"/>
+          <a:lstStyle/>
+          <a:p>
+            <a:pPr algn="ctr" indent="0" marL="0">
+              <a:buNone/>
+            </a:pPr>
+            <a:r>
+              <a:rPr lang="en-US" sz="800" dirty="0">
+                <a:solidFill>
+                  <a:srgbClr val="888888"/>
+                </a:solidFill>
+                <a:latin typeface="Calibri" pitchFamily="34" charset="0"/>
+                <a:ea typeface="Calibri" pitchFamily="34" charset="-122"/>
+                <a:cs typeface="Calibri" pitchFamily="34" charset="-120"/>
+              </a:rPr>
+              <a:t>Slide 05</a:t>
+            </a:r>
+            <a:endParaRPr lang="en-US" sz="800" dirty="0"/>
+          </a:p>
+        </p:txBody>
+      </p:sp>
+      <p:sp>
+        <p:nvSpPr>
+          <p:cNvPr id="28" name="Shape 26"/>
+          <p:cNvSpPr/>
+          <p:nvPr/>
+        </p:nvSpPr>
+        <p:spPr>
+          <a:xfrm>
+            <a:off x="8125968" y="2103120"/>
+            <a:ext cx="3697224" cy="3474720"/>
+          </a:xfrm>
+          <a:prstGeom prst="roundRect">
+            <a:avLst>
+              <a:gd name="adj" fmla="val 1842"/>
             </a:avLst>
           </a:prstGeom>
           <a:solidFill>
@@ -2560,19 +3100,69 @@
       </p:sp>
       <p:sp>
         <p:nvSpPr>
-          <p:cNvPr id="15" name="Shape 13"/>
-          <p:cNvSpPr/>
-          <p:nvPr/>
-        </p:nvSpPr>
-        <p:spPr>
-          <a:xfrm>
-            <a:off x="512064" y="3511296"/>
-            <a:ext cx="457200" cy="457200"/>
+          <p:cNvPr id="29" name="Shape 27"/>
+          <p:cNvSpPr/>
+          <p:nvPr/>
+        </p:nvSpPr>
+        <p:spPr>
+          <a:xfrm>
+            <a:off x="8125968" y="2103120"/>
+            <a:ext cx="3697224" cy="658368"/>
           </a:xfrm>
           <a:prstGeom prst="roundRect">
             <a:avLst>
-              <a:gd name="adj" fmla="val 16000"/>
+              <a:gd name="adj" fmla="val 9722"/>
             </a:avLst>
+          </a:prstGeom>
+          <a:solidFill>
+            <a:srgbClr val="EDE8F5"/>
+          </a:solidFill>
+          <a:ln w="12700">
+            <a:solidFill>
+              <a:srgbClr val="EDE8F5"/>
+            </a:solidFill>
+            <a:prstDash val="solid"/>
+          </a:ln>
+        </p:spPr>
+      </p:sp>
+      <p:sp>
+        <p:nvSpPr>
+          <p:cNvPr id="30" name="Shape 28"/>
+          <p:cNvSpPr/>
+          <p:nvPr/>
+        </p:nvSpPr>
+        <p:spPr>
+          <a:xfrm>
+            <a:off x="8125968" y="2578608"/>
+            <a:ext cx="3697224" cy="182880"/>
+          </a:xfrm>
+          <a:prstGeom prst="rect">
+            <a:avLst/>
+          </a:prstGeom>
+          <a:solidFill>
+            <a:srgbClr val="EDE8F5"/>
+          </a:solidFill>
+          <a:ln w="12700">
+            <a:solidFill>
+              <a:srgbClr val="EDE8F5"/>
+            </a:solidFill>
+            <a:prstDash val="solid"/>
+          </a:ln>
+        </p:spPr>
+      </p:sp>
+      <p:sp>
+        <p:nvSpPr>
+          <p:cNvPr id="31" name="Shape 29"/>
+          <p:cNvSpPr/>
+          <p:nvPr/>
+        </p:nvSpPr>
+        <p:spPr>
+          <a:xfrm>
+            <a:off x="8308848" y="2194560"/>
+            <a:ext cx="384048" cy="384048"/>
+          </a:xfrm>
+          <a:prstGeom prst="ellipse">
+            <a:avLst/>
           </a:prstGeom>
           <a:solidFill>
             <a:srgbClr val="5B2C8D"/>
@@ -2587,14 +3177,14 @@
       </p:sp>
       <p:sp>
         <p:nvSpPr>
-          <p:cNvPr id="16" name="Text 14"/>
-          <p:cNvSpPr/>
-          <p:nvPr/>
-        </p:nvSpPr>
-        <p:spPr>
-          <a:xfrm>
-            <a:off x="512064" y="3511296"/>
-            <a:ext cx="457200" cy="457200"/>
+          <p:cNvPr id="32" name="Text 30"/>
+          <p:cNvSpPr/>
+          <p:nvPr/>
+        </p:nvSpPr>
+        <p:spPr>
+          <a:xfrm>
+            <a:off x="8308848" y="2194560"/>
+            <a:ext cx="384048" cy="384048"/>
           </a:xfrm>
           <a:prstGeom prst="rect">
             <a:avLst/>
@@ -2610,7 +3200,7 @@
               <a:buNone/>
             </a:pPr>
             <a:r>
-              <a:rPr lang="en-US" sz="1300" b="1" dirty="0">
+              <a:rPr lang="en-US" sz="1100" b="1" dirty="0">
                 <a:solidFill>
                   <a:srgbClr val="FFFFFF"/>
                 </a:solidFill>
@@ -2618,46 +3208,7 @@
                 <a:ea typeface="Calibri" pitchFamily="34" charset="-122"/>
                 <a:cs typeface="Calibri" pitchFamily="34" charset="-120"/>
               </a:rPr>
-              <a:t>5</a:t>
-            </a:r>
-            <a:endParaRPr lang="en-US" sz="1300" dirty="0"/>
-          </a:p>
-        </p:txBody>
-      </p:sp>
-      <p:sp>
-        <p:nvSpPr>
-          <p:cNvPr id="17" name="Text 15"/>
-          <p:cNvSpPr/>
-          <p:nvPr/>
-        </p:nvSpPr>
-        <p:spPr>
-          <a:xfrm>
-            <a:off x="1115568" y="3511296"/>
-            <a:ext cx="4695444" cy="368686"/>
-          </a:xfrm>
-          <a:prstGeom prst="rect">
-            <a:avLst/>
-          </a:prstGeom>
-          <a:noFill/>
-          <a:ln/>
-        </p:spPr>
-        <p:txBody>
-          <a:bodyPr wrap="square" rtlCol="0" anchor="t"/>
-          <a:lstStyle/>
-          <a:p>
-            <a:pPr indent="0" marL="0">
-              <a:buNone/>
-            </a:pPr>
-            <a:r>
-              <a:rPr lang="en-US" sz="1100" b="1" dirty="0">
-                <a:solidFill>
-                  <a:srgbClr val="111111"/>
-                </a:solidFill>
-                <a:latin typeface="Calibri" pitchFamily="34" charset="0"/>
-                <a:ea typeface="Calibri" pitchFamily="34" charset="-122"/>
-                <a:cs typeface="Calibri" pitchFamily="34" charset="-120"/>
-              </a:rPr>
-              <a:t>Scaling the Proven Inventory Model Across Every Program</a:t>
+              <a:t>03</a:t>
             </a:r>
             <a:endParaRPr lang="en-US" sz="1100" dirty="0"/>
           </a:p>
@@ -2665,395 +3216,53 @@
       </p:sp>
       <p:sp>
         <p:nvSpPr>
-          <p:cNvPr id="18" name="Text 16"/>
-          <p:cNvSpPr/>
-          <p:nvPr/>
-        </p:nvSpPr>
-        <p:spPr>
-          <a:xfrm>
-            <a:off x="1115568" y="3782690"/>
-            <a:ext cx="4695444" cy="307238"/>
-          </a:xfrm>
-          <a:prstGeom prst="rect">
-            <a:avLst/>
-          </a:prstGeom>
-          <a:noFill/>
-          <a:ln/>
-        </p:spPr>
-        <p:txBody>
-          <a:bodyPr wrap="square" rtlCol="0" anchor="t"/>
-          <a:lstStyle/>
-          <a:p>
-            <a:pPr indent="0" marL="0">
-              <a:buNone/>
-            </a:pPr>
-            <a:r>
-              <a:rPr lang="en-US" sz="900" dirty="0">
-                <a:solidFill>
-                  <a:srgbClr val="888888"/>
-                </a:solidFill>
-                <a:latin typeface="Calibri" pitchFamily="34" charset="0"/>
-                <a:ea typeface="Calibri" pitchFamily="34" charset="-122"/>
-                <a:cs typeface="Calibri" pitchFamily="34" charset="-120"/>
-              </a:rPr>
-              <a:t>The DES single-source-of-truth playbook, extended phase by phase</a:t>
-            </a:r>
-            <a:endParaRPr lang="en-US" sz="900" dirty="0"/>
-          </a:p>
-        </p:txBody>
-      </p:sp>
-      <p:sp>
-        <p:nvSpPr>
-          <p:cNvPr id="19" name="Shape 17"/>
-          <p:cNvSpPr/>
-          <p:nvPr/>
-        </p:nvSpPr>
-        <p:spPr>
-          <a:xfrm>
-            <a:off x="6231636" y="1664208"/>
-            <a:ext cx="5591556" cy="768096"/>
-          </a:xfrm>
-          <a:prstGeom prst="roundRect">
-            <a:avLst>
-              <a:gd name="adj" fmla="val 7143"/>
-            </a:avLst>
-          </a:prstGeom>
-          <a:solidFill>
-            <a:srgbClr val="FFFFFF"/>
-          </a:solidFill>
-          <a:ln w="9525">
-            <a:solidFill>
-              <a:srgbClr val="DDDDDD"/>
-            </a:solidFill>
-            <a:prstDash val="solid"/>
-          </a:ln>
-        </p:spPr>
-      </p:sp>
-      <p:sp>
-        <p:nvSpPr>
-          <p:cNvPr id="20" name="Shape 18"/>
-          <p:cNvSpPr/>
-          <p:nvPr/>
-        </p:nvSpPr>
-        <p:spPr>
-          <a:xfrm>
-            <a:off x="6377940" y="1792224"/>
-            <a:ext cx="457200" cy="457200"/>
-          </a:xfrm>
-          <a:prstGeom prst="roundRect">
-            <a:avLst>
-              <a:gd name="adj" fmla="val 16000"/>
-            </a:avLst>
-          </a:prstGeom>
-          <a:solidFill>
-            <a:srgbClr val="5B2C8D"/>
-          </a:solidFill>
-          <a:ln w="12700">
-            <a:solidFill>
-              <a:srgbClr val="5B2C8D"/>
-            </a:solidFill>
-            <a:prstDash val="solid"/>
-          </a:ln>
-        </p:spPr>
-      </p:sp>
-      <p:sp>
-        <p:nvSpPr>
-          <p:cNvPr id="21" name="Text 19"/>
-          <p:cNvSpPr/>
-          <p:nvPr/>
-        </p:nvSpPr>
-        <p:spPr>
-          <a:xfrm>
-            <a:off x="6377940" y="1792224"/>
-            <a:ext cx="457200" cy="457200"/>
-          </a:xfrm>
-          <a:prstGeom prst="rect">
-            <a:avLst/>
-          </a:prstGeom>
-          <a:noFill/>
-          <a:ln/>
-        </p:spPr>
-        <p:txBody>
-          <a:bodyPr wrap="square" rtlCol="0" anchor="ctr"/>
-          <a:lstStyle/>
-          <a:p>
-            <a:pPr algn="ctr" indent="0" marL="0">
-              <a:buNone/>
-            </a:pPr>
-            <a:r>
-              <a:rPr lang="en-US" sz="1300" b="1" dirty="0">
-                <a:solidFill>
-                  <a:srgbClr val="FFFFFF"/>
-                </a:solidFill>
-                <a:latin typeface="Calibri" pitchFamily="34" charset="0"/>
-                <a:ea typeface="Calibri" pitchFamily="34" charset="-122"/>
-                <a:cs typeface="Calibri" pitchFamily="34" charset="-120"/>
-              </a:rPr>
-              <a:t>2</a:t>
-            </a:r>
-            <a:endParaRPr lang="en-US" sz="1300" dirty="0"/>
-          </a:p>
-        </p:txBody>
-      </p:sp>
-      <p:sp>
-        <p:nvSpPr>
-          <p:cNvPr id="22" name="Text 20"/>
-          <p:cNvSpPr/>
-          <p:nvPr/>
-        </p:nvSpPr>
-        <p:spPr>
-          <a:xfrm>
-            <a:off x="6981444" y="1792224"/>
-            <a:ext cx="4695444" cy="368686"/>
-          </a:xfrm>
-          <a:prstGeom prst="rect">
-            <a:avLst/>
-          </a:prstGeom>
-          <a:noFill/>
-          <a:ln/>
-        </p:spPr>
-        <p:txBody>
-          <a:bodyPr wrap="square" rtlCol="0" anchor="t"/>
-          <a:lstStyle/>
-          <a:p>
-            <a:pPr indent="0" marL="0">
-              <a:buNone/>
-            </a:pPr>
-            <a:r>
-              <a:rPr lang="en-US" sz="1100" b="1" dirty="0">
-                <a:solidFill>
-                  <a:srgbClr val="111111"/>
-                </a:solidFill>
-                <a:latin typeface="Calibri" pitchFamily="34" charset="0"/>
-                <a:ea typeface="Calibri" pitchFamily="34" charset="-122"/>
-                <a:cs typeface="Calibri" pitchFamily="34" charset="-120"/>
-              </a:rPr>
-              <a:t>Inventory Is Split Across Multiple Systems of Record</a:t>
-            </a:r>
-            <a:endParaRPr lang="en-US" sz="1100" dirty="0"/>
-          </a:p>
-        </p:txBody>
-      </p:sp>
-      <p:sp>
-        <p:nvSpPr>
-          <p:cNvPr id="23" name="Text 21"/>
-          <p:cNvSpPr/>
-          <p:nvPr/>
-        </p:nvSpPr>
-        <p:spPr>
-          <a:xfrm>
-            <a:off x="6981444" y="2063618"/>
-            <a:ext cx="4695444" cy="307238"/>
-          </a:xfrm>
-          <a:prstGeom prst="rect">
-            <a:avLst/>
-          </a:prstGeom>
-          <a:noFill/>
-          <a:ln/>
-        </p:spPr>
-        <p:txBody>
-          <a:bodyPr wrap="square" rtlCol="0" anchor="t"/>
-          <a:lstStyle/>
-          <a:p>
-            <a:pPr indent="0" marL="0">
-              <a:buNone/>
-            </a:pPr>
-            <a:r>
-              <a:rPr lang="en-US" sz="900" dirty="0">
-                <a:solidFill>
-                  <a:srgbClr val="888888"/>
-                </a:solidFill>
-                <a:latin typeface="Calibri" pitchFamily="34" charset="0"/>
-                <a:ea typeface="Calibri" pitchFamily="34" charset="-122"/>
-                <a:cs typeface="Calibri" pitchFamily="34" charset="-120"/>
-              </a:rPr>
-              <a:t>Why consolidating into one source of truth is a financial control, not just an operational one</a:t>
-            </a:r>
-            <a:endParaRPr lang="en-US" sz="900" dirty="0"/>
-          </a:p>
-        </p:txBody>
-      </p:sp>
-      <p:sp>
-        <p:nvSpPr>
-          <p:cNvPr id="24" name="Shape 22"/>
-          <p:cNvSpPr/>
-          <p:nvPr/>
-        </p:nvSpPr>
-        <p:spPr>
-          <a:xfrm>
-            <a:off x="6231636" y="2523744"/>
-            <a:ext cx="5591556" cy="768096"/>
-          </a:xfrm>
-          <a:prstGeom prst="roundRect">
-            <a:avLst>
-              <a:gd name="adj" fmla="val 7143"/>
-            </a:avLst>
-          </a:prstGeom>
-          <a:solidFill>
-            <a:srgbClr val="FFFFFF"/>
-          </a:solidFill>
-          <a:ln w="9525">
-            <a:solidFill>
-              <a:srgbClr val="DDDDDD"/>
-            </a:solidFill>
-            <a:prstDash val="solid"/>
-          </a:ln>
-        </p:spPr>
-      </p:sp>
-      <p:sp>
-        <p:nvSpPr>
-          <p:cNvPr id="25" name="Shape 23"/>
-          <p:cNvSpPr/>
-          <p:nvPr/>
-        </p:nvSpPr>
-        <p:spPr>
-          <a:xfrm>
-            <a:off x="6377940" y="2651760"/>
-            <a:ext cx="457200" cy="457200"/>
-          </a:xfrm>
-          <a:prstGeom prst="roundRect">
-            <a:avLst>
-              <a:gd name="adj" fmla="val 16000"/>
-            </a:avLst>
-          </a:prstGeom>
-          <a:solidFill>
-            <a:srgbClr val="5B2C8D"/>
-          </a:solidFill>
-          <a:ln w="12700">
-            <a:solidFill>
-              <a:srgbClr val="5B2C8D"/>
-            </a:solidFill>
-            <a:prstDash val="solid"/>
-          </a:ln>
-        </p:spPr>
-      </p:sp>
-      <p:sp>
-        <p:nvSpPr>
-          <p:cNvPr id="26" name="Text 24"/>
-          <p:cNvSpPr/>
-          <p:nvPr/>
-        </p:nvSpPr>
-        <p:spPr>
-          <a:xfrm>
-            <a:off x="6377940" y="2651760"/>
-            <a:ext cx="457200" cy="457200"/>
-          </a:xfrm>
-          <a:prstGeom prst="rect">
-            <a:avLst/>
-          </a:prstGeom>
-          <a:noFill/>
-          <a:ln/>
-        </p:spPr>
-        <p:txBody>
-          <a:bodyPr wrap="square" rtlCol="0" anchor="ctr"/>
-          <a:lstStyle/>
-          <a:p>
-            <a:pPr algn="ctr" indent="0" marL="0">
-              <a:buNone/>
-            </a:pPr>
-            <a:r>
-              <a:rPr lang="en-US" sz="1300" b="1" dirty="0">
-                <a:solidFill>
-                  <a:srgbClr val="FFFFFF"/>
-                </a:solidFill>
-                <a:latin typeface="Calibri" pitchFamily="34" charset="0"/>
-                <a:ea typeface="Calibri" pitchFamily="34" charset="-122"/>
-                <a:cs typeface="Calibri" pitchFamily="34" charset="-120"/>
-              </a:rPr>
-              <a:t>4</a:t>
-            </a:r>
-            <a:endParaRPr lang="en-US" sz="1300" dirty="0"/>
-          </a:p>
-        </p:txBody>
-      </p:sp>
-      <p:sp>
-        <p:nvSpPr>
-          <p:cNvPr id="27" name="Text 25"/>
-          <p:cNvSpPr/>
-          <p:nvPr/>
-        </p:nvSpPr>
-        <p:spPr>
-          <a:xfrm>
-            <a:off x="6981444" y="2651760"/>
-            <a:ext cx="4695444" cy="368686"/>
-          </a:xfrm>
-          <a:prstGeom prst="rect">
-            <a:avLst/>
-          </a:prstGeom>
-          <a:noFill/>
-          <a:ln/>
-        </p:spPr>
-        <p:txBody>
-          <a:bodyPr wrap="square" rtlCol="0" anchor="t"/>
-          <a:lstStyle/>
-          <a:p>
-            <a:pPr indent="0" marL="0">
-              <a:buNone/>
-            </a:pPr>
-            <a:r>
-              <a:rPr lang="en-US" sz="1100" b="1" dirty="0">
-                <a:solidFill>
-                  <a:srgbClr val="111111"/>
-                </a:solidFill>
-                <a:latin typeface="Calibri" pitchFamily="34" charset="0"/>
-                <a:ea typeface="Calibri" pitchFamily="34" charset="-122"/>
-                <a:cs typeface="Calibri" pitchFamily="34" charset="-120"/>
-              </a:rPr>
-              <a:t>One Operating Model Improves Visibility, Control, and Scale</a:t>
-            </a:r>
-            <a:endParaRPr lang="en-US" sz="1100" dirty="0"/>
-          </a:p>
-        </p:txBody>
-      </p:sp>
-      <p:sp>
-        <p:nvSpPr>
-          <p:cNvPr id="28" name="Text 26"/>
-          <p:cNvSpPr/>
-          <p:nvPr/>
-        </p:nvSpPr>
-        <p:spPr>
-          <a:xfrm>
-            <a:off x="6981444" y="2923154"/>
-            <a:ext cx="4695444" cy="307238"/>
-          </a:xfrm>
-          <a:prstGeom prst="rect">
-            <a:avLst/>
-          </a:prstGeom>
-          <a:noFill/>
-          <a:ln/>
-        </p:spPr>
-        <p:txBody>
-          <a:bodyPr wrap="square" rtlCol="0" anchor="t"/>
-          <a:lstStyle/>
-          <a:p>
-            <a:pPr indent="0" marL="0">
-              <a:buNone/>
-            </a:pPr>
-            <a:r>
-              <a:rPr lang="en-US" sz="900" dirty="0">
-                <a:solidFill>
-                  <a:srgbClr val="888888"/>
-                </a:solidFill>
-                <a:latin typeface="Calibri" pitchFamily="34" charset="0"/>
-                <a:ea typeface="Calibri" pitchFamily="34" charset="-122"/>
-                <a:cs typeface="Calibri" pitchFamily="34" charset="-120"/>
-              </a:rPr>
-              <a:t>Moving from fragmented tools to a single, governed operating model</a:t>
-            </a:r>
-            <a:endParaRPr lang="en-US" sz="900" dirty="0"/>
-          </a:p>
-        </p:txBody>
-      </p:sp>
-      <p:sp>
-        <p:nvSpPr>
-          <p:cNvPr id="29" name="Shape 27"/>
-          <p:cNvSpPr/>
-          <p:nvPr/>
-        </p:nvSpPr>
-        <p:spPr>
-          <a:xfrm>
-            <a:off x="0" y="6473952"/>
-            <a:ext cx="12188952" cy="0"/>
+          <p:cNvPr id="33" name="Text 31"/>
+          <p:cNvSpPr/>
+          <p:nvPr/>
+        </p:nvSpPr>
+        <p:spPr>
+          <a:xfrm>
+            <a:off x="8820912" y="2267712"/>
+            <a:ext cx="2874264" cy="237744"/>
+          </a:xfrm>
+          <a:prstGeom prst="rect">
+            <a:avLst/>
+          </a:prstGeom>
+          <a:noFill/>
+          <a:ln/>
+        </p:spPr>
+        <p:txBody>
+          <a:bodyPr wrap="square" rtlCol="0" anchor="ctr"/>
+          <a:lstStyle/>
+          <a:p>
+            <a:pPr indent="0" marL="0">
+              <a:buNone/>
+            </a:pPr>
+            <a:r>
+              <a:rPr lang="en-US" sz="800" b="1" spc="150" kern="0" dirty="0">
+                <a:solidFill>
+                  <a:srgbClr val="5B2C8D"/>
+                </a:solidFill>
+                <a:latin typeface="Calibri" pitchFamily="34" charset="0"/>
+                <a:ea typeface="Calibri" pitchFamily="34" charset="-122"/>
+                <a:cs typeface="Calibri" pitchFamily="34" charset="-120"/>
+              </a:rPr>
+              <a:t>THE PLAN</a:t>
+            </a:r>
+            <a:endParaRPr lang="en-US" sz="800" dirty="0"/>
+          </a:p>
+        </p:txBody>
+      </p:sp>
+      <p:sp>
+        <p:nvSpPr>
+          <p:cNvPr id="34" name="Shape 32"/>
+          <p:cNvSpPr/>
+          <p:nvPr/>
+        </p:nvSpPr>
+        <p:spPr>
+          <a:xfrm>
+            <a:off x="8308848" y="2779776"/>
+            <a:ext cx="3331464" cy="0"/>
           </a:xfrm>
           <a:prstGeom prst="line">
             <a:avLst/>
@@ -3069,7 +3278,269 @@
       </p:sp>
       <p:sp>
         <p:nvSpPr>
-          <p:cNvPr id="30" name="Text 28"/>
+          <p:cNvPr id="35" name="Text 33"/>
+          <p:cNvSpPr/>
+          <p:nvPr/>
+        </p:nvSpPr>
+        <p:spPr>
+          <a:xfrm>
+            <a:off x="8308848" y="2871216"/>
+            <a:ext cx="3331464" cy="658368"/>
+          </a:xfrm>
+          <a:prstGeom prst="rect">
+            <a:avLst/>
+          </a:prstGeom>
+          <a:noFill/>
+          <a:ln/>
+        </p:spPr>
+        <p:txBody>
+          <a:bodyPr wrap="square" rtlCol="0" anchor="t"/>
+          <a:lstStyle/>
+          <a:p>
+            <a:pPr indent="0" marL="0">
+              <a:buNone/>
+            </a:pPr>
+            <a:r>
+              <a:rPr lang="en-US" sz="1300" b="1" dirty="0">
+                <a:solidFill>
+                  <a:srgbClr val="111111"/>
+                </a:solidFill>
+                <a:latin typeface="Calibri Light" pitchFamily="34" charset="0"/>
+                <a:ea typeface="Calibri Light" pitchFamily="34" charset="-122"/>
+                <a:cs typeface="Calibri Light" pitchFamily="34" charset="-120"/>
+              </a:rPr>
+              <a:t>How we consolidate —</a:t>
+            </a:r>
+            <a:endParaRPr lang="en-US" sz="1300" dirty="0"/>
+          </a:p>
+          <a:p>
+            <a:pPr indent="0" marL="0">
+              <a:buNone/>
+            </a:pPr>
+            <a:r>
+              <a:rPr lang="en-US" sz="1300" b="1" dirty="0">
+                <a:solidFill>
+                  <a:srgbClr val="111111"/>
+                </a:solidFill>
+                <a:latin typeface="Calibri Light" pitchFamily="34" charset="0"/>
+                <a:ea typeface="Calibri Light" pitchFamily="34" charset="-122"/>
+                <a:cs typeface="Calibri Light" pitchFamily="34" charset="-120"/>
+              </a:rPr>
+              <a:t>and what it delivers</a:t>
+            </a:r>
+            <a:endParaRPr lang="en-US" sz="1300" dirty="0"/>
+          </a:p>
+        </p:txBody>
+      </p:sp>
+      <p:sp>
+        <p:nvSpPr>
+          <p:cNvPr id="36" name="Text 34"/>
+          <p:cNvSpPr/>
+          <p:nvPr/>
+        </p:nvSpPr>
+        <p:spPr>
+          <a:xfrm>
+            <a:off x="8308848" y="3621024"/>
+            <a:ext cx="3331464" cy="1508760"/>
+          </a:xfrm>
+          <a:prstGeom prst="rect">
+            <a:avLst/>
+          </a:prstGeom>
+          <a:noFill/>
+          <a:ln/>
+        </p:spPr>
+        <p:txBody>
+          <a:bodyPr wrap="square" rtlCol="0" anchor="t"/>
+          <a:lstStyle/>
+          <a:p>
+            <a:pPr indent="0" marL="0">
+              <a:buNone/>
+            </a:pPr>
+            <a:r>
+              <a:rPr lang="en-US" sz="1050" dirty="0">
+                <a:solidFill>
+                  <a:srgbClr val="555555"/>
+                </a:solidFill>
+                <a:latin typeface="Calibri" pitchFamily="34" charset="0"/>
+                <a:ea typeface="Calibri" pitchFamily="34" charset="-122"/>
+                <a:cs typeface="Calibri" pitchFamily="34" charset="-120"/>
+              </a:rPr>
+              <a:t>A phased ERP consolidation already delivering results. Phase 1 beat forecast by $5.7M. Three phases remain.</a:t>
+            </a:r>
+            <a:endParaRPr lang="en-US" sz="1050" dirty="0"/>
+          </a:p>
+        </p:txBody>
+      </p:sp>
+      <p:sp>
+        <p:nvSpPr>
+          <p:cNvPr id="37" name="Shape 35"/>
+          <p:cNvSpPr/>
+          <p:nvPr/>
+        </p:nvSpPr>
+        <p:spPr>
+          <a:xfrm>
+            <a:off x="8308848" y="5193792"/>
+            <a:ext cx="3331464" cy="256032"/>
+          </a:xfrm>
+          <a:prstGeom prst="roundRect">
+            <a:avLst>
+              <a:gd name="adj" fmla="val 14286"/>
+            </a:avLst>
+          </a:prstGeom>
+          <a:solidFill>
+            <a:srgbClr val="F5F4F8"/>
+          </a:solidFill>
+          <a:ln w="6350">
+            <a:solidFill>
+              <a:srgbClr val="DDDDDD"/>
+            </a:solidFill>
+            <a:prstDash val="solid"/>
+          </a:ln>
+        </p:spPr>
+      </p:sp>
+      <p:sp>
+        <p:nvSpPr>
+          <p:cNvPr id="38" name="Text 36"/>
+          <p:cNvSpPr/>
+          <p:nvPr/>
+        </p:nvSpPr>
+        <p:spPr>
+          <a:xfrm>
+            <a:off x="8308848" y="5193792"/>
+            <a:ext cx="3331464" cy="256032"/>
+          </a:xfrm>
+          <a:prstGeom prst="rect">
+            <a:avLst/>
+          </a:prstGeom>
+          <a:noFill/>
+          <a:ln/>
+        </p:spPr>
+        <p:txBody>
+          <a:bodyPr wrap="square" rtlCol="0" anchor="ctr"/>
+          <a:lstStyle/>
+          <a:p>
+            <a:pPr algn="ctr" indent="0" marL="0">
+              <a:buNone/>
+            </a:pPr>
+            <a:r>
+              <a:rPr lang="en-US" sz="800" dirty="0">
+                <a:solidFill>
+                  <a:srgbClr val="888888"/>
+                </a:solidFill>
+                <a:latin typeface="Calibri" pitchFamily="34" charset="0"/>
+                <a:ea typeface="Calibri" pitchFamily="34" charset="-122"/>
+                <a:cs typeface="Calibri" pitchFamily="34" charset="-120"/>
+              </a:rPr>
+              <a:t>Slides 06 – 07</a:t>
+            </a:r>
+            <a:endParaRPr lang="en-US" sz="800" dirty="0"/>
+          </a:p>
+        </p:txBody>
+      </p:sp>
+      <p:sp>
+        <p:nvSpPr>
+          <p:cNvPr id="39" name="Text 37"/>
+          <p:cNvSpPr/>
+          <p:nvPr/>
+        </p:nvSpPr>
+        <p:spPr>
+          <a:xfrm>
+            <a:off x="4081272" y="3675888"/>
+            <a:ext cx="292608" cy="329184"/>
+          </a:xfrm>
+          <a:prstGeom prst="rect">
+            <a:avLst/>
+          </a:prstGeom>
+          <a:noFill/>
+          <a:ln/>
+        </p:spPr>
+        <p:txBody>
+          <a:bodyPr wrap="square" rtlCol="0" anchor="ctr"/>
+          <a:lstStyle/>
+          <a:p>
+            <a:pPr algn="ctr" indent="0" marL="0">
+              <a:buNone/>
+            </a:pPr>
+            <a:r>
+              <a:rPr lang="en-US" sz="1600" b="1" dirty="0">
+                <a:solidFill>
+                  <a:srgbClr val="C4AEED"/>
+                </a:solidFill>
+                <a:latin typeface="Calibri" pitchFamily="34" charset="0"/>
+                <a:ea typeface="Calibri" pitchFamily="34" charset="-122"/>
+                <a:cs typeface="Calibri" pitchFamily="34" charset="-120"/>
+              </a:rPr>
+              <a:t>→</a:t>
+            </a:r>
+            <a:endParaRPr lang="en-US" sz="1600" dirty="0"/>
+          </a:p>
+        </p:txBody>
+      </p:sp>
+      <p:sp>
+        <p:nvSpPr>
+          <p:cNvPr id="40" name="Text 38"/>
+          <p:cNvSpPr/>
+          <p:nvPr/>
+        </p:nvSpPr>
+        <p:spPr>
+          <a:xfrm>
+            <a:off x="7961376" y="3675888"/>
+            <a:ext cx="292608" cy="329184"/>
+          </a:xfrm>
+          <a:prstGeom prst="rect">
+            <a:avLst/>
+          </a:prstGeom>
+          <a:noFill/>
+          <a:ln/>
+        </p:spPr>
+        <p:txBody>
+          <a:bodyPr wrap="square" rtlCol="0" anchor="ctr"/>
+          <a:lstStyle/>
+          <a:p>
+            <a:pPr algn="ctr" indent="0" marL="0">
+              <a:buNone/>
+            </a:pPr>
+            <a:r>
+              <a:rPr lang="en-US" sz="1600" b="1" dirty="0">
+                <a:solidFill>
+                  <a:srgbClr val="C4AEED"/>
+                </a:solidFill>
+                <a:latin typeface="Calibri" pitchFamily="34" charset="0"/>
+                <a:ea typeface="Calibri" pitchFamily="34" charset="-122"/>
+                <a:cs typeface="Calibri" pitchFamily="34" charset="-120"/>
+              </a:rPr>
+              <a:t>→</a:t>
+            </a:r>
+            <a:endParaRPr lang="en-US" sz="1600" dirty="0"/>
+          </a:p>
+        </p:txBody>
+      </p:sp>
+      <p:sp>
+        <p:nvSpPr>
+          <p:cNvPr id="41" name="Shape 39"/>
+          <p:cNvSpPr/>
+          <p:nvPr/>
+        </p:nvSpPr>
+        <p:spPr>
+          <a:xfrm>
+            <a:off x="0" y="6473952"/>
+            <a:ext cx="12188952" cy="0"/>
+          </a:xfrm>
+          <a:prstGeom prst="line">
+            <a:avLst/>
+          </a:prstGeom>
+          <a:noFill/>
+          <a:ln w="6350">
+            <a:solidFill>
+              <a:srgbClr val="DDDDDD"/>
+            </a:solidFill>
+            <a:prstDash val="solid"/>
+          </a:ln>
+        </p:spPr>
+      </p:sp>
+      <p:sp>
+        <p:nvSpPr>
+          <p:cNvPr id="42" name="Text 40"/>
           <p:cNvSpPr/>
           <p:nvPr/>
         </p:nvSpPr>
@@ -3108,7 +3579,7 @@
       </p:sp>
       <p:sp>
         <p:nvSpPr>
-          <p:cNvPr id="31" name="Text 29"/>
+          <p:cNvPr id="43" name="Text 41"/>
           <p:cNvSpPr/>
           <p:nvPr/>
         </p:nvSpPr>
@@ -3147,7 +3618,7 @@
       </p:sp>
       <p:sp>
         <p:nvSpPr>
-          <p:cNvPr id="32" name="Text 30"/>
+          <p:cNvPr id="44" name="Text 42"/>
           <p:cNvSpPr/>
           <p:nvPr/>
         </p:nvSpPr>

</xml_diff>

<commit_message>
Enrich agenda boxes with stats, body text, and bullet points
Each of the 3 story boxes now has: a large stat callout (dollar figure),
a supporting sentence, and 3 bullet points with specific details.
Box 1: program breakdown ($401.8M/$207M, 890 locations).
Box 2: legacy systems named (PRISM/Distro/SBX), pain points listed.
Box 3: phase-by-phase summary with Phase 1 results called out.

https://claude.ai/code/session_01KWybSEC2vfMTAERCxx1Z2W
</commit_message>
<xml_diff>
--- a/public/Inventory-at-Asurion.pptx
+++ b/public/Inventory-at-Asurion.pptx
@@ -2348,11 +2348,11 @@
         <p:spPr>
           <a:xfrm>
             <a:off x="365760" y="2103120"/>
-            <a:ext cx="3697224" cy="3474720"/>
+            <a:ext cx="3697224" cy="4041648"/>
           </a:xfrm>
           <a:prstGeom prst="roundRect">
             <a:avLst>
-              <a:gd name="adj" fmla="val 1842"/>
+              <a:gd name="adj" fmla="val 1731"/>
             </a:avLst>
           </a:prstGeom>
           <a:solidFill>
@@ -2529,7 +2529,7 @@
         </p:nvSpPr>
         <p:spPr>
           <a:xfrm>
-            <a:off x="548640" y="2779776"/>
+            <a:off x="548640" y="2761488"/>
             <a:ext cx="3331464" cy="0"/>
           </a:xfrm>
           <a:prstGeom prst="line">
@@ -2552,64 +2552,165 @@
         </p:nvSpPr>
         <p:spPr>
           <a:xfrm>
-            <a:off x="548640" y="2871216"/>
-            <a:ext cx="3331464" cy="658368"/>
-          </a:xfrm>
-          <a:prstGeom prst="rect">
-            <a:avLst/>
-          </a:prstGeom>
-          <a:noFill/>
-          <a:ln/>
-        </p:spPr>
-        <p:txBody>
-          <a:bodyPr wrap="square" rtlCol="0" anchor="t"/>
-          <a:lstStyle/>
-          <a:p>
-            <a:pPr indent="0" marL="0">
-              <a:buNone/>
-            </a:pPr>
-            <a:r>
-              <a:rPr lang="en-US" sz="1300" b="1" dirty="0">
-                <a:solidFill>
-                  <a:srgbClr val="111111"/>
+            <a:off x="548640" y="2834640"/>
+            <a:ext cx="3331464" cy="475488"/>
+          </a:xfrm>
+          <a:prstGeom prst="rect">
+            <a:avLst/>
+          </a:prstGeom>
+          <a:noFill/>
+          <a:ln/>
+        </p:spPr>
+        <p:txBody>
+          <a:bodyPr wrap="square" rtlCol="0" anchor="ctr"/>
+          <a:lstStyle/>
+          <a:p>
+            <a:pPr indent="0" marL="0">
+              <a:buNone/>
+            </a:pPr>
+            <a:r>
+              <a:rPr lang="en-US" sz="2600" b="1" dirty="0">
+                <a:solidFill>
+                  <a:srgbClr val="5B2C8D"/>
                 </a:solidFill>
                 <a:latin typeface="Calibri Light" pitchFamily="34" charset="0"/>
                 <a:ea typeface="Calibri Light" pitchFamily="34" charset="-122"/>
                 <a:cs typeface="Calibri Light" pitchFamily="34" charset="-120"/>
               </a:rPr>
+              <a:t>~$609M</a:t>
+            </a:r>
+            <a:endParaRPr lang="en-US" sz="2600" dirty="0"/>
+          </a:p>
+        </p:txBody>
+      </p:sp>
+      <p:sp>
+        <p:nvSpPr>
+          <p:cNvPr id="14" name="Text 12"/>
+          <p:cNvSpPr/>
+          <p:nvPr/>
+        </p:nvSpPr>
+        <p:spPr>
+          <a:xfrm>
+            <a:off x="548640" y="3291840"/>
+            <a:ext cx="3331464" cy="201168"/>
+          </a:xfrm>
+          <a:prstGeom prst="rect">
+            <a:avLst/>
+          </a:prstGeom>
+          <a:noFill/>
+          <a:ln/>
+        </p:spPr>
+        <p:txBody>
+          <a:bodyPr wrap="square" rtlCol="0" anchor="ctr"/>
+          <a:lstStyle/>
+          <a:p>
+            <a:pPr indent="0" marL="0">
+              <a:buNone/>
+            </a:pPr>
+            <a:r>
+              <a:rPr lang="en-US" sz="800" dirty="0">
+                <a:solidFill>
+                  <a:srgbClr val="888888"/>
+                </a:solidFill>
+                <a:latin typeface="Calibri" pitchFamily="34" charset="0"/>
+                <a:ea typeface="Calibri" pitchFamily="34" charset="-122"/>
+                <a:cs typeface="Calibri" pitchFamily="34" charset="-120"/>
+              </a:rPr>
+              <a:t>total inventory value</a:t>
+            </a:r>
+            <a:endParaRPr lang="en-US" sz="800" dirty="0"/>
+          </a:p>
+        </p:txBody>
+      </p:sp>
+      <p:sp>
+        <p:nvSpPr>
+          <p:cNvPr id="15" name="Shape 13"/>
+          <p:cNvSpPr/>
+          <p:nvPr/>
+        </p:nvSpPr>
+        <p:spPr>
+          <a:xfrm>
+            <a:off x="548640" y="3547872"/>
+            <a:ext cx="3331464" cy="0"/>
+          </a:xfrm>
+          <a:prstGeom prst="line">
+            <a:avLst/>
+          </a:prstGeom>
+          <a:noFill/>
+          <a:ln w="5080">
+            <a:solidFill>
+              <a:srgbClr val="DDDDDD"/>
+            </a:solidFill>
+            <a:prstDash val="solid"/>
+          </a:ln>
+        </p:spPr>
+      </p:sp>
+      <p:sp>
+        <p:nvSpPr>
+          <p:cNvPr id="16" name="Text 14"/>
+          <p:cNvSpPr/>
+          <p:nvPr/>
+        </p:nvSpPr>
+        <p:spPr>
+          <a:xfrm>
+            <a:off x="548640" y="3621024"/>
+            <a:ext cx="3331464" cy="594360"/>
+          </a:xfrm>
+          <a:prstGeom prst="rect">
+            <a:avLst/>
+          </a:prstGeom>
+          <a:noFill/>
+          <a:ln/>
+        </p:spPr>
+        <p:txBody>
+          <a:bodyPr wrap="square" rtlCol="0" anchor="t"/>
+          <a:lstStyle/>
+          <a:p>
+            <a:pPr indent="0" marL="0">
+              <a:buNone/>
+            </a:pPr>
+            <a:r>
+              <a:rPr lang="en-US" sz="1200" b="1" dirty="0">
+                <a:solidFill>
+                  <a:srgbClr val="111111"/>
+                </a:solidFill>
+                <a:latin typeface="Calibri" pitchFamily="34" charset="0"/>
+                <a:ea typeface="Calibri" pitchFamily="34" charset="-122"/>
+                <a:cs typeface="Calibri" pitchFamily="34" charset="-120"/>
+              </a:rPr>
               <a:t>What inventory is</a:t>
             </a:r>
-            <a:endParaRPr lang="en-US" sz="1300" dirty="0"/>
-          </a:p>
-          <a:p>
-            <a:pPr indent="0" marL="0">
-              <a:buNone/>
-            </a:pPr>
-            <a:r>
-              <a:rPr lang="en-US" sz="1300" b="1" dirty="0">
+            <a:endParaRPr lang="en-US" sz="1200" dirty="0"/>
+          </a:p>
+          <a:p>
+            <a:pPr indent="0" marL="0">
+              <a:buNone/>
+            </a:pPr>
+            <a:r>
+              <a:rPr lang="en-US" sz="1200" b="1" dirty="0">
                 <a:solidFill>
                   <a:srgbClr val="111111"/>
                 </a:solidFill>
-                <a:latin typeface="Calibri Light" pitchFamily="34" charset="0"/>
-                <a:ea typeface="Calibri Light" pitchFamily="34" charset="-122"/>
-                <a:cs typeface="Calibri Light" pitchFamily="34" charset="-120"/>
+                <a:latin typeface="Calibri" pitchFamily="34" charset="0"/>
+                <a:ea typeface="Calibri" pitchFamily="34" charset="-122"/>
+                <a:cs typeface="Calibri" pitchFamily="34" charset="-120"/>
               </a:rPr>
               <a:t>and where it lives</a:t>
             </a:r>
-            <a:endParaRPr lang="en-US" sz="1300" dirty="0"/>
-          </a:p>
-        </p:txBody>
-      </p:sp>
-      <p:sp>
-        <p:nvSpPr>
-          <p:cNvPr id="14" name="Text 12"/>
-          <p:cNvSpPr/>
-          <p:nvPr/>
-        </p:nvSpPr>
-        <p:spPr>
-          <a:xfrm>
-            <a:off x="548640" y="3621024"/>
-            <a:ext cx="3331464" cy="1508760"/>
+            <a:endParaRPr lang="en-US" sz="1200" dirty="0"/>
+          </a:p>
+        </p:txBody>
+      </p:sp>
+      <p:sp>
+        <p:nvSpPr>
+          <p:cNvPr id="17" name="Text 15"/>
+          <p:cNvSpPr/>
+          <p:nvPr/>
+        </p:nvSpPr>
+        <p:spPr>
+          <a:xfrm>
+            <a:off x="548640" y="4261104"/>
+            <a:ext cx="3331464" cy="566928"/>
           </a:xfrm>
           <a:prstGeom prst="rect">
             <a:avLst/>
@@ -2625,7 +2726,7 @@
               <a:buNone/>
             </a:pPr>
             <a:r>
-              <a:rPr lang="en-US" sz="1050" dirty="0">
+              <a:rPr lang="en-US" sz="900" dirty="0">
                 <a:solidFill>
                   <a:srgbClr val="555555"/>
                 </a:solidFill>
@@ -2633,26 +2734,218 @@
                 <a:ea typeface="Calibri" pitchFamily="34" charset="-122"/>
                 <a:cs typeface="Calibri" pitchFamily="34" charset="-120"/>
               </a:rPr>
-              <a:t>~$609M across replacement, repair, and reverse logistics — touching every service motion Asurion runs.</a:t>
-            </a:r>
-            <a:endParaRPr lang="en-US" sz="1050" dirty="0"/>
-          </a:p>
-        </p:txBody>
-      </p:sp>
-      <p:sp>
-        <p:nvSpPr>
-          <p:cNvPr id="15" name="Shape 13"/>
-          <p:cNvSpPr/>
-          <p:nvPr/>
-        </p:nvSpPr>
-        <p:spPr>
-          <a:xfrm>
-            <a:off x="548640" y="5193792"/>
-            <a:ext cx="3331464" cy="256032"/>
+              <a:t>Inventory is Asurion's operational backbone — every service motion depends on it being in the right place at the right time.</a:t>
+            </a:r>
+            <a:endParaRPr lang="en-US" sz="900" dirty="0"/>
+          </a:p>
+        </p:txBody>
+      </p:sp>
+      <p:sp>
+        <p:nvSpPr>
+          <p:cNvPr id="18" name="Shape 16"/>
+          <p:cNvSpPr/>
+          <p:nvPr/>
+        </p:nvSpPr>
+        <p:spPr>
+          <a:xfrm>
+            <a:off x="548640" y="4983480"/>
+            <a:ext cx="73152" cy="73152"/>
+          </a:xfrm>
+          <a:prstGeom prst="ellipse">
+            <a:avLst/>
+          </a:prstGeom>
+          <a:solidFill>
+            <a:srgbClr val="5B2C8D"/>
+          </a:solidFill>
+          <a:ln w="12700">
+            <a:solidFill>
+              <a:srgbClr val="5B2C8D"/>
+            </a:solidFill>
+            <a:prstDash val="solid"/>
+          </a:ln>
+        </p:spPr>
+      </p:sp>
+      <p:sp>
+        <p:nvSpPr>
+          <p:cNvPr id="19" name="Text 17"/>
+          <p:cNvSpPr/>
+          <p:nvPr/>
+        </p:nvSpPr>
+        <p:spPr>
+          <a:xfrm>
+            <a:off x="694944" y="4901184"/>
+            <a:ext cx="3185160" cy="329184"/>
+          </a:xfrm>
+          <a:prstGeom prst="rect">
+            <a:avLst/>
+          </a:prstGeom>
+          <a:noFill/>
+          <a:ln/>
+        </p:spPr>
+        <p:txBody>
+          <a:bodyPr wrap="square" rtlCol="0" anchor="ctr"/>
+          <a:lstStyle/>
+          <a:p>
+            <a:pPr indent="0" marL="0">
+              <a:buNone/>
+            </a:pPr>
+            <a:r>
+              <a:rPr lang="en-US" sz="900" dirty="0">
+                <a:solidFill>
+                  <a:srgbClr val="333333"/>
+                </a:solidFill>
+                <a:latin typeface="Calibri" pitchFamily="34" charset="0"/>
+                <a:ea typeface="Calibri" pitchFamily="34" charset="-122"/>
+                <a:cs typeface="Calibri" pitchFamily="34" charset="-120"/>
+              </a:rPr>
+              <a:t>$401.8M in Replacement (AE, DES, NDES, ISP)</a:t>
+            </a:r>
+            <a:endParaRPr lang="en-US" sz="900" dirty="0"/>
+          </a:p>
+        </p:txBody>
+      </p:sp>
+      <p:sp>
+        <p:nvSpPr>
+          <p:cNvPr id="20" name="Shape 18"/>
+          <p:cNvSpPr/>
+          <p:nvPr/>
+        </p:nvSpPr>
+        <p:spPr>
+          <a:xfrm>
+            <a:off x="548640" y="5349240"/>
+            <a:ext cx="73152" cy="73152"/>
+          </a:xfrm>
+          <a:prstGeom prst="ellipse">
+            <a:avLst/>
+          </a:prstGeom>
+          <a:solidFill>
+            <a:srgbClr val="5B2C8D"/>
+          </a:solidFill>
+          <a:ln w="12700">
+            <a:solidFill>
+              <a:srgbClr val="5B2C8D"/>
+            </a:solidFill>
+            <a:prstDash val="solid"/>
+          </a:ln>
+        </p:spPr>
+      </p:sp>
+      <p:sp>
+        <p:nvSpPr>
+          <p:cNvPr id="21" name="Text 19"/>
+          <p:cNvSpPr/>
+          <p:nvPr/>
+        </p:nvSpPr>
+        <p:spPr>
+          <a:xfrm>
+            <a:off x="694944" y="5266944"/>
+            <a:ext cx="3185160" cy="329184"/>
+          </a:xfrm>
+          <a:prstGeom prst="rect">
+            <a:avLst/>
+          </a:prstGeom>
+          <a:noFill/>
+          <a:ln/>
+        </p:spPr>
+        <p:txBody>
+          <a:bodyPr wrap="square" rtlCol="0" anchor="ctr"/>
+          <a:lstStyle/>
+          <a:p>
+            <a:pPr indent="0" marL="0">
+              <a:buNone/>
+            </a:pPr>
+            <a:r>
+              <a:rPr lang="en-US" sz="900" dirty="0">
+                <a:solidFill>
+                  <a:srgbClr val="333333"/>
+                </a:solidFill>
+                <a:latin typeface="Calibri" pitchFamily="34" charset="0"/>
+                <a:ea typeface="Calibri" pitchFamily="34" charset="-122"/>
+                <a:cs typeface="Calibri" pitchFamily="34" charset="-120"/>
+              </a:rPr>
+              <a:t>$207M in Repair (uBreakiFix, SUR, UROC)</a:t>
+            </a:r>
+            <a:endParaRPr lang="en-US" sz="900" dirty="0"/>
+          </a:p>
+        </p:txBody>
+      </p:sp>
+      <p:sp>
+        <p:nvSpPr>
+          <p:cNvPr id="22" name="Shape 20"/>
+          <p:cNvSpPr/>
+          <p:nvPr/>
+        </p:nvSpPr>
+        <p:spPr>
+          <a:xfrm>
+            <a:off x="548640" y="5715000"/>
+            <a:ext cx="73152" cy="73152"/>
+          </a:xfrm>
+          <a:prstGeom prst="ellipse">
+            <a:avLst/>
+          </a:prstGeom>
+          <a:solidFill>
+            <a:srgbClr val="5B2C8D"/>
+          </a:solidFill>
+          <a:ln w="12700">
+            <a:solidFill>
+              <a:srgbClr val="5B2C8D"/>
+            </a:solidFill>
+            <a:prstDash val="solid"/>
+          </a:ln>
+        </p:spPr>
+      </p:sp>
+      <p:sp>
+        <p:nvSpPr>
+          <p:cNvPr id="23" name="Text 21"/>
+          <p:cNvSpPr/>
+          <p:nvPr/>
+        </p:nvSpPr>
+        <p:spPr>
+          <a:xfrm>
+            <a:off x="694944" y="5632704"/>
+            <a:ext cx="3185160" cy="329184"/>
+          </a:xfrm>
+          <a:prstGeom prst="rect">
+            <a:avLst/>
+          </a:prstGeom>
+          <a:noFill/>
+          <a:ln/>
+        </p:spPr>
+        <p:txBody>
+          <a:bodyPr wrap="square" rtlCol="0" anchor="ctr"/>
+          <a:lstStyle/>
+          <a:p>
+            <a:pPr indent="0" marL="0">
+              <a:buNone/>
+            </a:pPr>
+            <a:r>
+              <a:rPr lang="en-US" sz="900" dirty="0">
+                <a:solidFill>
+                  <a:srgbClr val="333333"/>
+                </a:solidFill>
+                <a:latin typeface="Calibri" pitchFamily="34" charset="0"/>
+                <a:ea typeface="Calibri" pitchFamily="34" charset="-122"/>
+                <a:cs typeface="Calibri" pitchFamily="34" charset="-120"/>
+              </a:rPr>
+              <a:t>~890 locations: warehouses, FSLs, stores &amp; vendors</a:t>
+            </a:r>
+            <a:endParaRPr lang="en-US" sz="900" dirty="0"/>
+          </a:p>
+        </p:txBody>
+      </p:sp>
+      <p:sp>
+        <p:nvSpPr>
+          <p:cNvPr id="24" name="Shape 22"/>
+          <p:cNvSpPr/>
+          <p:nvPr/>
+        </p:nvSpPr>
+        <p:spPr>
+          <a:xfrm>
+            <a:off x="548640" y="5797296"/>
+            <a:ext cx="3331464" cy="237744"/>
           </a:xfrm>
           <a:prstGeom prst="roundRect">
             <a:avLst>
-              <a:gd name="adj" fmla="val 14286"/>
+              <a:gd name="adj" fmla="val 15385"/>
             </a:avLst>
           </a:prstGeom>
           <a:solidFill>
@@ -2668,14 +2961,14 @@
       </p:sp>
       <p:sp>
         <p:nvSpPr>
-          <p:cNvPr id="16" name="Text 14"/>
-          <p:cNvSpPr/>
-          <p:nvPr/>
-        </p:nvSpPr>
-        <p:spPr>
-          <a:xfrm>
-            <a:off x="548640" y="5193792"/>
-            <a:ext cx="3331464" cy="256032"/>
+          <p:cNvPr id="25" name="Text 23"/>
+          <p:cNvSpPr/>
+          <p:nvPr/>
+        </p:nvSpPr>
+        <p:spPr>
+          <a:xfrm>
+            <a:off x="548640" y="5797296"/>
+            <a:ext cx="3331464" cy="237744"/>
           </a:xfrm>
           <a:prstGeom prst="rect">
             <a:avLst/>
@@ -2707,18 +3000,18 @@
       </p:sp>
       <p:sp>
         <p:nvSpPr>
-          <p:cNvPr id="17" name="Shape 15"/>
+          <p:cNvPr id="26" name="Shape 24"/>
           <p:cNvSpPr/>
           <p:nvPr/>
         </p:nvSpPr>
         <p:spPr>
           <a:xfrm>
             <a:off x="4245864" y="2103120"/>
-            <a:ext cx="3697224" cy="3474720"/>
+            <a:ext cx="3697224" cy="4041648"/>
           </a:xfrm>
           <a:prstGeom prst="roundRect">
             <a:avLst>
-              <a:gd name="adj" fmla="val 1842"/>
+              <a:gd name="adj" fmla="val 1731"/>
             </a:avLst>
           </a:prstGeom>
           <a:solidFill>
@@ -2734,7 +3027,7 @@
       </p:sp>
       <p:sp>
         <p:nvSpPr>
-          <p:cNvPr id="18" name="Shape 16"/>
+          <p:cNvPr id="27" name="Shape 25"/>
           <p:cNvSpPr/>
           <p:nvPr/>
         </p:nvSpPr>
@@ -2761,7 +3054,7 @@
       </p:sp>
       <p:sp>
         <p:nvSpPr>
-          <p:cNvPr id="19" name="Shape 17"/>
+          <p:cNvPr id="28" name="Shape 26"/>
           <p:cNvSpPr/>
           <p:nvPr/>
         </p:nvSpPr>
@@ -2786,7 +3079,7 @@
       </p:sp>
       <p:sp>
         <p:nvSpPr>
-          <p:cNvPr id="20" name="Shape 18"/>
+          <p:cNvPr id="29" name="Shape 27"/>
           <p:cNvSpPr/>
           <p:nvPr/>
         </p:nvSpPr>
@@ -2811,7 +3104,7 @@
       </p:sp>
       <p:sp>
         <p:nvSpPr>
-          <p:cNvPr id="21" name="Text 19"/>
+          <p:cNvPr id="30" name="Text 28"/>
           <p:cNvSpPr/>
           <p:nvPr/>
         </p:nvSpPr>
@@ -2850,7 +3143,7 @@
       </p:sp>
       <p:sp>
         <p:nvSpPr>
-          <p:cNvPr id="22" name="Text 20"/>
+          <p:cNvPr id="31" name="Text 29"/>
           <p:cNvSpPr/>
           <p:nvPr/>
         </p:nvSpPr>
@@ -2889,13 +3182,13 @@
       </p:sp>
       <p:sp>
         <p:nvSpPr>
-          <p:cNvPr id="23" name="Shape 21"/>
-          <p:cNvSpPr/>
-          <p:nvPr/>
-        </p:nvSpPr>
-        <p:spPr>
-          <a:xfrm>
-            <a:off x="4428744" y="2779776"/>
+          <p:cNvPr id="32" name="Shape 30"/>
+          <p:cNvSpPr/>
+          <p:nvPr/>
+        </p:nvSpPr>
+        <p:spPr>
+          <a:xfrm>
+            <a:off x="4428744" y="2761488"/>
             <a:ext cx="3331464" cy="0"/>
           </a:xfrm>
           <a:prstGeom prst="line">
@@ -2912,70 +3205,171 @@
       </p:sp>
       <p:sp>
         <p:nvSpPr>
-          <p:cNvPr id="24" name="Text 22"/>
-          <p:cNvSpPr/>
-          <p:nvPr/>
-        </p:nvSpPr>
-        <p:spPr>
-          <a:xfrm>
-            <a:off x="4428744" y="2871216"/>
-            <a:ext cx="3331464" cy="658368"/>
-          </a:xfrm>
-          <a:prstGeom prst="rect">
-            <a:avLst/>
-          </a:prstGeom>
-          <a:noFill/>
-          <a:ln/>
-        </p:spPr>
-        <p:txBody>
-          <a:bodyPr wrap="square" rtlCol="0" anchor="t"/>
-          <a:lstStyle/>
-          <a:p>
-            <a:pPr indent="0" marL="0">
-              <a:buNone/>
-            </a:pPr>
-            <a:r>
-              <a:rPr lang="en-US" sz="1300" b="1" dirty="0">
-                <a:solidFill>
-                  <a:srgbClr val="111111"/>
+          <p:cNvPr id="33" name="Text 31"/>
+          <p:cNvSpPr/>
+          <p:nvPr/>
+        </p:nvSpPr>
+        <p:spPr>
+          <a:xfrm>
+            <a:off x="4428744" y="2834640"/>
+            <a:ext cx="3331464" cy="475488"/>
+          </a:xfrm>
+          <a:prstGeom prst="rect">
+            <a:avLst/>
+          </a:prstGeom>
+          <a:noFill/>
+          <a:ln/>
+        </p:spPr>
+        <p:txBody>
+          <a:bodyPr wrap="square" rtlCol="0" anchor="ctr"/>
+          <a:lstStyle/>
+          <a:p>
+            <a:pPr indent="0" marL="0">
+              <a:buNone/>
+            </a:pPr>
+            <a:r>
+              <a:rPr lang="en-US" sz="2600" b="1" dirty="0">
+                <a:solidFill>
+                  <a:srgbClr val="5B2C8D"/>
                 </a:solidFill>
                 <a:latin typeface="Calibri Light" pitchFamily="34" charset="0"/>
                 <a:ea typeface="Calibri Light" pitchFamily="34" charset="-122"/>
                 <a:cs typeface="Calibri Light" pitchFamily="34" charset="-120"/>
               </a:rPr>
+              <a:t>$207M</a:t>
+            </a:r>
+            <a:endParaRPr lang="en-US" sz="2600" dirty="0"/>
+          </a:p>
+        </p:txBody>
+      </p:sp>
+      <p:sp>
+        <p:nvSpPr>
+          <p:cNvPr id="34" name="Text 32"/>
+          <p:cNvSpPr/>
+          <p:nvPr/>
+        </p:nvSpPr>
+        <p:spPr>
+          <a:xfrm>
+            <a:off x="4428744" y="3291840"/>
+            <a:ext cx="3331464" cy="201168"/>
+          </a:xfrm>
+          <a:prstGeom prst="rect">
+            <a:avLst/>
+          </a:prstGeom>
+          <a:noFill/>
+          <a:ln/>
+        </p:spPr>
+        <p:txBody>
+          <a:bodyPr wrap="square" rtlCol="0" anchor="ctr"/>
+          <a:lstStyle/>
+          <a:p>
+            <a:pPr indent="0" marL="0">
+              <a:buNone/>
+            </a:pPr>
+            <a:r>
+              <a:rPr lang="en-US" sz="800" dirty="0">
+                <a:solidFill>
+                  <a:srgbClr val="888888"/>
+                </a:solidFill>
+                <a:latin typeface="Calibri" pitchFamily="34" charset="0"/>
+                <a:ea typeface="Calibri" pitchFamily="34" charset="-122"/>
+                <a:cs typeface="Calibri" pitchFamily="34" charset="-120"/>
+              </a:rPr>
+              <a:t>outside D365 F&amp;O today</a:t>
+            </a:r>
+            <a:endParaRPr lang="en-US" sz="800" dirty="0"/>
+          </a:p>
+        </p:txBody>
+      </p:sp>
+      <p:sp>
+        <p:nvSpPr>
+          <p:cNvPr id="35" name="Shape 33"/>
+          <p:cNvSpPr/>
+          <p:nvPr/>
+        </p:nvSpPr>
+        <p:spPr>
+          <a:xfrm>
+            <a:off x="4428744" y="3547872"/>
+            <a:ext cx="3331464" cy="0"/>
+          </a:xfrm>
+          <a:prstGeom prst="line">
+            <a:avLst/>
+          </a:prstGeom>
+          <a:noFill/>
+          <a:ln w="5080">
+            <a:solidFill>
+              <a:srgbClr val="DDDDDD"/>
+            </a:solidFill>
+            <a:prstDash val="solid"/>
+          </a:ln>
+        </p:spPr>
+      </p:sp>
+      <p:sp>
+        <p:nvSpPr>
+          <p:cNvPr id="36" name="Text 34"/>
+          <p:cNvSpPr/>
+          <p:nvPr/>
+        </p:nvSpPr>
+        <p:spPr>
+          <a:xfrm>
+            <a:off x="4428744" y="3621024"/>
+            <a:ext cx="3331464" cy="594360"/>
+          </a:xfrm>
+          <a:prstGeom prst="rect">
+            <a:avLst/>
+          </a:prstGeom>
+          <a:noFill/>
+          <a:ln/>
+        </p:spPr>
+        <p:txBody>
+          <a:bodyPr wrap="square" rtlCol="0" anchor="t"/>
+          <a:lstStyle/>
+          <a:p>
+            <a:pPr indent="0" marL="0">
+              <a:buNone/>
+            </a:pPr>
+            <a:r>
+              <a:rPr lang="en-US" sz="1200" b="1" dirty="0">
+                <a:solidFill>
+                  <a:srgbClr val="111111"/>
+                </a:solidFill>
+                <a:latin typeface="Calibri" pitchFamily="34" charset="0"/>
+                <a:ea typeface="Calibri" pitchFamily="34" charset="-122"/>
+                <a:cs typeface="Calibri" pitchFamily="34" charset="-120"/>
+              </a:rPr>
               <a:t>Why fragmented systems</a:t>
             </a:r>
-            <a:endParaRPr lang="en-US" sz="1300" dirty="0"/>
-          </a:p>
-          <a:p>
-            <a:pPr indent="0" marL="0">
-              <a:buNone/>
-            </a:pPr>
-            <a:r>
-              <a:rPr lang="en-US" sz="1300" b="1" dirty="0">
+            <a:endParaRPr lang="en-US" sz="1200" dirty="0"/>
+          </a:p>
+          <a:p>
+            <a:pPr indent="0" marL="0">
+              <a:buNone/>
+            </a:pPr>
+            <a:r>
+              <a:rPr lang="en-US" sz="1200" b="1" dirty="0">
                 <a:solidFill>
                   <a:srgbClr val="111111"/>
                 </a:solidFill>
-                <a:latin typeface="Calibri Light" pitchFamily="34" charset="0"/>
-                <a:ea typeface="Calibri Light" pitchFamily="34" charset="-122"/>
-                <a:cs typeface="Calibri Light" pitchFamily="34" charset="-120"/>
+                <a:latin typeface="Calibri" pitchFamily="34" charset="0"/>
+                <a:ea typeface="Calibri" pitchFamily="34" charset="-122"/>
+                <a:cs typeface="Calibri" pitchFamily="34" charset="-120"/>
               </a:rPr>
               <a:t>create financial risk</a:t>
             </a:r>
-            <a:endParaRPr lang="en-US" sz="1300" dirty="0"/>
-          </a:p>
-        </p:txBody>
-      </p:sp>
-      <p:sp>
-        <p:nvSpPr>
-          <p:cNvPr id="25" name="Text 23"/>
-          <p:cNvSpPr/>
-          <p:nvPr/>
-        </p:nvSpPr>
-        <p:spPr>
-          <a:xfrm>
-            <a:off x="4428744" y="3621024"/>
-            <a:ext cx="3331464" cy="1508760"/>
+            <a:endParaRPr lang="en-US" sz="1200" dirty="0"/>
+          </a:p>
+        </p:txBody>
+      </p:sp>
+      <p:sp>
+        <p:nvSpPr>
+          <p:cNvPr id="37" name="Text 35"/>
+          <p:cNvSpPr/>
+          <p:nvPr/>
+        </p:nvSpPr>
+        <p:spPr>
+          <a:xfrm>
+            <a:off x="4428744" y="4261104"/>
+            <a:ext cx="3331464" cy="566928"/>
           </a:xfrm>
           <a:prstGeom prst="rect">
             <a:avLst/>
@@ -2991,7 +3385,7 @@
               <a:buNone/>
             </a:pPr>
             <a:r>
-              <a:rPr lang="en-US" sz="1050" dirty="0">
+              <a:rPr lang="en-US" sz="900" dirty="0">
                 <a:solidFill>
                   <a:srgbClr val="555555"/>
                 </a:solidFill>
@@ -2999,26 +3393,218 @@
                 <a:ea typeface="Calibri" pitchFamily="34" charset="-122"/>
                 <a:cs typeface="Calibri" pitchFamily="34" charset="-120"/>
               </a:rPr>
-              <a:t>$207M sits on legacy platforms outside D365 F&amp;O. Every split system is a gap where inventory and dollars go untraced.</a:t>
-            </a:r>
-            <a:endParaRPr lang="en-US" sz="1050" dirty="0"/>
-          </a:p>
-        </p:txBody>
-      </p:sp>
-      <p:sp>
-        <p:nvSpPr>
-          <p:cNvPr id="26" name="Shape 24"/>
-          <p:cNvSpPr/>
-          <p:nvPr/>
-        </p:nvSpPr>
-        <p:spPr>
-          <a:xfrm>
-            <a:off x="4428744" y="5193792"/>
-            <a:ext cx="3331464" cy="256032"/>
+              <a:t>When inventory and financials live in separate systems, every unit and dollar becomes harder to trace — and risk grows with volume.</a:t>
+            </a:r>
+            <a:endParaRPr lang="en-US" sz="900" dirty="0"/>
+          </a:p>
+        </p:txBody>
+      </p:sp>
+      <p:sp>
+        <p:nvSpPr>
+          <p:cNvPr id="38" name="Shape 36"/>
+          <p:cNvSpPr/>
+          <p:nvPr/>
+        </p:nvSpPr>
+        <p:spPr>
+          <a:xfrm>
+            <a:off x="4428744" y="4983480"/>
+            <a:ext cx="73152" cy="73152"/>
+          </a:xfrm>
+          <a:prstGeom prst="ellipse">
+            <a:avLst/>
+          </a:prstGeom>
+          <a:solidFill>
+            <a:srgbClr val="5B2C8D"/>
+          </a:solidFill>
+          <a:ln w="12700">
+            <a:solidFill>
+              <a:srgbClr val="5B2C8D"/>
+            </a:solidFill>
+            <a:prstDash val="solid"/>
+          </a:ln>
+        </p:spPr>
+      </p:sp>
+      <p:sp>
+        <p:nvSpPr>
+          <p:cNvPr id="39" name="Text 37"/>
+          <p:cNvSpPr/>
+          <p:nvPr/>
+        </p:nvSpPr>
+        <p:spPr>
+          <a:xfrm>
+            <a:off x="4575048" y="4901184"/>
+            <a:ext cx="3185160" cy="329184"/>
+          </a:xfrm>
+          <a:prstGeom prst="rect">
+            <a:avLst/>
+          </a:prstGeom>
+          <a:noFill/>
+          <a:ln/>
+        </p:spPr>
+        <p:txBody>
+          <a:bodyPr wrap="square" rtlCol="0" anchor="ctr"/>
+          <a:lstStyle/>
+          <a:p>
+            <a:pPr indent="0" marL="0">
+              <a:buNone/>
+            </a:pPr>
+            <a:r>
+              <a:rPr lang="en-US" sz="900" dirty="0">
+                <a:solidFill>
+                  <a:srgbClr val="333333"/>
+                </a:solidFill>
+                <a:latin typeface="Calibri" pitchFamily="34" charset="0"/>
+                <a:ea typeface="Calibri" pitchFamily="34" charset="-122"/>
+                <a:cs typeface="Calibri" pitchFamily="34" charset="-120"/>
+              </a:rPr>
+              <a:t>3 legacy systems: PRISM, Distro, SBX Cycle Count</a:t>
+            </a:r>
+            <a:endParaRPr lang="en-US" sz="900" dirty="0"/>
+          </a:p>
+        </p:txBody>
+      </p:sp>
+      <p:sp>
+        <p:nvSpPr>
+          <p:cNvPr id="40" name="Shape 38"/>
+          <p:cNvSpPr/>
+          <p:nvPr/>
+        </p:nvSpPr>
+        <p:spPr>
+          <a:xfrm>
+            <a:off x="4428744" y="5349240"/>
+            <a:ext cx="73152" cy="73152"/>
+          </a:xfrm>
+          <a:prstGeom prst="ellipse">
+            <a:avLst/>
+          </a:prstGeom>
+          <a:solidFill>
+            <a:srgbClr val="5B2C8D"/>
+          </a:solidFill>
+          <a:ln w="12700">
+            <a:solidFill>
+              <a:srgbClr val="5B2C8D"/>
+            </a:solidFill>
+            <a:prstDash val="solid"/>
+          </a:ln>
+        </p:spPr>
+      </p:sp>
+      <p:sp>
+        <p:nvSpPr>
+          <p:cNvPr id="41" name="Text 39"/>
+          <p:cNvSpPr/>
+          <p:nvPr/>
+        </p:nvSpPr>
+        <p:spPr>
+          <a:xfrm>
+            <a:off x="4575048" y="5266944"/>
+            <a:ext cx="3185160" cy="329184"/>
+          </a:xfrm>
+          <a:prstGeom prst="rect">
+            <a:avLst/>
+          </a:prstGeom>
+          <a:noFill/>
+          <a:ln/>
+        </p:spPr>
+        <p:txBody>
+          <a:bodyPr wrap="square" rtlCol="0" anchor="ctr"/>
+          <a:lstStyle/>
+          <a:p>
+            <a:pPr indent="0" marL="0">
+              <a:buNone/>
+            </a:pPr>
+            <a:r>
+              <a:rPr lang="en-US" sz="900" dirty="0">
+                <a:solidFill>
+                  <a:srgbClr val="333333"/>
+                </a:solidFill>
+                <a:latin typeface="Calibri" pitchFamily="34" charset="0"/>
+                <a:ea typeface="Calibri" pitchFamily="34" charset="-122"/>
+                <a:cs typeface="Calibri" pitchFamily="34" charset="-120"/>
+              </a:rPr>
+              <a:t>Manual reconciliation, billing disputes, delayed visibility</a:t>
+            </a:r>
+            <a:endParaRPr lang="en-US" sz="900" dirty="0"/>
+          </a:p>
+        </p:txBody>
+      </p:sp>
+      <p:sp>
+        <p:nvSpPr>
+          <p:cNvPr id="42" name="Shape 40"/>
+          <p:cNvSpPr/>
+          <p:nvPr/>
+        </p:nvSpPr>
+        <p:spPr>
+          <a:xfrm>
+            <a:off x="4428744" y="5715000"/>
+            <a:ext cx="73152" cy="73152"/>
+          </a:xfrm>
+          <a:prstGeom prst="ellipse">
+            <a:avLst/>
+          </a:prstGeom>
+          <a:solidFill>
+            <a:srgbClr val="5B2C8D"/>
+          </a:solidFill>
+          <a:ln w="12700">
+            <a:solidFill>
+              <a:srgbClr val="5B2C8D"/>
+            </a:solidFill>
+            <a:prstDash val="solid"/>
+          </a:ln>
+        </p:spPr>
+      </p:sp>
+      <p:sp>
+        <p:nvSpPr>
+          <p:cNvPr id="43" name="Text 41"/>
+          <p:cNvSpPr/>
+          <p:nvPr/>
+        </p:nvSpPr>
+        <p:spPr>
+          <a:xfrm>
+            <a:off x="4575048" y="5632704"/>
+            <a:ext cx="3185160" cy="329184"/>
+          </a:xfrm>
+          <a:prstGeom prst="rect">
+            <a:avLst/>
+          </a:prstGeom>
+          <a:noFill/>
+          <a:ln/>
+        </p:spPr>
+        <p:txBody>
+          <a:bodyPr wrap="square" rtlCol="0" anchor="ctr"/>
+          <a:lstStyle/>
+          <a:p>
+            <a:pPr indent="0" marL="0">
+              <a:buNone/>
+            </a:pPr>
+            <a:r>
+              <a:rPr lang="en-US" sz="900" dirty="0">
+                <a:solidFill>
+                  <a:srgbClr val="333333"/>
+                </a:solidFill>
+                <a:latin typeface="Calibri" pitchFamily="34" charset="0"/>
+                <a:ea typeface="Calibri" pitchFamily="34" charset="-122"/>
+                <a:cs typeface="Calibri" pitchFamily="34" charset="-120"/>
+              </a:rPr>
+              <a:t>Financial exposure compounds as programs scale</a:t>
+            </a:r>
+            <a:endParaRPr lang="en-US" sz="900" dirty="0"/>
+          </a:p>
+        </p:txBody>
+      </p:sp>
+      <p:sp>
+        <p:nvSpPr>
+          <p:cNvPr id="44" name="Shape 42"/>
+          <p:cNvSpPr/>
+          <p:nvPr/>
+        </p:nvSpPr>
+        <p:spPr>
+          <a:xfrm>
+            <a:off x="4428744" y="5797296"/>
+            <a:ext cx="3331464" cy="237744"/>
           </a:xfrm>
           <a:prstGeom prst="roundRect">
             <a:avLst>
-              <a:gd name="adj" fmla="val 14286"/>
+              <a:gd name="adj" fmla="val 15385"/>
             </a:avLst>
           </a:prstGeom>
           <a:solidFill>
@@ -3034,14 +3620,14 @@
       </p:sp>
       <p:sp>
         <p:nvSpPr>
-          <p:cNvPr id="27" name="Text 25"/>
-          <p:cNvSpPr/>
-          <p:nvPr/>
-        </p:nvSpPr>
-        <p:spPr>
-          <a:xfrm>
-            <a:off x="4428744" y="5193792"/>
-            <a:ext cx="3331464" cy="256032"/>
+          <p:cNvPr id="45" name="Text 43"/>
+          <p:cNvSpPr/>
+          <p:nvPr/>
+        </p:nvSpPr>
+        <p:spPr>
+          <a:xfrm>
+            <a:off x="4428744" y="5797296"/>
+            <a:ext cx="3331464" cy="237744"/>
           </a:xfrm>
           <a:prstGeom prst="rect">
             <a:avLst/>
@@ -3073,18 +3659,18 @@
       </p:sp>
       <p:sp>
         <p:nvSpPr>
-          <p:cNvPr id="28" name="Shape 26"/>
+          <p:cNvPr id="46" name="Shape 44"/>
           <p:cNvSpPr/>
           <p:nvPr/>
         </p:nvSpPr>
         <p:spPr>
           <a:xfrm>
             <a:off x="8125968" y="2103120"/>
-            <a:ext cx="3697224" cy="3474720"/>
+            <a:ext cx="3697224" cy="4041648"/>
           </a:xfrm>
           <a:prstGeom prst="roundRect">
             <a:avLst>
-              <a:gd name="adj" fmla="val 1842"/>
+              <a:gd name="adj" fmla="val 1731"/>
             </a:avLst>
           </a:prstGeom>
           <a:solidFill>
@@ -3100,7 +3686,7 @@
       </p:sp>
       <p:sp>
         <p:nvSpPr>
-          <p:cNvPr id="29" name="Shape 27"/>
+          <p:cNvPr id="47" name="Shape 45"/>
           <p:cNvSpPr/>
           <p:nvPr/>
         </p:nvSpPr>
@@ -3127,7 +3713,7 @@
       </p:sp>
       <p:sp>
         <p:nvSpPr>
-          <p:cNvPr id="30" name="Shape 28"/>
+          <p:cNvPr id="48" name="Shape 46"/>
           <p:cNvSpPr/>
           <p:nvPr/>
         </p:nvSpPr>
@@ -3152,7 +3738,7 @@
       </p:sp>
       <p:sp>
         <p:nvSpPr>
-          <p:cNvPr id="31" name="Shape 29"/>
+          <p:cNvPr id="49" name="Shape 47"/>
           <p:cNvSpPr/>
           <p:nvPr/>
         </p:nvSpPr>
@@ -3177,7 +3763,7 @@
       </p:sp>
       <p:sp>
         <p:nvSpPr>
-          <p:cNvPr id="32" name="Text 30"/>
+          <p:cNvPr id="50" name="Text 48"/>
           <p:cNvSpPr/>
           <p:nvPr/>
         </p:nvSpPr>
@@ -3216,7 +3802,7 @@
       </p:sp>
       <p:sp>
         <p:nvSpPr>
-          <p:cNvPr id="33" name="Text 31"/>
+          <p:cNvPr id="51" name="Text 49"/>
           <p:cNvSpPr/>
           <p:nvPr/>
         </p:nvSpPr>
@@ -3255,13 +3841,13 @@
       </p:sp>
       <p:sp>
         <p:nvSpPr>
-          <p:cNvPr id="34" name="Shape 32"/>
-          <p:cNvSpPr/>
-          <p:nvPr/>
-        </p:nvSpPr>
-        <p:spPr>
-          <a:xfrm>
-            <a:off x="8308848" y="2779776"/>
+          <p:cNvPr id="52" name="Shape 50"/>
+          <p:cNvSpPr/>
+          <p:nvPr/>
+        </p:nvSpPr>
+        <p:spPr>
+          <a:xfrm>
+            <a:off x="8308848" y="2761488"/>
             <a:ext cx="3331464" cy="0"/>
           </a:xfrm>
           <a:prstGeom prst="line">
@@ -3278,70 +3864,171 @@
       </p:sp>
       <p:sp>
         <p:nvSpPr>
-          <p:cNvPr id="35" name="Text 33"/>
-          <p:cNvSpPr/>
-          <p:nvPr/>
-        </p:nvSpPr>
-        <p:spPr>
-          <a:xfrm>
-            <a:off x="8308848" y="2871216"/>
-            <a:ext cx="3331464" cy="658368"/>
-          </a:xfrm>
-          <a:prstGeom prst="rect">
-            <a:avLst/>
-          </a:prstGeom>
-          <a:noFill/>
-          <a:ln/>
-        </p:spPr>
-        <p:txBody>
-          <a:bodyPr wrap="square" rtlCol="0" anchor="t"/>
-          <a:lstStyle/>
-          <a:p>
-            <a:pPr indent="0" marL="0">
-              <a:buNone/>
-            </a:pPr>
-            <a:r>
-              <a:rPr lang="en-US" sz="1300" b="1" dirty="0">
-                <a:solidFill>
-                  <a:srgbClr val="111111"/>
+          <p:cNvPr id="53" name="Text 51"/>
+          <p:cNvSpPr/>
+          <p:nvPr/>
+        </p:nvSpPr>
+        <p:spPr>
+          <a:xfrm>
+            <a:off x="8308848" y="2834640"/>
+            <a:ext cx="3331464" cy="475488"/>
+          </a:xfrm>
+          <a:prstGeom prst="rect">
+            <a:avLst/>
+          </a:prstGeom>
+          <a:noFill/>
+          <a:ln/>
+        </p:spPr>
+        <p:txBody>
+          <a:bodyPr wrap="square" rtlCol="0" anchor="ctr"/>
+          <a:lstStyle/>
+          <a:p>
+            <a:pPr indent="0" marL="0">
+              <a:buNone/>
+            </a:pPr>
+            <a:r>
+              <a:rPr lang="en-US" sz="2600" b="1" dirty="0">
+                <a:solidFill>
+                  <a:srgbClr val="5B2C8D"/>
                 </a:solidFill>
                 <a:latin typeface="Calibri Light" pitchFamily="34" charset="0"/>
                 <a:ea typeface="Calibri Light" pitchFamily="34" charset="-122"/>
                 <a:cs typeface="Calibri Light" pitchFamily="34" charset="-120"/>
               </a:rPr>
+              <a:t>$5.7M</a:t>
+            </a:r>
+            <a:endParaRPr lang="en-US" sz="2600" dirty="0"/>
+          </a:p>
+        </p:txBody>
+      </p:sp>
+      <p:sp>
+        <p:nvSpPr>
+          <p:cNvPr id="54" name="Text 52"/>
+          <p:cNvSpPr/>
+          <p:nvPr/>
+        </p:nvSpPr>
+        <p:spPr>
+          <a:xfrm>
+            <a:off x="8308848" y="3291840"/>
+            <a:ext cx="3331464" cy="201168"/>
+          </a:xfrm>
+          <a:prstGeom prst="rect">
+            <a:avLst/>
+          </a:prstGeom>
+          <a:noFill/>
+          <a:ln/>
+        </p:spPr>
+        <p:txBody>
+          <a:bodyPr wrap="square" rtlCol="0" anchor="ctr"/>
+          <a:lstStyle/>
+          <a:p>
+            <a:pPr indent="0" marL="0">
+              <a:buNone/>
+            </a:pPr>
+            <a:r>
+              <a:rPr lang="en-US" sz="800" dirty="0">
+                <a:solidFill>
+                  <a:srgbClr val="888888"/>
+                </a:solidFill>
+                <a:latin typeface="Calibri" pitchFamily="34" charset="0"/>
+                <a:ea typeface="Calibri" pitchFamily="34" charset="-122"/>
+                <a:cs typeface="Calibri" pitchFamily="34" charset="-120"/>
+              </a:rPr>
+              <a:t>better than forecast — Phase 1</a:t>
+            </a:r>
+            <a:endParaRPr lang="en-US" sz="800" dirty="0"/>
+          </a:p>
+        </p:txBody>
+      </p:sp>
+      <p:sp>
+        <p:nvSpPr>
+          <p:cNvPr id="55" name="Shape 53"/>
+          <p:cNvSpPr/>
+          <p:nvPr/>
+        </p:nvSpPr>
+        <p:spPr>
+          <a:xfrm>
+            <a:off x="8308848" y="3547872"/>
+            <a:ext cx="3331464" cy="0"/>
+          </a:xfrm>
+          <a:prstGeom prst="line">
+            <a:avLst/>
+          </a:prstGeom>
+          <a:noFill/>
+          <a:ln w="5080">
+            <a:solidFill>
+              <a:srgbClr val="DDDDDD"/>
+            </a:solidFill>
+            <a:prstDash val="solid"/>
+          </a:ln>
+        </p:spPr>
+      </p:sp>
+      <p:sp>
+        <p:nvSpPr>
+          <p:cNvPr id="56" name="Text 54"/>
+          <p:cNvSpPr/>
+          <p:nvPr/>
+        </p:nvSpPr>
+        <p:spPr>
+          <a:xfrm>
+            <a:off x="8308848" y="3621024"/>
+            <a:ext cx="3331464" cy="594360"/>
+          </a:xfrm>
+          <a:prstGeom prst="rect">
+            <a:avLst/>
+          </a:prstGeom>
+          <a:noFill/>
+          <a:ln/>
+        </p:spPr>
+        <p:txBody>
+          <a:bodyPr wrap="square" rtlCol="0" anchor="t"/>
+          <a:lstStyle/>
+          <a:p>
+            <a:pPr indent="0" marL="0">
+              <a:buNone/>
+            </a:pPr>
+            <a:r>
+              <a:rPr lang="en-US" sz="1200" b="1" dirty="0">
+                <a:solidFill>
+                  <a:srgbClr val="111111"/>
+                </a:solidFill>
+                <a:latin typeface="Calibri" pitchFamily="34" charset="0"/>
+                <a:ea typeface="Calibri" pitchFamily="34" charset="-122"/>
+                <a:cs typeface="Calibri" pitchFamily="34" charset="-120"/>
+              </a:rPr>
               <a:t>How we consolidate —</a:t>
             </a:r>
-            <a:endParaRPr lang="en-US" sz="1300" dirty="0"/>
-          </a:p>
-          <a:p>
-            <a:pPr indent="0" marL="0">
-              <a:buNone/>
-            </a:pPr>
-            <a:r>
-              <a:rPr lang="en-US" sz="1300" b="1" dirty="0">
+            <a:endParaRPr lang="en-US" sz="1200" dirty="0"/>
+          </a:p>
+          <a:p>
+            <a:pPr indent="0" marL="0">
+              <a:buNone/>
+            </a:pPr>
+            <a:r>
+              <a:rPr lang="en-US" sz="1200" b="1" dirty="0">
                 <a:solidFill>
                   <a:srgbClr val="111111"/>
                 </a:solidFill>
-                <a:latin typeface="Calibri Light" pitchFamily="34" charset="0"/>
-                <a:ea typeface="Calibri Light" pitchFamily="34" charset="-122"/>
-                <a:cs typeface="Calibri Light" pitchFamily="34" charset="-120"/>
+                <a:latin typeface="Calibri" pitchFamily="34" charset="0"/>
+                <a:ea typeface="Calibri" pitchFamily="34" charset="-122"/>
+                <a:cs typeface="Calibri" pitchFamily="34" charset="-120"/>
               </a:rPr>
               <a:t>and what it delivers</a:t>
             </a:r>
-            <a:endParaRPr lang="en-US" sz="1300" dirty="0"/>
-          </a:p>
-        </p:txBody>
-      </p:sp>
-      <p:sp>
-        <p:nvSpPr>
-          <p:cNvPr id="36" name="Text 34"/>
-          <p:cNvSpPr/>
-          <p:nvPr/>
-        </p:nvSpPr>
-        <p:spPr>
-          <a:xfrm>
-            <a:off x="8308848" y="3621024"/>
-            <a:ext cx="3331464" cy="1508760"/>
+            <a:endParaRPr lang="en-US" sz="1200" dirty="0"/>
+          </a:p>
+        </p:txBody>
+      </p:sp>
+      <p:sp>
+        <p:nvSpPr>
+          <p:cNvPr id="57" name="Text 55"/>
+          <p:cNvSpPr/>
+          <p:nvPr/>
+        </p:nvSpPr>
+        <p:spPr>
+          <a:xfrm>
+            <a:off x="8308848" y="4261104"/>
+            <a:ext cx="3331464" cy="566928"/>
           </a:xfrm>
           <a:prstGeom prst="rect">
             <a:avLst/>
@@ -3357,7 +4044,7 @@
               <a:buNone/>
             </a:pPr>
             <a:r>
-              <a:rPr lang="en-US" sz="1050" dirty="0">
+              <a:rPr lang="en-US" sz="900" dirty="0">
                 <a:solidFill>
                   <a:srgbClr val="555555"/>
                 </a:solidFill>
@@ -3365,26 +4052,218 @@
                 <a:ea typeface="Calibri" pitchFamily="34" charset="-122"/>
                 <a:cs typeface="Calibri" pitchFamily="34" charset="-120"/>
               </a:rPr>
-              <a:t>A phased ERP consolidation already delivering results. Phase 1 beat forecast by $5.7M. Three phases remain.</a:t>
-            </a:r>
-            <a:endParaRPr lang="en-US" sz="1050" dirty="0"/>
-          </a:p>
-        </p:txBody>
-      </p:sp>
-      <p:sp>
-        <p:nvSpPr>
-          <p:cNvPr id="37" name="Shape 35"/>
-          <p:cNvSpPr/>
-          <p:nvPr/>
-        </p:nvSpPr>
-        <p:spPr>
-          <a:xfrm>
-            <a:off x="8308848" y="5193792"/>
-            <a:ext cx="3331464" cy="256032"/>
+              <a:t>A 4-phase ERP consolidation moves every program into D365 F&amp;O. Phase 1 is done and already proving the model.</a:t>
+            </a:r>
+            <a:endParaRPr lang="en-US" sz="900" dirty="0"/>
+          </a:p>
+        </p:txBody>
+      </p:sp>
+      <p:sp>
+        <p:nvSpPr>
+          <p:cNvPr id="58" name="Shape 56"/>
+          <p:cNvSpPr/>
+          <p:nvPr/>
+        </p:nvSpPr>
+        <p:spPr>
+          <a:xfrm>
+            <a:off x="8308848" y="4983480"/>
+            <a:ext cx="73152" cy="73152"/>
+          </a:xfrm>
+          <a:prstGeom prst="ellipse">
+            <a:avLst/>
+          </a:prstGeom>
+          <a:solidFill>
+            <a:srgbClr val="5B2C8D"/>
+          </a:solidFill>
+          <a:ln w="12700">
+            <a:solidFill>
+              <a:srgbClr val="5B2C8D"/>
+            </a:solidFill>
+            <a:prstDash val="solid"/>
+          </a:ln>
+        </p:spPr>
+      </p:sp>
+      <p:sp>
+        <p:nvSpPr>
+          <p:cNvPr id="59" name="Text 57"/>
+          <p:cNvSpPr/>
+          <p:nvPr/>
+        </p:nvSpPr>
+        <p:spPr>
+          <a:xfrm>
+            <a:off x="8455152" y="4901184"/>
+            <a:ext cx="3185160" cy="329184"/>
+          </a:xfrm>
+          <a:prstGeom prst="rect">
+            <a:avLst/>
+          </a:prstGeom>
+          <a:noFill/>
+          <a:ln/>
+        </p:spPr>
+        <p:txBody>
+          <a:bodyPr wrap="square" rtlCol="0" anchor="ctr"/>
+          <a:lstStyle/>
+          <a:p>
+            <a:pPr indent="0" marL="0">
+              <a:buNone/>
+            </a:pPr>
+            <a:r>
+              <a:rPr lang="en-US" sz="900" dirty="0">
+                <a:solidFill>
+                  <a:srgbClr val="333333"/>
+                </a:solidFill>
+                <a:latin typeface="Calibri" pitchFamily="34" charset="0"/>
+                <a:ea typeface="Calibri" pitchFamily="34" charset="-122"/>
+                <a:cs typeface="Calibri" pitchFamily="34" charset="-120"/>
+              </a:rPr>
+              <a:t>Phase 1 (2024–25): DES / NDES / ISP — complete</a:t>
+            </a:r>
+            <a:endParaRPr lang="en-US" sz="900" dirty="0"/>
+          </a:p>
+        </p:txBody>
+      </p:sp>
+      <p:sp>
+        <p:nvSpPr>
+          <p:cNvPr id="60" name="Shape 58"/>
+          <p:cNvSpPr/>
+          <p:nvPr/>
+        </p:nvSpPr>
+        <p:spPr>
+          <a:xfrm>
+            <a:off x="8308848" y="5349240"/>
+            <a:ext cx="73152" cy="73152"/>
+          </a:xfrm>
+          <a:prstGeom prst="ellipse">
+            <a:avLst/>
+          </a:prstGeom>
+          <a:solidFill>
+            <a:srgbClr val="5B2C8D"/>
+          </a:solidFill>
+          <a:ln w="12700">
+            <a:solidFill>
+              <a:srgbClr val="5B2C8D"/>
+            </a:solidFill>
+            <a:prstDash val="solid"/>
+          </a:ln>
+        </p:spPr>
+      </p:sp>
+      <p:sp>
+        <p:nvSpPr>
+          <p:cNvPr id="61" name="Text 59"/>
+          <p:cNvSpPr/>
+          <p:nvPr/>
+        </p:nvSpPr>
+        <p:spPr>
+          <a:xfrm>
+            <a:off x="8455152" y="5266944"/>
+            <a:ext cx="3185160" cy="329184"/>
+          </a:xfrm>
+          <a:prstGeom prst="rect">
+            <a:avLst/>
+          </a:prstGeom>
+          <a:noFill/>
+          <a:ln/>
+        </p:spPr>
+        <p:txBody>
+          <a:bodyPr wrap="square" rtlCol="0" anchor="ctr"/>
+          <a:lstStyle/>
+          <a:p>
+            <a:pPr indent="0" marL="0">
+              <a:buNone/>
+            </a:pPr>
+            <a:r>
+              <a:rPr lang="en-US" sz="900" dirty="0">
+                <a:solidFill>
+                  <a:srgbClr val="333333"/>
+                </a:solidFill>
+                <a:latin typeface="Calibri" pitchFamily="34" charset="0"/>
+                <a:ea typeface="Calibri" pitchFamily="34" charset="-122"/>
+                <a:cs typeface="Calibri" pitchFamily="34" charset="-120"/>
+              </a:rPr>
+              <a:t>Phases 2–3 (2026): UBIF Portal + SUR — in progress</a:t>
+            </a:r>
+            <a:endParaRPr lang="en-US" sz="900" dirty="0"/>
+          </a:p>
+        </p:txBody>
+      </p:sp>
+      <p:sp>
+        <p:nvSpPr>
+          <p:cNvPr id="62" name="Shape 60"/>
+          <p:cNvSpPr/>
+          <p:nvPr/>
+        </p:nvSpPr>
+        <p:spPr>
+          <a:xfrm>
+            <a:off x="8308848" y="5715000"/>
+            <a:ext cx="73152" cy="73152"/>
+          </a:xfrm>
+          <a:prstGeom prst="ellipse">
+            <a:avLst/>
+          </a:prstGeom>
+          <a:solidFill>
+            <a:srgbClr val="5B2C8D"/>
+          </a:solidFill>
+          <a:ln w="12700">
+            <a:solidFill>
+              <a:srgbClr val="5B2C8D"/>
+            </a:solidFill>
+            <a:prstDash val="solid"/>
+          </a:ln>
+        </p:spPr>
+      </p:sp>
+      <p:sp>
+        <p:nvSpPr>
+          <p:cNvPr id="63" name="Text 61"/>
+          <p:cNvSpPr/>
+          <p:nvPr/>
+        </p:nvSpPr>
+        <p:spPr>
+          <a:xfrm>
+            <a:off x="8455152" y="5632704"/>
+            <a:ext cx="3185160" cy="329184"/>
+          </a:xfrm>
+          <a:prstGeom prst="rect">
+            <a:avLst/>
+          </a:prstGeom>
+          <a:noFill/>
+          <a:ln/>
+        </p:spPr>
+        <p:txBody>
+          <a:bodyPr wrap="square" rtlCol="0" anchor="ctr"/>
+          <a:lstStyle/>
+          <a:p>
+            <a:pPr indent="0" marL="0">
+              <a:buNone/>
+            </a:pPr>
+            <a:r>
+              <a:rPr lang="en-US" sz="900" dirty="0">
+                <a:solidFill>
+                  <a:srgbClr val="333333"/>
+                </a:solidFill>
+                <a:latin typeface="Calibri" pitchFamily="34" charset="0"/>
+                <a:ea typeface="Calibri" pitchFamily="34" charset="-122"/>
+                <a:cs typeface="Calibri" pitchFamily="34" charset="-120"/>
+              </a:rPr>
+              <a:t>Phase 4 (2027): Distro → 100% of inventory in one ERP</a:t>
+            </a:r>
+            <a:endParaRPr lang="en-US" sz="900" dirty="0"/>
+          </a:p>
+        </p:txBody>
+      </p:sp>
+      <p:sp>
+        <p:nvSpPr>
+          <p:cNvPr id="64" name="Shape 62"/>
+          <p:cNvSpPr/>
+          <p:nvPr/>
+        </p:nvSpPr>
+        <p:spPr>
+          <a:xfrm>
+            <a:off x="8308848" y="5797296"/>
+            <a:ext cx="3331464" cy="237744"/>
           </a:xfrm>
           <a:prstGeom prst="roundRect">
             <a:avLst>
-              <a:gd name="adj" fmla="val 14286"/>
+              <a:gd name="adj" fmla="val 15385"/>
             </a:avLst>
           </a:prstGeom>
           <a:solidFill>
@@ -3400,14 +4279,14 @@
       </p:sp>
       <p:sp>
         <p:nvSpPr>
-          <p:cNvPr id="38" name="Text 36"/>
-          <p:cNvSpPr/>
-          <p:nvPr/>
-        </p:nvSpPr>
-        <p:spPr>
-          <a:xfrm>
-            <a:off x="8308848" y="5193792"/>
-            <a:ext cx="3331464" cy="256032"/>
+          <p:cNvPr id="65" name="Text 63"/>
+          <p:cNvSpPr/>
+          <p:nvPr/>
+        </p:nvSpPr>
+        <p:spPr>
+          <a:xfrm>
+            <a:off x="8308848" y="5797296"/>
+            <a:ext cx="3331464" cy="237744"/>
           </a:xfrm>
           <a:prstGeom prst="rect">
             <a:avLst/>
@@ -3439,13 +4318,13 @@
       </p:sp>
       <p:sp>
         <p:nvSpPr>
-          <p:cNvPr id="39" name="Text 37"/>
-          <p:cNvSpPr/>
-          <p:nvPr/>
-        </p:nvSpPr>
-        <p:spPr>
-          <a:xfrm>
-            <a:off x="4081272" y="3675888"/>
+          <p:cNvPr id="66" name="Text 64"/>
+          <p:cNvSpPr/>
+          <p:nvPr/>
+        </p:nvSpPr>
+        <p:spPr>
+          <a:xfrm>
+            <a:off x="4081272" y="3959352"/>
             <a:ext cx="292608" cy="329184"/>
           </a:xfrm>
           <a:prstGeom prst="rect">
@@ -3478,13 +4357,13 @@
       </p:sp>
       <p:sp>
         <p:nvSpPr>
-          <p:cNvPr id="40" name="Text 38"/>
-          <p:cNvSpPr/>
-          <p:nvPr/>
-        </p:nvSpPr>
-        <p:spPr>
-          <a:xfrm>
-            <a:off x="7961376" y="3675888"/>
+          <p:cNvPr id="67" name="Text 65"/>
+          <p:cNvSpPr/>
+          <p:nvPr/>
+        </p:nvSpPr>
+        <p:spPr>
+          <a:xfrm>
+            <a:off x="7961376" y="3959352"/>
             <a:ext cx="292608" cy="329184"/>
           </a:xfrm>
           <a:prstGeom prst="rect">
@@ -3517,7 +4396,7 @@
       </p:sp>
       <p:sp>
         <p:nvSpPr>
-          <p:cNvPr id="41" name="Shape 39"/>
+          <p:cNvPr id="68" name="Shape 66"/>
           <p:cNvSpPr/>
           <p:nvPr/>
         </p:nvSpPr>
@@ -3540,7 +4419,7 @@
       </p:sp>
       <p:sp>
         <p:nvSpPr>
-          <p:cNvPr id="42" name="Text 40"/>
+          <p:cNvPr id="69" name="Text 67"/>
           <p:cNvSpPr/>
           <p:nvPr/>
         </p:nvSpPr>
@@ -3579,7 +4458,7 @@
       </p:sp>
       <p:sp>
         <p:nvSpPr>
-          <p:cNvPr id="43" name="Text 41"/>
+          <p:cNvPr id="70" name="Text 68"/>
           <p:cNvSpPr/>
           <p:nvPr/>
         </p:nvSpPr>
@@ -3618,7 +4497,7 @@
       </p:sp>
       <p:sp>
         <p:nvSpPr>
-          <p:cNvPr id="44" name="Text 42"/>
+          <p:cNvPr id="71" name="Text 69"/>
           <p:cNvSpPr/>
           <p:nvPr/>
         </p:nvSpPr>

</xml_diff>

<commit_message>
Formalize hero statement tone on agenda slide
https://claude.ai/code/session_01KWybSEC2vfMTAERCxx1Z2W
</commit_message>
<xml_diff>
--- a/public/Inventory-at-Asurion.pptx
+++ b/public/Inventory-at-Asurion.pptx
@@ -2249,7 +2249,7 @@
                 <a:ea typeface="Calibri" pitchFamily="34" charset="-122"/>
                 <a:cs typeface="Calibri" pitchFamily="34" charset="-120"/>
               </a:rPr>
-              <a:t>Inventory is a </a:t>
+              <a:t>Asurion manages approximately </a:t>
             </a:r>
             <a:pPr indent="0" marL="0">
               <a:buNone/>
@@ -2263,7 +2263,7 @@
                 <a:ea typeface="Calibri" pitchFamily="34" charset="-122"/>
                 <a:cs typeface="Calibri" pitchFamily="34" charset="-120"/>
               </a:rPr>
-              <a:t>~$609M asset</a:t>
+              <a:t>~$609M in inventory</a:t>
             </a:r>
             <a:pPr indent="0" marL="0">
               <a:buNone/>
@@ -2277,7 +2277,7 @@
                 <a:ea typeface="Calibri" pitchFamily="34" charset="-122"/>
                 <a:cs typeface="Calibri" pitchFamily="34" charset="-120"/>
               </a:rPr>
-              <a:t> moving across </a:t>
+              <a:t> across </a:t>
             </a:r>
             <a:pPr indent="0" marL="0">
               <a:buNone/>
@@ -2305,7 +2305,7 @@
                 <a:ea typeface="Calibri" pitchFamily="34" charset="-122"/>
                 <a:cs typeface="Calibri" pitchFamily="34" charset="-120"/>
               </a:rPr>
-              <a:t> every day. Today, </a:t>
+              <a:t> spanning every fulfillment program. Of that, </a:t>
             </a:r>
             <a:pPr indent="0" marL="0">
               <a:buNone/>
@@ -2319,7 +2319,7 @@
                 <a:ea typeface="Calibri" pitchFamily="34" charset="-122"/>
                 <a:cs typeface="Calibri" pitchFamily="34" charset="-120"/>
               </a:rPr>
-              <a:t>$207M of it lives outside our ERP</a:t>
+              <a:t>$207M remains on legacy systems outside D365 F&amp;O</a:t>
             </a:r>
             <a:pPr indent="0" marL="0">
               <a:buNone/>
@@ -2333,7 +2333,7 @@
                 <a:ea typeface="Calibri" pitchFamily="34" charset="-122"/>
                 <a:cs typeface="Calibri" pitchFamily="34" charset="-120"/>
               </a:rPr>
-              <a:t> — creating financial blind spots, reconciliation gaps, and operational risk. This session explains what we have, what's broken, and the plan to fix it.</a:t>
+              <a:t> — introducing financial exposure, reconciliation gaps, and limited operational visibility. This review outlines the current state, the systemic risk, and the consolidation path to a single source of truth.</a:t>
             </a:r>
             <a:endParaRPr lang="en-US" sz="1100" dirty="0"/>
           </a:p>

</xml_diff>

<commit_message>
Replace agenda slide boxes with narrative-only content
Removed stats, stat labels, and bullet points from each box.
Each box now has a single prose narrative paragraph that
walks leadership through the story arc without data clutter.

https://claude.ai/code/session_01KWybSEC2vfMTAERCxx1Z2W
</commit_message>
<xml_diff>
--- a/public/Inventory-at-Asurion.pptx
+++ b/public/Inventory-at-Asurion.pptx
@@ -2348,11 +2348,11 @@
         <p:spPr>
           <a:xfrm>
             <a:off x="365760" y="2103120"/>
-            <a:ext cx="3697224" cy="4041648"/>
+            <a:ext cx="3697224" cy="3566160"/>
           </a:xfrm>
           <a:prstGeom prst="roundRect">
             <a:avLst>
-              <a:gd name="adj" fmla="val 1731"/>
+              <a:gd name="adj" fmla="val 1795"/>
             </a:avLst>
           </a:prstGeom>
           <a:solidFill>
@@ -2552,34 +2552,51 @@
         </p:nvSpPr>
         <p:spPr>
           <a:xfrm>
-            <a:off x="548640" y="2834640"/>
-            <a:ext cx="3331464" cy="475488"/>
-          </a:xfrm>
-          <a:prstGeom prst="rect">
-            <a:avLst/>
-          </a:prstGeom>
-          <a:noFill/>
-          <a:ln/>
-        </p:spPr>
-        <p:txBody>
-          <a:bodyPr wrap="square" rtlCol="0" anchor="ctr"/>
-          <a:lstStyle/>
-          <a:p>
-            <a:pPr indent="0" marL="0">
-              <a:buNone/>
-            </a:pPr>
-            <a:r>
-              <a:rPr lang="en-US" sz="2600" b="1" dirty="0">
-                <a:solidFill>
-                  <a:srgbClr val="5B2C8D"/>
+            <a:off x="548640" y="2852928"/>
+            <a:ext cx="3331464" cy="658368"/>
+          </a:xfrm>
+          <a:prstGeom prst="rect">
+            <a:avLst/>
+          </a:prstGeom>
+          <a:noFill/>
+          <a:ln/>
+        </p:spPr>
+        <p:txBody>
+          <a:bodyPr wrap="square" rtlCol="0" anchor="t"/>
+          <a:lstStyle/>
+          <a:p>
+            <a:pPr indent="0" marL="0">
+              <a:buNone/>
+            </a:pPr>
+            <a:r>
+              <a:rPr lang="en-US" sz="1300" b="1" dirty="0">
+                <a:solidFill>
+                  <a:srgbClr val="111111"/>
                 </a:solidFill>
                 <a:latin typeface="Calibri Light" pitchFamily="34" charset="0"/>
                 <a:ea typeface="Calibri Light" pitchFamily="34" charset="-122"/>
                 <a:cs typeface="Calibri Light" pitchFamily="34" charset="-120"/>
               </a:rPr>
-              <a:t>~$609M</a:t>
-            </a:r>
-            <a:endParaRPr lang="en-US" sz="2600" dirty="0"/>
+              <a:t>Inventory powers every</a:t>
+            </a:r>
+            <a:endParaRPr lang="en-US" sz="1300" dirty="0"/>
+          </a:p>
+          <a:p>
+            <a:pPr indent="0" marL="0">
+              <a:buNone/>
+            </a:pPr>
+            <a:r>
+              <a:rPr lang="en-US" sz="1300" b="1" dirty="0">
+                <a:solidFill>
+                  <a:srgbClr val="111111"/>
+                </a:solidFill>
+                <a:latin typeface="Calibri Light" pitchFamily="34" charset="0"/>
+                <a:ea typeface="Calibri Light" pitchFamily="34" charset="-122"/>
+                <a:cs typeface="Calibri Light" pitchFamily="34" charset="-120"/>
+              </a:rPr>
+              <a:t>service motion we run</a:t>
+            </a:r>
+            <a:endParaRPr lang="en-US" sz="1300" dirty="0"/>
           </a:p>
         </p:txBody>
       </p:sp>
@@ -2591,34 +2608,37 @@
         </p:nvSpPr>
         <p:spPr>
           <a:xfrm>
-            <a:off x="548640" y="3291840"/>
-            <a:ext cx="3331464" cy="201168"/>
-          </a:xfrm>
-          <a:prstGeom prst="rect">
-            <a:avLst/>
-          </a:prstGeom>
-          <a:noFill/>
-          <a:ln/>
-        </p:spPr>
-        <p:txBody>
-          <a:bodyPr wrap="square" rtlCol="0" anchor="ctr"/>
-          <a:lstStyle/>
-          <a:p>
-            <a:pPr indent="0" marL="0">
-              <a:buNone/>
-            </a:pPr>
-            <a:r>
-              <a:rPr lang="en-US" sz="800" dirty="0">
-                <a:solidFill>
-                  <a:srgbClr val="888888"/>
-                </a:solidFill>
-                <a:latin typeface="Calibri" pitchFamily="34" charset="0"/>
-                <a:ea typeface="Calibri" pitchFamily="34" charset="-122"/>
-                <a:cs typeface="Calibri" pitchFamily="34" charset="-120"/>
-              </a:rPr>
-              <a:t>total inventory value</a:t>
-            </a:r>
-            <a:endParaRPr lang="en-US" sz="800" dirty="0"/>
+            <a:off x="548640" y="3602736"/>
+            <a:ext cx="3331464" cy="2194560"/>
+          </a:xfrm>
+          <a:prstGeom prst="rect">
+            <a:avLst/>
+          </a:prstGeom>
+          <a:noFill/>
+          <a:ln/>
+        </p:spPr>
+        <p:txBody>
+          <a:bodyPr wrap="square" rtlCol="0" anchor="t"/>
+          <a:lstStyle/>
+          <a:p>
+            <a:pPr indent="0" marL="0">
+              <a:spcBef>
+                <a:spcPts val="200"/>
+              </a:spcBef>
+              <a:buNone/>
+            </a:pPr>
+            <a:r>
+              <a:rPr lang="en-US" sz="1000" dirty="0">
+                <a:solidFill>
+                  <a:srgbClr val="555555"/>
+                </a:solidFill>
+                <a:latin typeface="Calibri" pitchFamily="34" charset="0"/>
+                <a:ea typeface="Calibri" pitchFamily="34" charset="-122"/>
+                <a:cs typeface="Calibri" pitchFamily="34" charset="-120"/>
+              </a:rPr>
+              <a:t>From advance exchange to same-unit repair to reverse logistics, inventory is present at every step. Understanding its scale — where it lives, how it moves, and what programs it supports — is the foundation for everything else in this review.</a:t>
+            </a:r>
+            <a:endParaRPr lang="en-US" sz="1000" dirty="0"/>
           </a:p>
         </p:txBody>
       </p:sp>
@@ -2630,14 +2650,18 @@
         </p:nvSpPr>
         <p:spPr>
           <a:xfrm>
-            <a:off x="548640" y="3547872"/>
-            <a:ext cx="3331464" cy="0"/>
-          </a:xfrm>
-          <a:prstGeom prst="line">
-            <a:avLst/>
-          </a:prstGeom>
-          <a:noFill/>
-          <a:ln w="5080">
+            <a:off x="548640" y="5321808"/>
+            <a:ext cx="3331464" cy="237744"/>
+          </a:xfrm>
+          <a:prstGeom prst="roundRect">
+            <a:avLst>
+              <a:gd name="adj" fmla="val 15385"/>
+            </a:avLst>
+          </a:prstGeom>
+          <a:solidFill>
+            <a:srgbClr val="F5F4F8"/>
+          </a:solidFill>
+          <a:ln w="6350">
             <a:solidFill>
               <a:srgbClr val="DDDDDD"/>
             </a:solidFill>
@@ -2653,92 +2677,63 @@
         </p:nvSpPr>
         <p:spPr>
           <a:xfrm>
-            <a:off x="548640" y="3621024"/>
-            <a:ext cx="3331464" cy="594360"/>
-          </a:xfrm>
-          <a:prstGeom prst="rect">
-            <a:avLst/>
-          </a:prstGeom>
-          <a:noFill/>
-          <a:ln/>
-        </p:spPr>
-        <p:txBody>
-          <a:bodyPr wrap="square" rtlCol="0" anchor="t"/>
-          <a:lstStyle/>
-          <a:p>
-            <a:pPr indent="0" marL="0">
-              <a:buNone/>
-            </a:pPr>
-            <a:r>
-              <a:rPr lang="en-US" sz="1200" b="1" dirty="0">
-                <a:solidFill>
-                  <a:srgbClr val="111111"/>
-                </a:solidFill>
-                <a:latin typeface="Calibri" pitchFamily="34" charset="0"/>
-                <a:ea typeface="Calibri" pitchFamily="34" charset="-122"/>
-                <a:cs typeface="Calibri" pitchFamily="34" charset="-120"/>
-              </a:rPr>
-              <a:t>What inventory is</a:t>
-            </a:r>
-            <a:endParaRPr lang="en-US" sz="1200" dirty="0"/>
-          </a:p>
-          <a:p>
-            <a:pPr indent="0" marL="0">
-              <a:buNone/>
-            </a:pPr>
-            <a:r>
-              <a:rPr lang="en-US" sz="1200" b="1" dirty="0">
-                <a:solidFill>
-                  <a:srgbClr val="111111"/>
-                </a:solidFill>
-                <a:latin typeface="Calibri" pitchFamily="34" charset="0"/>
-                <a:ea typeface="Calibri" pitchFamily="34" charset="-122"/>
-                <a:cs typeface="Calibri" pitchFamily="34" charset="-120"/>
-              </a:rPr>
-              <a:t>and where it lives</a:t>
-            </a:r>
-            <a:endParaRPr lang="en-US" sz="1200" dirty="0"/>
-          </a:p>
-        </p:txBody>
-      </p:sp>
-      <p:sp>
-        <p:nvSpPr>
-          <p:cNvPr id="17" name="Text 15"/>
-          <p:cNvSpPr/>
-          <p:nvPr/>
-        </p:nvSpPr>
-        <p:spPr>
-          <a:xfrm>
-            <a:off x="548640" y="4261104"/>
-            <a:ext cx="3331464" cy="566928"/>
-          </a:xfrm>
-          <a:prstGeom prst="rect">
-            <a:avLst/>
-          </a:prstGeom>
-          <a:noFill/>
-          <a:ln/>
-        </p:spPr>
-        <p:txBody>
-          <a:bodyPr wrap="square" rtlCol="0" anchor="t"/>
-          <a:lstStyle/>
-          <a:p>
-            <a:pPr indent="0" marL="0">
-              <a:buNone/>
-            </a:pPr>
-            <a:r>
-              <a:rPr lang="en-US" sz="900" dirty="0">
-                <a:solidFill>
-                  <a:srgbClr val="555555"/>
-                </a:solidFill>
-                <a:latin typeface="Calibri" pitchFamily="34" charset="0"/>
-                <a:ea typeface="Calibri" pitchFamily="34" charset="-122"/>
-                <a:cs typeface="Calibri" pitchFamily="34" charset="-120"/>
-              </a:rPr>
-              <a:t>Inventory is Asurion's operational backbone — every service motion depends on it being in the right place at the right time.</a:t>
-            </a:r>
-            <a:endParaRPr lang="en-US" sz="900" dirty="0"/>
-          </a:p>
-        </p:txBody>
+            <a:off x="548640" y="5321808"/>
+            <a:ext cx="3331464" cy="237744"/>
+          </a:xfrm>
+          <a:prstGeom prst="rect">
+            <a:avLst/>
+          </a:prstGeom>
+          <a:noFill/>
+          <a:ln/>
+        </p:spPr>
+        <p:txBody>
+          <a:bodyPr wrap="square" rtlCol="0" anchor="ctr"/>
+          <a:lstStyle/>
+          <a:p>
+            <a:pPr algn="ctr" indent="0" marL="0">
+              <a:buNone/>
+            </a:pPr>
+            <a:r>
+              <a:rPr lang="en-US" sz="800" dirty="0">
+                <a:solidFill>
+                  <a:srgbClr val="888888"/>
+                </a:solidFill>
+                <a:latin typeface="Calibri" pitchFamily="34" charset="0"/>
+                <a:ea typeface="Calibri" pitchFamily="34" charset="-122"/>
+                <a:cs typeface="Calibri" pitchFamily="34" charset="-120"/>
+              </a:rPr>
+              <a:t>Slides 03 – 04</a:t>
+            </a:r>
+            <a:endParaRPr lang="en-US" sz="800" dirty="0"/>
+          </a:p>
+        </p:txBody>
+      </p:sp>
+      <p:sp>
+        <p:nvSpPr>
+          <p:cNvPr id="17" name="Shape 15"/>
+          <p:cNvSpPr/>
+          <p:nvPr/>
+        </p:nvSpPr>
+        <p:spPr>
+          <a:xfrm>
+            <a:off x="4245864" y="2103120"/>
+            <a:ext cx="3697224" cy="3566160"/>
+          </a:xfrm>
+          <a:prstGeom prst="roundRect">
+            <a:avLst>
+              <a:gd name="adj" fmla="val 1795"/>
+            </a:avLst>
+          </a:prstGeom>
+          <a:solidFill>
+            <a:srgbClr val="FFFFFF"/>
+          </a:solidFill>
+          <a:ln w="9525">
+            <a:solidFill>
+              <a:srgbClr val="DDDDDD"/>
+            </a:solidFill>
+            <a:prstDash val="solid"/>
+          </a:ln>
+        </p:spPr>
       </p:sp>
       <p:sp>
         <p:nvSpPr>
@@ -2748,8 +2743,60 @@
         </p:nvSpPr>
         <p:spPr>
           <a:xfrm>
-            <a:off x="548640" y="4983480"/>
-            <a:ext cx="73152" cy="73152"/>
+            <a:off x="4245864" y="2103120"/>
+            <a:ext cx="3697224" cy="658368"/>
+          </a:xfrm>
+          <a:prstGeom prst="roundRect">
+            <a:avLst>
+              <a:gd name="adj" fmla="val 9722"/>
+            </a:avLst>
+          </a:prstGeom>
+          <a:solidFill>
+            <a:srgbClr val="F5EEF8"/>
+          </a:solidFill>
+          <a:ln w="12700">
+            <a:solidFill>
+              <a:srgbClr val="F5EEF8"/>
+            </a:solidFill>
+            <a:prstDash val="solid"/>
+          </a:ln>
+        </p:spPr>
+      </p:sp>
+      <p:sp>
+        <p:nvSpPr>
+          <p:cNvPr id="19" name="Shape 17"/>
+          <p:cNvSpPr/>
+          <p:nvPr/>
+        </p:nvSpPr>
+        <p:spPr>
+          <a:xfrm>
+            <a:off x="4245864" y="2578608"/>
+            <a:ext cx="3697224" cy="182880"/>
+          </a:xfrm>
+          <a:prstGeom prst="rect">
+            <a:avLst/>
+          </a:prstGeom>
+          <a:solidFill>
+            <a:srgbClr val="F5EEF8"/>
+          </a:solidFill>
+          <a:ln w="12700">
+            <a:solidFill>
+              <a:srgbClr val="F5EEF8"/>
+            </a:solidFill>
+            <a:prstDash val="solid"/>
+          </a:ln>
+        </p:spPr>
+      </p:sp>
+      <p:sp>
+        <p:nvSpPr>
+          <p:cNvPr id="20" name="Shape 18"/>
+          <p:cNvSpPr/>
+          <p:nvPr/>
+        </p:nvSpPr>
+        <p:spPr>
+          <a:xfrm>
+            <a:off x="4428744" y="2194560"/>
+            <a:ext cx="384048" cy="384048"/>
           </a:xfrm>
           <a:prstGeom prst="ellipse">
             <a:avLst/>
@@ -2767,53 +2814,358 @@
       </p:sp>
       <p:sp>
         <p:nvSpPr>
-          <p:cNvPr id="19" name="Text 17"/>
-          <p:cNvSpPr/>
-          <p:nvPr/>
-        </p:nvSpPr>
-        <p:spPr>
-          <a:xfrm>
-            <a:off x="694944" y="4901184"/>
-            <a:ext cx="3185160" cy="329184"/>
-          </a:xfrm>
-          <a:prstGeom prst="rect">
-            <a:avLst/>
-          </a:prstGeom>
-          <a:noFill/>
-          <a:ln/>
-        </p:spPr>
-        <p:txBody>
-          <a:bodyPr wrap="square" rtlCol="0" anchor="ctr"/>
-          <a:lstStyle/>
-          <a:p>
-            <a:pPr indent="0" marL="0">
-              <a:buNone/>
-            </a:pPr>
-            <a:r>
-              <a:rPr lang="en-US" sz="900" dirty="0">
-                <a:solidFill>
-                  <a:srgbClr val="333333"/>
-                </a:solidFill>
-                <a:latin typeface="Calibri" pitchFamily="34" charset="0"/>
-                <a:ea typeface="Calibri" pitchFamily="34" charset="-122"/>
-                <a:cs typeface="Calibri" pitchFamily="34" charset="-120"/>
-              </a:rPr>
-              <a:t>$401.8M in Replacement (AE, DES, NDES, ISP)</a:t>
-            </a:r>
-            <a:endParaRPr lang="en-US" sz="900" dirty="0"/>
-          </a:p>
-        </p:txBody>
-      </p:sp>
-      <p:sp>
-        <p:nvSpPr>
-          <p:cNvPr id="20" name="Shape 18"/>
-          <p:cNvSpPr/>
-          <p:nvPr/>
-        </p:nvSpPr>
-        <p:spPr>
-          <a:xfrm>
-            <a:off x="548640" y="5349240"/>
-            <a:ext cx="73152" cy="73152"/>
+          <p:cNvPr id="21" name="Text 19"/>
+          <p:cNvSpPr/>
+          <p:nvPr/>
+        </p:nvSpPr>
+        <p:spPr>
+          <a:xfrm>
+            <a:off x="4428744" y="2194560"/>
+            <a:ext cx="384048" cy="384048"/>
+          </a:xfrm>
+          <a:prstGeom prst="rect">
+            <a:avLst/>
+          </a:prstGeom>
+          <a:noFill/>
+          <a:ln/>
+        </p:spPr>
+        <p:txBody>
+          <a:bodyPr wrap="square" rtlCol="0" anchor="ctr"/>
+          <a:lstStyle/>
+          <a:p>
+            <a:pPr algn="ctr" indent="0" marL="0">
+              <a:buNone/>
+            </a:pPr>
+            <a:r>
+              <a:rPr lang="en-US" sz="1100" b="1" dirty="0">
+                <a:solidFill>
+                  <a:srgbClr val="FFFFFF"/>
+                </a:solidFill>
+                <a:latin typeface="Calibri" pitchFamily="34" charset="0"/>
+                <a:ea typeface="Calibri" pitchFamily="34" charset="-122"/>
+                <a:cs typeface="Calibri" pitchFamily="34" charset="-120"/>
+              </a:rPr>
+              <a:t>02</a:t>
+            </a:r>
+            <a:endParaRPr lang="en-US" sz="1100" dirty="0"/>
+          </a:p>
+        </p:txBody>
+      </p:sp>
+      <p:sp>
+        <p:nvSpPr>
+          <p:cNvPr id="22" name="Text 20"/>
+          <p:cNvSpPr/>
+          <p:nvPr/>
+        </p:nvSpPr>
+        <p:spPr>
+          <a:xfrm>
+            <a:off x="4940808" y="2267712"/>
+            <a:ext cx="2874264" cy="237744"/>
+          </a:xfrm>
+          <a:prstGeom prst="rect">
+            <a:avLst/>
+          </a:prstGeom>
+          <a:noFill/>
+          <a:ln/>
+        </p:spPr>
+        <p:txBody>
+          <a:bodyPr wrap="square" rtlCol="0" anchor="ctr"/>
+          <a:lstStyle/>
+          <a:p>
+            <a:pPr indent="0" marL="0">
+              <a:buNone/>
+            </a:pPr>
+            <a:r>
+              <a:rPr lang="en-US" sz="800" b="1" spc="150" kern="0" dirty="0">
+                <a:solidFill>
+                  <a:srgbClr val="5B2C8D"/>
+                </a:solidFill>
+                <a:latin typeface="Calibri" pitchFamily="34" charset="0"/>
+                <a:ea typeface="Calibri" pitchFamily="34" charset="-122"/>
+                <a:cs typeface="Calibri" pitchFamily="34" charset="-120"/>
+              </a:rPr>
+              <a:t>THE PROBLEM</a:t>
+            </a:r>
+            <a:endParaRPr lang="en-US" sz="800" dirty="0"/>
+          </a:p>
+        </p:txBody>
+      </p:sp>
+      <p:sp>
+        <p:nvSpPr>
+          <p:cNvPr id="23" name="Shape 21"/>
+          <p:cNvSpPr/>
+          <p:nvPr/>
+        </p:nvSpPr>
+        <p:spPr>
+          <a:xfrm>
+            <a:off x="4428744" y="2761488"/>
+            <a:ext cx="3331464" cy="0"/>
+          </a:xfrm>
+          <a:prstGeom prst="line">
+            <a:avLst/>
+          </a:prstGeom>
+          <a:noFill/>
+          <a:ln w="6350">
+            <a:solidFill>
+              <a:srgbClr val="DDDDDD"/>
+            </a:solidFill>
+            <a:prstDash val="solid"/>
+          </a:ln>
+        </p:spPr>
+      </p:sp>
+      <p:sp>
+        <p:nvSpPr>
+          <p:cNvPr id="24" name="Text 22"/>
+          <p:cNvSpPr/>
+          <p:nvPr/>
+        </p:nvSpPr>
+        <p:spPr>
+          <a:xfrm>
+            <a:off x="4428744" y="2852928"/>
+            <a:ext cx="3331464" cy="658368"/>
+          </a:xfrm>
+          <a:prstGeom prst="rect">
+            <a:avLst/>
+          </a:prstGeom>
+          <a:noFill/>
+          <a:ln/>
+        </p:spPr>
+        <p:txBody>
+          <a:bodyPr wrap="square" rtlCol="0" anchor="t"/>
+          <a:lstStyle/>
+          <a:p>
+            <a:pPr indent="0" marL="0">
+              <a:buNone/>
+            </a:pPr>
+            <a:r>
+              <a:rPr lang="en-US" sz="1300" b="1" dirty="0">
+                <a:solidFill>
+                  <a:srgbClr val="111111"/>
+                </a:solidFill>
+                <a:latin typeface="Calibri Light" pitchFamily="34" charset="0"/>
+                <a:ea typeface="Calibri Light" pitchFamily="34" charset="-122"/>
+                <a:cs typeface="Calibri Light" pitchFamily="34" charset="-120"/>
+              </a:rPr>
+              <a:t>Fragmented systems create</a:t>
+            </a:r>
+            <a:endParaRPr lang="en-US" sz="1300" dirty="0"/>
+          </a:p>
+          <a:p>
+            <a:pPr indent="0" marL="0">
+              <a:buNone/>
+            </a:pPr>
+            <a:r>
+              <a:rPr lang="en-US" sz="1300" b="1" dirty="0">
+                <a:solidFill>
+                  <a:srgbClr val="111111"/>
+                </a:solidFill>
+                <a:latin typeface="Calibri Light" pitchFamily="34" charset="0"/>
+                <a:ea typeface="Calibri Light" pitchFamily="34" charset="-122"/>
+                <a:cs typeface="Calibri Light" pitchFamily="34" charset="-120"/>
+              </a:rPr>
+              <a:t>financial and operational risk</a:t>
+            </a:r>
+            <a:endParaRPr lang="en-US" sz="1300" dirty="0"/>
+          </a:p>
+        </p:txBody>
+      </p:sp>
+      <p:sp>
+        <p:nvSpPr>
+          <p:cNvPr id="25" name="Text 23"/>
+          <p:cNvSpPr/>
+          <p:nvPr/>
+        </p:nvSpPr>
+        <p:spPr>
+          <a:xfrm>
+            <a:off x="4428744" y="3602736"/>
+            <a:ext cx="3331464" cy="2194560"/>
+          </a:xfrm>
+          <a:prstGeom prst="rect">
+            <a:avLst/>
+          </a:prstGeom>
+          <a:noFill/>
+          <a:ln/>
+        </p:spPr>
+        <p:txBody>
+          <a:bodyPr wrap="square" rtlCol="0" anchor="t"/>
+          <a:lstStyle/>
+          <a:p>
+            <a:pPr indent="0" marL="0">
+              <a:spcBef>
+                <a:spcPts val="200"/>
+              </a:spcBef>
+              <a:buNone/>
+            </a:pPr>
+            <a:r>
+              <a:rPr lang="en-US" sz="1000" dirty="0">
+                <a:solidFill>
+                  <a:srgbClr val="555555"/>
+                </a:solidFill>
+                <a:latin typeface="Calibri" pitchFamily="34" charset="0"/>
+                <a:ea typeface="Calibri" pitchFamily="34" charset="-122"/>
+                <a:cs typeface="Calibri" pitchFamily="34" charset="-120"/>
+              </a:rPr>
+              <a:t>A significant portion of our inventory is managed across legacy platforms that are disconnected from our ERP. This fragmentation makes it difficult to trace units, close financial records accurately, and respond to issues before they compound into larger losses.</a:t>
+            </a:r>
+            <a:endParaRPr lang="en-US" sz="1000" dirty="0"/>
+          </a:p>
+        </p:txBody>
+      </p:sp>
+      <p:sp>
+        <p:nvSpPr>
+          <p:cNvPr id="26" name="Shape 24"/>
+          <p:cNvSpPr/>
+          <p:nvPr/>
+        </p:nvSpPr>
+        <p:spPr>
+          <a:xfrm>
+            <a:off x="4428744" y="5321808"/>
+            <a:ext cx="3331464" cy="237744"/>
+          </a:xfrm>
+          <a:prstGeom prst="roundRect">
+            <a:avLst>
+              <a:gd name="adj" fmla="val 15385"/>
+            </a:avLst>
+          </a:prstGeom>
+          <a:solidFill>
+            <a:srgbClr val="F5F4F8"/>
+          </a:solidFill>
+          <a:ln w="6350">
+            <a:solidFill>
+              <a:srgbClr val="DDDDDD"/>
+            </a:solidFill>
+            <a:prstDash val="solid"/>
+          </a:ln>
+        </p:spPr>
+      </p:sp>
+      <p:sp>
+        <p:nvSpPr>
+          <p:cNvPr id="27" name="Text 25"/>
+          <p:cNvSpPr/>
+          <p:nvPr/>
+        </p:nvSpPr>
+        <p:spPr>
+          <a:xfrm>
+            <a:off x="4428744" y="5321808"/>
+            <a:ext cx="3331464" cy="237744"/>
+          </a:xfrm>
+          <a:prstGeom prst="rect">
+            <a:avLst/>
+          </a:prstGeom>
+          <a:noFill/>
+          <a:ln/>
+        </p:spPr>
+        <p:txBody>
+          <a:bodyPr wrap="square" rtlCol="0" anchor="ctr"/>
+          <a:lstStyle/>
+          <a:p>
+            <a:pPr algn="ctr" indent="0" marL="0">
+              <a:buNone/>
+            </a:pPr>
+            <a:r>
+              <a:rPr lang="en-US" sz="800" dirty="0">
+                <a:solidFill>
+                  <a:srgbClr val="888888"/>
+                </a:solidFill>
+                <a:latin typeface="Calibri" pitchFamily="34" charset="0"/>
+                <a:ea typeface="Calibri" pitchFamily="34" charset="-122"/>
+                <a:cs typeface="Calibri" pitchFamily="34" charset="-120"/>
+              </a:rPr>
+              <a:t>Slide 05</a:t>
+            </a:r>
+            <a:endParaRPr lang="en-US" sz="800" dirty="0"/>
+          </a:p>
+        </p:txBody>
+      </p:sp>
+      <p:sp>
+        <p:nvSpPr>
+          <p:cNvPr id="28" name="Shape 26"/>
+          <p:cNvSpPr/>
+          <p:nvPr/>
+        </p:nvSpPr>
+        <p:spPr>
+          <a:xfrm>
+            <a:off x="8125968" y="2103120"/>
+            <a:ext cx="3697224" cy="3566160"/>
+          </a:xfrm>
+          <a:prstGeom prst="roundRect">
+            <a:avLst>
+              <a:gd name="adj" fmla="val 1795"/>
+            </a:avLst>
+          </a:prstGeom>
+          <a:solidFill>
+            <a:srgbClr val="FFFFFF"/>
+          </a:solidFill>
+          <a:ln w="9525">
+            <a:solidFill>
+              <a:srgbClr val="DDDDDD"/>
+            </a:solidFill>
+            <a:prstDash val="solid"/>
+          </a:ln>
+        </p:spPr>
+      </p:sp>
+      <p:sp>
+        <p:nvSpPr>
+          <p:cNvPr id="29" name="Shape 27"/>
+          <p:cNvSpPr/>
+          <p:nvPr/>
+        </p:nvSpPr>
+        <p:spPr>
+          <a:xfrm>
+            <a:off x="8125968" y="2103120"/>
+            <a:ext cx="3697224" cy="658368"/>
+          </a:xfrm>
+          <a:prstGeom prst="roundRect">
+            <a:avLst>
+              <a:gd name="adj" fmla="val 9722"/>
+            </a:avLst>
+          </a:prstGeom>
+          <a:solidFill>
+            <a:srgbClr val="EDE8F5"/>
+          </a:solidFill>
+          <a:ln w="12700">
+            <a:solidFill>
+              <a:srgbClr val="EDE8F5"/>
+            </a:solidFill>
+            <a:prstDash val="solid"/>
+          </a:ln>
+        </p:spPr>
+      </p:sp>
+      <p:sp>
+        <p:nvSpPr>
+          <p:cNvPr id="30" name="Shape 28"/>
+          <p:cNvSpPr/>
+          <p:nvPr/>
+        </p:nvSpPr>
+        <p:spPr>
+          <a:xfrm>
+            <a:off x="8125968" y="2578608"/>
+            <a:ext cx="3697224" cy="182880"/>
+          </a:xfrm>
+          <a:prstGeom prst="rect">
+            <a:avLst/>
+          </a:prstGeom>
+          <a:solidFill>
+            <a:srgbClr val="EDE8F5"/>
+          </a:solidFill>
+          <a:ln w="12700">
+            <a:solidFill>
+              <a:srgbClr val="EDE8F5"/>
+            </a:solidFill>
+            <a:prstDash val="solid"/>
+          </a:ln>
+        </p:spPr>
+      </p:sp>
+      <p:sp>
+        <p:nvSpPr>
+          <p:cNvPr id="31" name="Shape 29"/>
+          <p:cNvSpPr/>
+          <p:nvPr/>
+        </p:nvSpPr>
+        <p:spPr>
+          <a:xfrm>
+            <a:off x="8308848" y="2194560"/>
+            <a:ext cx="384048" cy="384048"/>
           </a:xfrm>
           <a:prstGeom prst="ellipse">
             <a:avLst/>
@@ -2831,63 +3183,100 @@
       </p:sp>
       <p:sp>
         <p:nvSpPr>
-          <p:cNvPr id="21" name="Text 19"/>
-          <p:cNvSpPr/>
-          <p:nvPr/>
-        </p:nvSpPr>
-        <p:spPr>
-          <a:xfrm>
-            <a:off x="694944" y="5266944"/>
-            <a:ext cx="3185160" cy="329184"/>
-          </a:xfrm>
-          <a:prstGeom prst="rect">
-            <a:avLst/>
-          </a:prstGeom>
-          <a:noFill/>
-          <a:ln/>
-        </p:spPr>
-        <p:txBody>
-          <a:bodyPr wrap="square" rtlCol="0" anchor="ctr"/>
-          <a:lstStyle/>
-          <a:p>
-            <a:pPr indent="0" marL="0">
-              <a:buNone/>
-            </a:pPr>
-            <a:r>
-              <a:rPr lang="en-US" sz="900" dirty="0">
-                <a:solidFill>
-                  <a:srgbClr val="333333"/>
-                </a:solidFill>
-                <a:latin typeface="Calibri" pitchFamily="34" charset="0"/>
-                <a:ea typeface="Calibri" pitchFamily="34" charset="-122"/>
-                <a:cs typeface="Calibri" pitchFamily="34" charset="-120"/>
-              </a:rPr>
-              <a:t>$207M in Repair (uBreakiFix, SUR, UROC)</a:t>
-            </a:r>
-            <a:endParaRPr lang="en-US" sz="900" dirty="0"/>
-          </a:p>
-        </p:txBody>
-      </p:sp>
-      <p:sp>
-        <p:nvSpPr>
-          <p:cNvPr id="22" name="Shape 20"/>
-          <p:cNvSpPr/>
-          <p:nvPr/>
-        </p:nvSpPr>
-        <p:spPr>
-          <a:xfrm>
-            <a:off x="548640" y="5715000"/>
-            <a:ext cx="73152" cy="73152"/>
-          </a:xfrm>
-          <a:prstGeom prst="ellipse">
-            <a:avLst/>
-          </a:prstGeom>
-          <a:solidFill>
-            <a:srgbClr val="5B2C8D"/>
-          </a:solidFill>
-          <a:ln w="12700">
+          <p:cNvPr id="32" name="Text 30"/>
+          <p:cNvSpPr/>
+          <p:nvPr/>
+        </p:nvSpPr>
+        <p:spPr>
+          <a:xfrm>
+            <a:off x="8308848" y="2194560"/>
+            <a:ext cx="384048" cy="384048"/>
+          </a:xfrm>
+          <a:prstGeom prst="rect">
+            <a:avLst/>
+          </a:prstGeom>
+          <a:noFill/>
+          <a:ln/>
+        </p:spPr>
+        <p:txBody>
+          <a:bodyPr wrap="square" rtlCol="0" anchor="ctr"/>
+          <a:lstStyle/>
+          <a:p>
+            <a:pPr algn="ctr" indent="0" marL="0">
+              <a:buNone/>
+            </a:pPr>
+            <a:r>
+              <a:rPr lang="en-US" sz="1100" b="1" dirty="0">
+                <a:solidFill>
+                  <a:srgbClr val="FFFFFF"/>
+                </a:solidFill>
+                <a:latin typeface="Calibri" pitchFamily="34" charset="0"/>
+                <a:ea typeface="Calibri" pitchFamily="34" charset="-122"/>
+                <a:cs typeface="Calibri" pitchFamily="34" charset="-120"/>
+              </a:rPr>
+              <a:t>03</a:t>
+            </a:r>
+            <a:endParaRPr lang="en-US" sz="1100" dirty="0"/>
+          </a:p>
+        </p:txBody>
+      </p:sp>
+      <p:sp>
+        <p:nvSpPr>
+          <p:cNvPr id="33" name="Text 31"/>
+          <p:cNvSpPr/>
+          <p:nvPr/>
+        </p:nvSpPr>
+        <p:spPr>
+          <a:xfrm>
+            <a:off x="8820912" y="2267712"/>
+            <a:ext cx="2874264" cy="237744"/>
+          </a:xfrm>
+          <a:prstGeom prst="rect">
+            <a:avLst/>
+          </a:prstGeom>
+          <a:noFill/>
+          <a:ln/>
+        </p:spPr>
+        <p:txBody>
+          <a:bodyPr wrap="square" rtlCol="0" anchor="ctr"/>
+          <a:lstStyle/>
+          <a:p>
+            <a:pPr indent="0" marL="0">
+              <a:buNone/>
+            </a:pPr>
+            <a:r>
+              <a:rPr lang="en-US" sz="800" b="1" spc="150" kern="0" dirty="0">
+                <a:solidFill>
+                  <a:srgbClr val="5B2C8D"/>
+                </a:solidFill>
+                <a:latin typeface="Calibri" pitchFamily="34" charset="0"/>
+                <a:ea typeface="Calibri" pitchFamily="34" charset="-122"/>
+                <a:cs typeface="Calibri" pitchFamily="34" charset="-120"/>
+              </a:rPr>
+              <a:t>THE PATH FORWARD</a:t>
+            </a:r>
+            <a:endParaRPr lang="en-US" sz="800" dirty="0"/>
+          </a:p>
+        </p:txBody>
+      </p:sp>
+      <p:sp>
+        <p:nvSpPr>
+          <p:cNvPr id="34" name="Shape 32"/>
+          <p:cNvSpPr/>
+          <p:nvPr/>
+        </p:nvSpPr>
+        <p:spPr>
+          <a:xfrm>
+            <a:off x="8308848" y="2761488"/>
+            <a:ext cx="3331464" cy="0"/>
+          </a:xfrm>
+          <a:prstGeom prst="line">
+            <a:avLst/>
+          </a:prstGeom>
+          <a:noFill/>
+          <a:ln w="6350">
             <a:solidFill>
-              <a:srgbClr val="5B2C8D"/>
+              <a:srgbClr val="DDDDDD"/>
             </a:solidFill>
             <a:prstDash val="solid"/>
           </a:ln>
@@ -2895,52 +3284,111 @@
       </p:sp>
       <p:sp>
         <p:nvSpPr>
-          <p:cNvPr id="23" name="Text 21"/>
-          <p:cNvSpPr/>
-          <p:nvPr/>
-        </p:nvSpPr>
-        <p:spPr>
-          <a:xfrm>
-            <a:off x="694944" y="5632704"/>
-            <a:ext cx="3185160" cy="329184"/>
-          </a:xfrm>
-          <a:prstGeom prst="rect">
-            <a:avLst/>
-          </a:prstGeom>
-          <a:noFill/>
-          <a:ln/>
-        </p:spPr>
-        <p:txBody>
-          <a:bodyPr wrap="square" rtlCol="0" anchor="ctr"/>
-          <a:lstStyle/>
-          <a:p>
-            <a:pPr indent="0" marL="0">
-              <a:buNone/>
-            </a:pPr>
-            <a:r>
-              <a:rPr lang="en-US" sz="900" dirty="0">
-                <a:solidFill>
-                  <a:srgbClr val="333333"/>
-                </a:solidFill>
-                <a:latin typeface="Calibri" pitchFamily="34" charset="0"/>
-                <a:ea typeface="Calibri" pitchFamily="34" charset="-122"/>
-                <a:cs typeface="Calibri" pitchFamily="34" charset="-120"/>
-              </a:rPr>
-              <a:t>~890 locations: warehouses, FSLs, stores &amp; vendors</a:t>
-            </a:r>
-            <a:endParaRPr lang="en-US" sz="900" dirty="0"/>
-          </a:p>
-        </p:txBody>
-      </p:sp>
-      <p:sp>
-        <p:nvSpPr>
-          <p:cNvPr id="24" name="Shape 22"/>
-          <p:cNvSpPr/>
-          <p:nvPr/>
-        </p:nvSpPr>
-        <p:spPr>
-          <a:xfrm>
-            <a:off x="548640" y="5797296"/>
+          <p:cNvPr id="35" name="Text 33"/>
+          <p:cNvSpPr/>
+          <p:nvPr/>
+        </p:nvSpPr>
+        <p:spPr>
+          <a:xfrm>
+            <a:off x="8308848" y="2852928"/>
+            <a:ext cx="3331464" cy="658368"/>
+          </a:xfrm>
+          <a:prstGeom prst="rect">
+            <a:avLst/>
+          </a:prstGeom>
+          <a:noFill/>
+          <a:ln/>
+        </p:spPr>
+        <p:txBody>
+          <a:bodyPr wrap="square" rtlCol="0" anchor="t"/>
+          <a:lstStyle/>
+          <a:p>
+            <a:pPr indent="0" marL="0">
+              <a:buNone/>
+            </a:pPr>
+            <a:r>
+              <a:rPr lang="en-US" sz="1300" b="1" dirty="0">
+                <a:solidFill>
+                  <a:srgbClr val="111111"/>
+                </a:solidFill>
+                <a:latin typeface="Calibri Light" pitchFamily="34" charset="0"/>
+                <a:ea typeface="Calibri Light" pitchFamily="34" charset="-122"/>
+                <a:cs typeface="Calibri Light" pitchFamily="34" charset="-120"/>
+              </a:rPr>
+              <a:t>A proven model, scaling</a:t>
+            </a:r>
+            <a:endParaRPr lang="en-US" sz="1300" dirty="0"/>
+          </a:p>
+          <a:p>
+            <a:pPr indent="0" marL="0">
+              <a:buNone/>
+            </a:pPr>
+            <a:r>
+              <a:rPr lang="en-US" sz="1300" b="1" dirty="0">
+                <a:solidFill>
+                  <a:srgbClr val="111111"/>
+                </a:solidFill>
+                <a:latin typeface="Calibri Light" pitchFamily="34" charset="0"/>
+                <a:ea typeface="Calibri Light" pitchFamily="34" charset="-122"/>
+                <a:cs typeface="Calibri Light" pitchFamily="34" charset="-120"/>
+              </a:rPr>
+              <a:t>program by program</a:t>
+            </a:r>
+            <a:endParaRPr lang="en-US" sz="1300" dirty="0"/>
+          </a:p>
+        </p:txBody>
+      </p:sp>
+      <p:sp>
+        <p:nvSpPr>
+          <p:cNvPr id="36" name="Text 34"/>
+          <p:cNvSpPr/>
+          <p:nvPr/>
+        </p:nvSpPr>
+        <p:spPr>
+          <a:xfrm>
+            <a:off x="8308848" y="3602736"/>
+            <a:ext cx="3331464" cy="2194560"/>
+          </a:xfrm>
+          <a:prstGeom prst="rect">
+            <a:avLst/>
+          </a:prstGeom>
+          <a:noFill/>
+          <a:ln/>
+        </p:spPr>
+        <p:txBody>
+          <a:bodyPr wrap="square" rtlCol="0" anchor="t"/>
+          <a:lstStyle/>
+          <a:p>
+            <a:pPr indent="0" marL="0">
+              <a:spcBef>
+                <a:spcPts val="200"/>
+              </a:spcBef>
+              <a:buNone/>
+            </a:pPr>
+            <a:r>
+              <a:rPr lang="en-US" sz="1000" dirty="0">
+                <a:solidFill>
+                  <a:srgbClr val="555555"/>
+                </a:solidFill>
+                <a:latin typeface="Calibri" pitchFamily="34" charset="0"/>
+                <a:ea typeface="Calibri" pitchFamily="34" charset="-122"/>
+                <a:cs typeface="Calibri" pitchFamily="34" charset="-120"/>
+              </a:rPr>
+              <a:t>We have a tested, phased approach to consolidating every inventory program into a single source of truth. The model is already working — and this review outlines what remains, why it matters, and what full consolidation makes possible.</a:t>
+            </a:r>
+            <a:endParaRPr lang="en-US" sz="1000" dirty="0"/>
+          </a:p>
+        </p:txBody>
+      </p:sp>
+      <p:sp>
+        <p:nvSpPr>
+          <p:cNvPr id="37" name="Shape 35"/>
+          <p:cNvSpPr/>
+          <p:nvPr/>
+        </p:nvSpPr>
+        <p:spPr>
+          <a:xfrm>
+            <a:off x="8308848" y="5321808"/>
             <a:ext cx="3331464" cy="237744"/>
           </a:xfrm>
           <a:prstGeom prst="roundRect">
@@ -2961,13 +3409,13 @@
       </p:sp>
       <p:sp>
         <p:nvSpPr>
-          <p:cNvPr id="25" name="Text 23"/>
-          <p:cNvSpPr/>
-          <p:nvPr/>
-        </p:nvSpPr>
-        <p:spPr>
-          <a:xfrm>
-            <a:off x="548640" y="5797296"/>
+          <p:cNvPr id="38" name="Text 36"/>
+          <p:cNvSpPr/>
+          <p:nvPr/>
+        </p:nvSpPr>
+        <p:spPr>
+          <a:xfrm>
+            <a:off x="8308848" y="5321808"/>
             <a:ext cx="3331464" cy="237744"/>
           </a:xfrm>
           <a:prstGeom prst="rect">
@@ -2992,7 +3440,7 @@
                 <a:ea typeface="Calibri" pitchFamily="34" charset="-122"/>
                 <a:cs typeface="Calibri" pitchFamily="34" charset="-120"/>
               </a:rPr>
-              <a:t>Slides 03 – 04</a:t>
+              <a:t>Slides 06 – 07</a:t>
             </a:r>
             <a:endParaRPr lang="en-US" sz="800" dirty="0"/>
           </a:p>
@@ -3000,118 +3448,14 @@
       </p:sp>
       <p:sp>
         <p:nvSpPr>
-          <p:cNvPr id="26" name="Shape 24"/>
-          <p:cNvSpPr/>
-          <p:nvPr/>
-        </p:nvSpPr>
-        <p:spPr>
-          <a:xfrm>
-            <a:off x="4245864" y="2103120"/>
-            <a:ext cx="3697224" cy="4041648"/>
-          </a:xfrm>
-          <a:prstGeom prst="roundRect">
-            <a:avLst>
-              <a:gd name="adj" fmla="val 1731"/>
-            </a:avLst>
-          </a:prstGeom>
-          <a:solidFill>
-            <a:srgbClr val="FFFFFF"/>
-          </a:solidFill>
-          <a:ln w="9525">
-            <a:solidFill>
-              <a:srgbClr val="DDDDDD"/>
-            </a:solidFill>
-            <a:prstDash val="solid"/>
-          </a:ln>
-        </p:spPr>
-      </p:sp>
-      <p:sp>
-        <p:nvSpPr>
-          <p:cNvPr id="27" name="Shape 25"/>
-          <p:cNvSpPr/>
-          <p:nvPr/>
-        </p:nvSpPr>
-        <p:spPr>
-          <a:xfrm>
-            <a:off x="4245864" y="2103120"/>
-            <a:ext cx="3697224" cy="658368"/>
-          </a:xfrm>
-          <a:prstGeom prst="roundRect">
-            <a:avLst>
-              <a:gd name="adj" fmla="val 9722"/>
-            </a:avLst>
-          </a:prstGeom>
-          <a:solidFill>
-            <a:srgbClr val="F5EEF8"/>
-          </a:solidFill>
-          <a:ln w="12700">
-            <a:solidFill>
-              <a:srgbClr val="F5EEF8"/>
-            </a:solidFill>
-            <a:prstDash val="solid"/>
-          </a:ln>
-        </p:spPr>
-      </p:sp>
-      <p:sp>
-        <p:nvSpPr>
-          <p:cNvPr id="28" name="Shape 26"/>
-          <p:cNvSpPr/>
-          <p:nvPr/>
-        </p:nvSpPr>
-        <p:spPr>
-          <a:xfrm>
-            <a:off x="4245864" y="2578608"/>
-            <a:ext cx="3697224" cy="182880"/>
-          </a:xfrm>
-          <a:prstGeom prst="rect">
-            <a:avLst/>
-          </a:prstGeom>
-          <a:solidFill>
-            <a:srgbClr val="F5EEF8"/>
-          </a:solidFill>
-          <a:ln w="12700">
-            <a:solidFill>
-              <a:srgbClr val="F5EEF8"/>
-            </a:solidFill>
-            <a:prstDash val="solid"/>
-          </a:ln>
-        </p:spPr>
-      </p:sp>
-      <p:sp>
-        <p:nvSpPr>
-          <p:cNvPr id="29" name="Shape 27"/>
-          <p:cNvSpPr/>
-          <p:nvPr/>
-        </p:nvSpPr>
-        <p:spPr>
-          <a:xfrm>
-            <a:off x="4428744" y="2194560"/>
-            <a:ext cx="384048" cy="384048"/>
-          </a:xfrm>
-          <a:prstGeom prst="ellipse">
-            <a:avLst/>
-          </a:prstGeom>
-          <a:solidFill>
-            <a:srgbClr val="5B2C8D"/>
-          </a:solidFill>
-          <a:ln w="12700">
-            <a:solidFill>
-              <a:srgbClr val="5B2C8D"/>
-            </a:solidFill>
-            <a:prstDash val="solid"/>
-          </a:ln>
-        </p:spPr>
-      </p:sp>
-      <p:sp>
-        <p:nvSpPr>
-          <p:cNvPr id="30" name="Text 28"/>
-          <p:cNvSpPr/>
-          <p:nvPr/>
-        </p:nvSpPr>
-        <p:spPr>
-          <a:xfrm>
-            <a:off x="4428744" y="2194560"/>
-            <a:ext cx="384048" cy="384048"/>
+          <p:cNvPr id="39" name="Text 37"/>
+          <p:cNvSpPr/>
+          <p:nvPr/>
+        </p:nvSpPr>
+        <p:spPr>
+          <a:xfrm>
+            <a:off x="4081272" y="3721608"/>
+            <a:ext cx="292608" cy="329184"/>
           </a:xfrm>
           <a:prstGeom prst="rect">
             <a:avLst/>
@@ -3127,69 +3471,69 @@
               <a:buNone/>
             </a:pPr>
             <a:r>
-              <a:rPr lang="en-US" sz="1100" b="1" dirty="0">
-                <a:solidFill>
-                  <a:srgbClr val="FFFFFF"/>
-                </a:solidFill>
-                <a:latin typeface="Calibri" pitchFamily="34" charset="0"/>
-                <a:ea typeface="Calibri" pitchFamily="34" charset="-122"/>
-                <a:cs typeface="Calibri" pitchFamily="34" charset="-120"/>
-              </a:rPr>
-              <a:t>02</a:t>
-            </a:r>
-            <a:endParaRPr lang="en-US" sz="1100" dirty="0"/>
-          </a:p>
-        </p:txBody>
-      </p:sp>
-      <p:sp>
-        <p:nvSpPr>
-          <p:cNvPr id="31" name="Text 29"/>
-          <p:cNvSpPr/>
-          <p:nvPr/>
-        </p:nvSpPr>
-        <p:spPr>
-          <a:xfrm>
-            <a:off x="4940808" y="2267712"/>
-            <a:ext cx="2874264" cy="237744"/>
-          </a:xfrm>
-          <a:prstGeom prst="rect">
-            <a:avLst/>
-          </a:prstGeom>
-          <a:noFill/>
-          <a:ln/>
-        </p:spPr>
-        <p:txBody>
-          <a:bodyPr wrap="square" rtlCol="0" anchor="ctr"/>
-          <a:lstStyle/>
-          <a:p>
-            <a:pPr indent="0" marL="0">
-              <a:buNone/>
-            </a:pPr>
-            <a:r>
-              <a:rPr lang="en-US" sz="800" b="1" spc="150" kern="0" dirty="0">
-                <a:solidFill>
-                  <a:srgbClr val="5B2C8D"/>
-                </a:solidFill>
-                <a:latin typeface="Calibri" pitchFamily="34" charset="0"/>
-                <a:ea typeface="Calibri" pitchFamily="34" charset="-122"/>
-                <a:cs typeface="Calibri" pitchFamily="34" charset="-120"/>
-              </a:rPr>
-              <a:t>THE PROBLEM</a:t>
-            </a:r>
-            <a:endParaRPr lang="en-US" sz="800" dirty="0"/>
-          </a:p>
-        </p:txBody>
-      </p:sp>
-      <p:sp>
-        <p:nvSpPr>
-          <p:cNvPr id="32" name="Shape 30"/>
-          <p:cNvSpPr/>
-          <p:nvPr/>
-        </p:nvSpPr>
-        <p:spPr>
-          <a:xfrm>
-            <a:off x="4428744" y="2761488"/>
-            <a:ext cx="3331464" cy="0"/>
+              <a:rPr lang="en-US" sz="1600" b="1" dirty="0">
+                <a:solidFill>
+                  <a:srgbClr val="C4AEED"/>
+                </a:solidFill>
+                <a:latin typeface="Calibri" pitchFamily="34" charset="0"/>
+                <a:ea typeface="Calibri" pitchFamily="34" charset="-122"/>
+                <a:cs typeface="Calibri" pitchFamily="34" charset="-120"/>
+              </a:rPr>
+              <a:t>→</a:t>
+            </a:r>
+            <a:endParaRPr lang="en-US" sz="1600" dirty="0"/>
+          </a:p>
+        </p:txBody>
+      </p:sp>
+      <p:sp>
+        <p:nvSpPr>
+          <p:cNvPr id="40" name="Text 38"/>
+          <p:cNvSpPr/>
+          <p:nvPr/>
+        </p:nvSpPr>
+        <p:spPr>
+          <a:xfrm>
+            <a:off x="7961376" y="3721608"/>
+            <a:ext cx="292608" cy="329184"/>
+          </a:xfrm>
+          <a:prstGeom prst="rect">
+            <a:avLst/>
+          </a:prstGeom>
+          <a:noFill/>
+          <a:ln/>
+        </p:spPr>
+        <p:txBody>
+          <a:bodyPr wrap="square" rtlCol="0" anchor="ctr"/>
+          <a:lstStyle/>
+          <a:p>
+            <a:pPr algn="ctr" indent="0" marL="0">
+              <a:buNone/>
+            </a:pPr>
+            <a:r>
+              <a:rPr lang="en-US" sz="1600" b="1" dirty="0">
+                <a:solidFill>
+                  <a:srgbClr val="C4AEED"/>
+                </a:solidFill>
+                <a:latin typeface="Calibri" pitchFamily="34" charset="0"/>
+                <a:ea typeface="Calibri" pitchFamily="34" charset="-122"/>
+                <a:cs typeface="Calibri" pitchFamily="34" charset="-120"/>
+              </a:rPr>
+              <a:t>→</a:t>
+            </a:r>
+            <a:endParaRPr lang="en-US" sz="1600" dirty="0"/>
+          </a:p>
+        </p:txBody>
+      </p:sp>
+      <p:sp>
+        <p:nvSpPr>
+          <p:cNvPr id="41" name="Shape 39"/>
+          <p:cNvSpPr/>
+          <p:nvPr/>
+        </p:nvSpPr>
+        <p:spPr>
+          <a:xfrm>
+            <a:off x="0" y="6473952"/>
+            <a:ext cx="12188952" cy="0"/>
           </a:xfrm>
           <a:prstGeom prst="line">
             <a:avLst/>
@@ -3205,1221 +3549,7 @@
       </p:sp>
       <p:sp>
         <p:nvSpPr>
-          <p:cNvPr id="33" name="Text 31"/>
-          <p:cNvSpPr/>
-          <p:nvPr/>
-        </p:nvSpPr>
-        <p:spPr>
-          <a:xfrm>
-            <a:off x="4428744" y="2834640"/>
-            <a:ext cx="3331464" cy="475488"/>
-          </a:xfrm>
-          <a:prstGeom prst="rect">
-            <a:avLst/>
-          </a:prstGeom>
-          <a:noFill/>
-          <a:ln/>
-        </p:spPr>
-        <p:txBody>
-          <a:bodyPr wrap="square" rtlCol="0" anchor="ctr"/>
-          <a:lstStyle/>
-          <a:p>
-            <a:pPr indent="0" marL="0">
-              <a:buNone/>
-            </a:pPr>
-            <a:r>
-              <a:rPr lang="en-US" sz="2600" b="1" dirty="0">
-                <a:solidFill>
-                  <a:srgbClr val="5B2C8D"/>
-                </a:solidFill>
-                <a:latin typeface="Calibri Light" pitchFamily="34" charset="0"/>
-                <a:ea typeface="Calibri Light" pitchFamily="34" charset="-122"/>
-                <a:cs typeface="Calibri Light" pitchFamily="34" charset="-120"/>
-              </a:rPr>
-              <a:t>$207M</a:t>
-            </a:r>
-            <a:endParaRPr lang="en-US" sz="2600" dirty="0"/>
-          </a:p>
-        </p:txBody>
-      </p:sp>
-      <p:sp>
-        <p:nvSpPr>
-          <p:cNvPr id="34" name="Text 32"/>
-          <p:cNvSpPr/>
-          <p:nvPr/>
-        </p:nvSpPr>
-        <p:spPr>
-          <a:xfrm>
-            <a:off x="4428744" y="3291840"/>
-            <a:ext cx="3331464" cy="201168"/>
-          </a:xfrm>
-          <a:prstGeom prst="rect">
-            <a:avLst/>
-          </a:prstGeom>
-          <a:noFill/>
-          <a:ln/>
-        </p:spPr>
-        <p:txBody>
-          <a:bodyPr wrap="square" rtlCol="0" anchor="ctr"/>
-          <a:lstStyle/>
-          <a:p>
-            <a:pPr indent="0" marL="0">
-              <a:buNone/>
-            </a:pPr>
-            <a:r>
-              <a:rPr lang="en-US" sz="800" dirty="0">
-                <a:solidFill>
-                  <a:srgbClr val="888888"/>
-                </a:solidFill>
-                <a:latin typeface="Calibri" pitchFamily="34" charset="0"/>
-                <a:ea typeface="Calibri" pitchFamily="34" charset="-122"/>
-                <a:cs typeface="Calibri" pitchFamily="34" charset="-120"/>
-              </a:rPr>
-              <a:t>outside D365 F&amp;O today</a:t>
-            </a:r>
-            <a:endParaRPr lang="en-US" sz="800" dirty="0"/>
-          </a:p>
-        </p:txBody>
-      </p:sp>
-      <p:sp>
-        <p:nvSpPr>
-          <p:cNvPr id="35" name="Shape 33"/>
-          <p:cNvSpPr/>
-          <p:nvPr/>
-        </p:nvSpPr>
-        <p:spPr>
-          <a:xfrm>
-            <a:off x="4428744" y="3547872"/>
-            <a:ext cx="3331464" cy="0"/>
-          </a:xfrm>
-          <a:prstGeom prst="line">
-            <a:avLst/>
-          </a:prstGeom>
-          <a:noFill/>
-          <a:ln w="5080">
-            <a:solidFill>
-              <a:srgbClr val="DDDDDD"/>
-            </a:solidFill>
-            <a:prstDash val="solid"/>
-          </a:ln>
-        </p:spPr>
-      </p:sp>
-      <p:sp>
-        <p:nvSpPr>
-          <p:cNvPr id="36" name="Text 34"/>
-          <p:cNvSpPr/>
-          <p:nvPr/>
-        </p:nvSpPr>
-        <p:spPr>
-          <a:xfrm>
-            <a:off x="4428744" y="3621024"/>
-            <a:ext cx="3331464" cy="594360"/>
-          </a:xfrm>
-          <a:prstGeom prst="rect">
-            <a:avLst/>
-          </a:prstGeom>
-          <a:noFill/>
-          <a:ln/>
-        </p:spPr>
-        <p:txBody>
-          <a:bodyPr wrap="square" rtlCol="0" anchor="t"/>
-          <a:lstStyle/>
-          <a:p>
-            <a:pPr indent="0" marL="0">
-              <a:buNone/>
-            </a:pPr>
-            <a:r>
-              <a:rPr lang="en-US" sz="1200" b="1" dirty="0">
-                <a:solidFill>
-                  <a:srgbClr val="111111"/>
-                </a:solidFill>
-                <a:latin typeface="Calibri" pitchFamily="34" charset="0"/>
-                <a:ea typeface="Calibri" pitchFamily="34" charset="-122"/>
-                <a:cs typeface="Calibri" pitchFamily="34" charset="-120"/>
-              </a:rPr>
-              <a:t>Why fragmented systems</a:t>
-            </a:r>
-            <a:endParaRPr lang="en-US" sz="1200" dirty="0"/>
-          </a:p>
-          <a:p>
-            <a:pPr indent="0" marL="0">
-              <a:buNone/>
-            </a:pPr>
-            <a:r>
-              <a:rPr lang="en-US" sz="1200" b="1" dirty="0">
-                <a:solidFill>
-                  <a:srgbClr val="111111"/>
-                </a:solidFill>
-                <a:latin typeface="Calibri" pitchFamily="34" charset="0"/>
-                <a:ea typeface="Calibri" pitchFamily="34" charset="-122"/>
-                <a:cs typeface="Calibri" pitchFamily="34" charset="-120"/>
-              </a:rPr>
-              <a:t>create financial risk</a:t>
-            </a:r>
-            <a:endParaRPr lang="en-US" sz="1200" dirty="0"/>
-          </a:p>
-        </p:txBody>
-      </p:sp>
-      <p:sp>
-        <p:nvSpPr>
-          <p:cNvPr id="37" name="Text 35"/>
-          <p:cNvSpPr/>
-          <p:nvPr/>
-        </p:nvSpPr>
-        <p:spPr>
-          <a:xfrm>
-            <a:off x="4428744" y="4261104"/>
-            <a:ext cx="3331464" cy="566928"/>
-          </a:xfrm>
-          <a:prstGeom prst="rect">
-            <a:avLst/>
-          </a:prstGeom>
-          <a:noFill/>
-          <a:ln/>
-        </p:spPr>
-        <p:txBody>
-          <a:bodyPr wrap="square" rtlCol="0" anchor="t"/>
-          <a:lstStyle/>
-          <a:p>
-            <a:pPr indent="0" marL="0">
-              <a:buNone/>
-            </a:pPr>
-            <a:r>
-              <a:rPr lang="en-US" sz="900" dirty="0">
-                <a:solidFill>
-                  <a:srgbClr val="555555"/>
-                </a:solidFill>
-                <a:latin typeface="Calibri" pitchFamily="34" charset="0"/>
-                <a:ea typeface="Calibri" pitchFamily="34" charset="-122"/>
-                <a:cs typeface="Calibri" pitchFamily="34" charset="-120"/>
-              </a:rPr>
-              <a:t>When inventory and financials live in separate systems, every unit and dollar becomes harder to trace — and risk grows with volume.</a:t>
-            </a:r>
-            <a:endParaRPr lang="en-US" sz="900" dirty="0"/>
-          </a:p>
-        </p:txBody>
-      </p:sp>
-      <p:sp>
-        <p:nvSpPr>
-          <p:cNvPr id="38" name="Shape 36"/>
-          <p:cNvSpPr/>
-          <p:nvPr/>
-        </p:nvSpPr>
-        <p:spPr>
-          <a:xfrm>
-            <a:off x="4428744" y="4983480"/>
-            <a:ext cx="73152" cy="73152"/>
-          </a:xfrm>
-          <a:prstGeom prst="ellipse">
-            <a:avLst/>
-          </a:prstGeom>
-          <a:solidFill>
-            <a:srgbClr val="5B2C8D"/>
-          </a:solidFill>
-          <a:ln w="12700">
-            <a:solidFill>
-              <a:srgbClr val="5B2C8D"/>
-            </a:solidFill>
-            <a:prstDash val="solid"/>
-          </a:ln>
-        </p:spPr>
-      </p:sp>
-      <p:sp>
-        <p:nvSpPr>
-          <p:cNvPr id="39" name="Text 37"/>
-          <p:cNvSpPr/>
-          <p:nvPr/>
-        </p:nvSpPr>
-        <p:spPr>
-          <a:xfrm>
-            <a:off x="4575048" y="4901184"/>
-            <a:ext cx="3185160" cy="329184"/>
-          </a:xfrm>
-          <a:prstGeom prst="rect">
-            <a:avLst/>
-          </a:prstGeom>
-          <a:noFill/>
-          <a:ln/>
-        </p:spPr>
-        <p:txBody>
-          <a:bodyPr wrap="square" rtlCol="0" anchor="ctr"/>
-          <a:lstStyle/>
-          <a:p>
-            <a:pPr indent="0" marL="0">
-              <a:buNone/>
-            </a:pPr>
-            <a:r>
-              <a:rPr lang="en-US" sz="900" dirty="0">
-                <a:solidFill>
-                  <a:srgbClr val="333333"/>
-                </a:solidFill>
-                <a:latin typeface="Calibri" pitchFamily="34" charset="0"/>
-                <a:ea typeface="Calibri" pitchFamily="34" charset="-122"/>
-                <a:cs typeface="Calibri" pitchFamily="34" charset="-120"/>
-              </a:rPr>
-              <a:t>3 legacy systems: PRISM, Distro, SBX Cycle Count</a:t>
-            </a:r>
-            <a:endParaRPr lang="en-US" sz="900" dirty="0"/>
-          </a:p>
-        </p:txBody>
-      </p:sp>
-      <p:sp>
-        <p:nvSpPr>
-          <p:cNvPr id="40" name="Shape 38"/>
-          <p:cNvSpPr/>
-          <p:nvPr/>
-        </p:nvSpPr>
-        <p:spPr>
-          <a:xfrm>
-            <a:off x="4428744" y="5349240"/>
-            <a:ext cx="73152" cy="73152"/>
-          </a:xfrm>
-          <a:prstGeom prst="ellipse">
-            <a:avLst/>
-          </a:prstGeom>
-          <a:solidFill>
-            <a:srgbClr val="5B2C8D"/>
-          </a:solidFill>
-          <a:ln w="12700">
-            <a:solidFill>
-              <a:srgbClr val="5B2C8D"/>
-            </a:solidFill>
-            <a:prstDash val="solid"/>
-          </a:ln>
-        </p:spPr>
-      </p:sp>
-      <p:sp>
-        <p:nvSpPr>
-          <p:cNvPr id="41" name="Text 39"/>
-          <p:cNvSpPr/>
-          <p:nvPr/>
-        </p:nvSpPr>
-        <p:spPr>
-          <a:xfrm>
-            <a:off x="4575048" y="5266944"/>
-            <a:ext cx="3185160" cy="329184"/>
-          </a:xfrm>
-          <a:prstGeom prst="rect">
-            <a:avLst/>
-          </a:prstGeom>
-          <a:noFill/>
-          <a:ln/>
-        </p:spPr>
-        <p:txBody>
-          <a:bodyPr wrap="square" rtlCol="0" anchor="ctr"/>
-          <a:lstStyle/>
-          <a:p>
-            <a:pPr indent="0" marL="0">
-              <a:buNone/>
-            </a:pPr>
-            <a:r>
-              <a:rPr lang="en-US" sz="900" dirty="0">
-                <a:solidFill>
-                  <a:srgbClr val="333333"/>
-                </a:solidFill>
-                <a:latin typeface="Calibri" pitchFamily="34" charset="0"/>
-                <a:ea typeface="Calibri" pitchFamily="34" charset="-122"/>
-                <a:cs typeface="Calibri" pitchFamily="34" charset="-120"/>
-              </a:rPr>
-              <a:t>Manual reconciliation, billing disputes, delayed visibility</a:t>
-            </a:r>
-            <a:endParaRPr lang="en-US" sz="900" dirty="0"/>
-          </a:p>
-        </p:txBody>
-      </p:sp>
-      <p:sp>
-        <p:nvSpPr>
-          <p:cNvPr id="42" name="Shape 40"/>
-          <p:cNvSpPr/>
-          <p:nvPr/>
-        </p:nvSpPr>
-        <p:spPr>
-          <a:xfrm>
-            <a:off x="4428744" y="5715000"/>
-            <a:ext cx="73152" cy="73152"/>
-          </a:xfrm>
-          <a:prstGeom prst="ellipse">
-            <a:avLst/>
-          </a:prstGeom>
-          <a:solidFill>
-            <a:srgbClr val="5B2C8D"/>
-          </a:solidFill>
-          <a:ln w="12700">
-            <a:solidFill>
-              <a:srgbClr val="5B2C8D"/>
-            </a:solidFill>
-            <a:prstDash val="solid"/>
-          </a:ln>
-        </p:spPr>
-      </p:sp>
-      <p:sp>
-        <p:nvSpPr>
-          <p:cNvPr id="43" name="Text 41"/>
-          <p:cNvSpPr/>
-          <p:nvPr/>
-        </p:nvSpPr>
-        <p:spPr>
-          <a:xfrm>
-            <a:off x="4575048" y="5632704"/>
-            <a:ext cx="3185160" cy="329184"/>
-          </a:xfrm>
-          <a:prstGeom prst="rect">
-            <a:avLst/>
-          </a:prstGeom>
-          <a:noFill/>
-          <a:ln/>
-        </p:spPr>
-        <p:txBody>
-          <a:bodyPr wrap="square" rtlCol="0" anchor="ctr"/>
-          <a:lstStyle/>
-          <a:p>
-            <a:pPr indent="0" marL="0">
-              <a:buNone/>
-            </a:pPr>
-            <a:r>
-              <a:rPr lang="en-US" sz="900" dirty="0">
-                <a:solidFill>
-                  <a:srgbClr val="333333"/>
-                </a:solidFill>
-                <a:latin typeface="Calibri" pitchFamily="34" charset="0"/>
-                <a:ea typeface="Calibri" pitchFamily="34" charset="-122"/>
-                <a:cs typeface="Calibri" pitchFamily="34" charset="-120"/>
-              </a:rPr>
-              <a:t>Financial exposure compounds as programs scale</a:t>
-            </a:r>
-            <a:endParaRPr lang="en-US" sz="900" dirty="0"/>
-          </a:p>
-        </p:txBody>
-      </p:sp>
-      <p:sp>
-        <p:nvSpPr>
-          <p:cNvPr id="44" name="Shape 42"/>
-          <p:cNvSpPr/>
-          <p:nvPr/>
-        </p:nvSpPr>
-        <p:spPr>
-          <a:xfrm>
-            <a:off x="4428744" y="5797296"/>
-            <a:ext cx="3331464" cy="237744"/>
-          </a:xfrm>
-          <a:prstGeom prst="roundRect">
-            <a:avLst>
-              <a:gd name="adj" fmla="val 15385"/>
-            </a:avLst>
-          </a:prstGeom>
-          <a:solidFill>
-            <a:srgbClr val="F5F4F8"/>
-          </a:solidFill>
-          <a:ln w="6350">
-            <a:solidFill>
-              <a:srgbClr val="DDDDDD"/>
-            </a:solidFill>
-            <a:prstDash val="solid"/>
-          </a:ln>
-        </p:spPr>
-      </p:sp>
-      <p:sp>
-        <p:nvSpPr>
-          <p:cNvPr id="45" name="Text 43"/>
-          <p:cNvSpPr/>
-          <p:nvPr/>
-        </p:nvSpPr>
-        <p:spPr>
-          <a:xfrm>
-            <a:off x="4428744" y="5797296"/>
-            <a:ext cx="3331464" cy="237744"/>
-          </a:xfrm>
-          <a:prstGeom prst="rect">
-            <a:avLst/>
-          </a:prstGeom>
-          <a:noFill/>
-          <a:ln/>
-        </p:spPr>
-        <p:txBody>
-          <a:bodyPr wrap="square" rtlCol="0" anchor="ctr"/>
-          <a:lstStyle/>
-          <a:p>
-            <a:pPr algn="ctr" indent="0" marL="0">
-              <a:buNone/>
-            </a:pPr>
-            <a:r>
-              <a:rPr lang="en-US" sz="800" dirty="0">
-                <a:solidFill>
-                  <a:srgbClr val="888888"/>
-                </a:solidFill>
-                <a:latin typeface="Calibri" pitchFamily="34" charset="0"/>
-                <a:ea typeface="Calibri" pitchFamily="34" charset="-122"/>
-                <a:cs typeface="Calibri" pitchFamily="34" charset="-120"/>
-              </a:rPr>
-              <a:t>Slide 05</a:t>
-            </a:r>
-            <a:endParaRPr lang="en-US" sz="800" dirty="0"/>
-          </a:p>
-        </p:txBody>
-      </p:sp>
-      <p:sp>
-        <p:nvSpPr>
-          <p:cNvPr id="46" name="Shape 44"/>
-          <p:cNvSpPr/>
-          <p:nvPr/>
-        </p:nvSpPr>
-        <p:spPr>
-          <a:xfrm>
-            <a:off x="8125968" y="2103120"/>
-            <a:ext cx="3697224" cy="4041648"/>
-          </a:xfrm>
-          <a:prstGeom prst="roundRect">
-            <a:avLst>
-              <a:gd name="adj" fmla="val 1731"/>
-            </a:avLst>
-          </a:prstGeom>
-          <a:solidFill>
-            <a:srgbClr val="FFFFFF"/>
-          </a:solidFill>
-          <a:ln w="9525">
-            <a:solidFill>
-              <a:srgbClr val="DDDDDD"/>
-            </a:solidFill>
-            <a:prstDash val="solid"/>
-          </a:ln>
-        </p:spPr>
-      </p:sp>
-      <p:sp>
-        <p:nvSpPr>
-          <p:cNvPr id="47" name="Shape 45"/>
-          <p:cNvSpPr/>
-          <p:nvPr/>
-        </p:nvSpPr>
-        <p:spPr>
-          <a:xfrm>
-            <a:off x="8125968" y="2103120"/>
-            <a:ext cx="3697224" cy="658368"/>
-          </a:xfrm>
-          <a:prstGeom prst="roundRect">
-            <a:avLst>
-              <a:gd name="adj" fmla="val 9722"/>
-            </a:avLst>
-          </a:prstGeom>
-          <a:solidFill>
-            <a:srgbClr val="EDE8F5"/>
-          </a:solidFill>
-          <a:ln w="12700">
-            <a:solidFill>
-              <a:srgbClr val="EDE8F5"/>
-            </a:solidFill>
-            <a:prstDash val="solid"/>
-          </a:ln>
-        </p:spPr>
-      </p:sp>
-      <p:sp>
-        <p:nvSpPr>
-          <p:cNvPr id="48" name="Shape 46"/>
-          <p:cNvSpPr/>
-          <p:nvPr/>
-        </p:nvSpPr>
-        <p:spPr>
-          <a:xfrm>
-            <a:off x="8125968" y="2578608"/>
-            <a:ext cx="3697224" cy="182880"/>
-          </a:xfrm>
-          <a:prstGeom prst="rect">
-            <a:avLst/>
-          </a:prstGeom>
-          <a:solidFill>
-            <a:srgbClr val="EDE8F5"/>
-          </a:solidFill>
-          <a:ln w="12700">
-            <a:solidFill>
-              <a:srgbClr val="EDE8F5"/>
-            </a:solidFill>
-            <a:prstDash val="solid"/>
-          </a:ln>
-        </p:spPr>
-      </p:sp>
-      <p:sp>
-        <p:nvSpPr>
-          <p:cNvPr id="49" name="Shape 47"/>
-          <p:cNvSpPr/>
-          <p:nvPr/>
-        </p:nvSpPr>
-        <p:spPr>
-          <a:xfrm>
-            <a:off x="8308848" y="2194560"/>
-            <a:ext cx="384048" cy="384048"/>
-          </a:xfrm>
-          <a:prstGeom prst="ellipse">
-            <a:avLst/>
-          </a:prstGeom>
-          <a:solidFill>
-            <a:srgbClr val="5B2C8D"/>
-          </a:solidFill>
-          <a:ln w="12700">
-            <a:solidFill>
-              <a:srgbClr val="5B2C8D"/>
-            </a:solidFill>
-            <a:prstDash val="solid"/>
-          </a:ln>
-        </p:spPr>
-      </p:sp>
-      <p:sp>
-        <p:nvSpPr>
-          <p:cNvPr id="50" name="Text 48"/>
-          <p:cNvSpPr/>
-          <p:nvPr/>
-        </p:nvSpPr>
-        <p:spPr>
-          <a:xfrm>
-            <a:off x="8308848" y="2194560"/>
-            <a:ext cx="384048" cy="384048"/>
-          </a:xfrm>
-          <a:prstGeom prst="rect">
-            <a:avLst/>
-          </a:prstGeom>
-          <a:noFill/>
-          <a:ln/>
-        </p:spPr>
-        <p:txBody>
-          <a:bodyPr wrap="square" rtlCol="0" anchor="ctr"/>
-          <a:lstStyle/>
-          <a:p>
-            <a:pPr algn="ctr" indent="0" marL="0">
-              <a:buNone/>
-            </a:pPr>
-            <a:r>
-              <a:rPr lang="en-US" sz="1100" b="1" dirty="0">
-                <a:solidFill>
-                  <a:srgbClr val="FFFFFF"/>
-                </a:solidFill>
-                <a:latin typeface="Calibri" pitchFamily="34" charset="0"/>
-                <a:ea typeface="Calibri" pitchFamily="34" charset="-122"/>
-                <a:cs typeface="Calibri" pitchFamily="34" charset="-120"/>
-              </a:rPr>
-              <a:t>03</a:t>
-            </a:r>
-            <a:endParaRPr lang="en-US" sz="1100" dirty="0"/>
-          </a:p>
-        </p:txBody>
-      </p:sp>
-      <p:sp>
-        <p:nvSpPr>
-          <p:cNvPr id="51" name="Text 49"/>
-          <p:cNvSpPr/>
-          <p:nvPr/>
-        </p:nvSpPr>
-        <p:spPr>
-          <a:xfrm>
-            <a:off x="8820912" y="2267712"/>
-            <a:ext cx="2874264" cy="237744"/>
-          </a:xfrm>
-          <a:prstGeom prst="rect">
-            <a:avLst/>
-          </a:prstGeom>
-          <a:noFill/>
-          <a:ln/>
-        </p:spPr>
-        <p:txBody>
-          <a:bodyPr wrap="square" rtlCol="0" anchor="ctr"/>
-          <a:lstStyle/>
-          <a:p>
-            <a:pPr indent="0" marL="0">
-              <a:buNone/>
-            </a:pPr>
-            <a:r>
-              <a:rPr lang="en-US" sz="800" b="1" spc="150" kern="0" dirty="0">
-                <a:solidFill>
-                  <a:srgbClr val="5B2C8D"/>
-                </a:solidFill>
-                <a:latin typeface="Calibri" pitchFamily="34" charset="0"/>
-                <a:ea typeface="Calibri" pitchFamily="34" charset="-122"/>
-                <a:cs typeface="Calibri" pitchFamily="34" charset="-120"/>
-              </a:rPr>
-              <a:t>THE PATH FORWARD</a:t>
-            </a:r>
-            <a:endParaRPr lang="en-US" sz="800" dirty="0"/>
-          </a:p>
-        </p:txBody>
-      </p:sp>
-      <p:sp>
-        <p:nvSpPr>
-          <p:cNvPr id="52" name="Shape 50"/>
-          <p:cNvSpPr/>
-          <p:nvPr/>
-        </p:nvSpPr>
-        <p:spPr>
-          <a:xfrm>
-            <a:off x="8308848" y="2761488"/>
-            <a:ext cx="3331464" cy="0"/>
-          </a:xfrm>
-          <a:prstGeom prst="line">
-            <a:avLst/>
-          </a:prstGeom>
-          <a:noFill/>
-          <a:ln w="6350">
-            <a:solidFill>
-              <a:srgbClr val="DDDDDD"/>
-            </a:solidFill>
-            <a:prstDash val="solid"/>
-          </a:ln>
-        </p:spPr>
-      </p:sp>
-      <p:sp>
-        <p:nvSpPr>
-          <p:cNvPr id="53" name="Text 51"/>
-          <p:cNvSpPr/>
-          <p:nvPr/>
-        </p:nvSpPr>
-        <p:spPr>
-          <a:xfrm>
-            <a:off x="8308848" y="2834640"/>
-            <a:ext cx="3331464" cy="475488"/>
-          </a:xfrm>
-          <a:prstGeom prst="rect">
-            <a:avLst/>
-          </a:prstGeom>
-          <a:noFill/>
-          <a:ln/>
-        </p:spPr>
-        <p:txBody>
-          <a:bodyPr wrap="square" rtlCol="0" anchor="ctr"/>
-          <a:lstStyle/>
-          <a:p>
-            <a:pPr indent="0" marL="0">
-              <a:buNone/>
-            </a:pPr>
-            <a:r>
-              <a:rPr lang="en-US" sz="2600" b="1" dirty="0">
-                <a:solidFill>
-                  <a:srgbClr val="5B2C8D"/>
-                </a:solidFill>
-                <a:latin typeface="Calibri Light" pitchFamily="34" charset="0"/>
-                <a:ea typeface="Calibri Light" pitchFamily="34" charset="-122"/>
-                <a:cs typeface="Calibri Light" pitchFamily="34" charset="-120"/>
-              </a:rPr>
-              <a:t>$5.7M</a:t>
-            </a:r>
-            <a:endParaRPr lang="en-US" sz="2600" dirty="0"/>
-          </a:p>
-        </p:txBody>
-      </p:sp>
-      <p:sp>
-        <p:nvSpPr>
-          <p:cNvPr id="54" name="Text 52"/>
-          <p:cNvSpPr/>
-          <p:nvPr/>
-        </p:nvSpPr>
-        <p:spPr>
-          <a:xfrm>
-            <a:off x="8308848" y="3291840"/>
-            <a:ext cx="3331464" cy="201168"/>
-          </a:xfrm>
-          <a:prstGeom prst="rect">
-            <a:avLst/>
-          </a:prstGeom>
-          <a:noFill/>
-          <a:ln/>
-        </p:spPr>
-        <p:txBody>
-          <a:bodyPr wrap="square" rtlCol="0" anchor="ctr"/>
-          <a:lstStyle/>
-          <a:p>
-            <a:pPr indent="0" marL="0">
-              <a:buNone/>
-            </a:pPr>
-            <a:r>
-              <a:rPr lang="en-US" sz="800" dirty="0">
-                <a:solidFill>
-                  <a:srgbClr val="888888"/>
-                </a:solidFill>
-                <a:latin typeface="Calibri" pitchFamily="34" charset="0"/>
-                <a:ea typeface="Calibri" pitchFamily="34" charset="-122"/>
-                <a:cs typeface="Calibri" pitchFamily="34" charset="-120"/>
-              </a:rPr>
-              <a:t>better than forecast — Phase 1</a:t>
-            </a:r>
-            <a:endParaRPr lang="en-US" sz="800" dirty="0"/>
-          </a:p>
-        </p:txBody>
-      </p:sp>
-      <p:sp>
-        <p:nvSpPr>
-          <p:cNvPr id="55" name="Shape 53"/>
-          <p:cNvSpPr/>
-          <p:nvPr/>
-        </p:nvSpPr>
-        <p:spPr>
-          <a:xfrm>
-            <a:off x="8308848" y="3547872"/>
-            <a:ext cx="3331464" cy="0"/>
-          </a:xfrm>
-          <a:prstGeom prst="line">
-            <a:avLst/>
-          </a:prstGeom>
-          <a:noFill/>
-          <a:ln w="5080">
-            <a:solidFill>
-              <a:srgbClr val="DDDDDD"/>
-            </a:solidFill>
-            <a:prstDash val="solid"/>
-          </a:ln>
-        </p:spPr>
-      </p:sp>
-      <p:sp>
-        <p:nvSpPr>
-          <p:cNvPr id="56" name="Text 54"/>
-          <p:cNvSpPr/>
-          <p:nvPr/>
-        </p:nvSpPr>
-        <p:spPr>
-          <a:xfrm>
-            <a:off x="8308848" y="3621024"/>
-            <a:ext cx="3331464" cy="594360"/>
-          </a:xfrm>
-          <a:prstGeom prst="rect">
-            <a:avLst/>
-          </a:prstGeom>
-          <a:noFill/>
-          <a:ln/>
-        </p:spPr>
-        <p:txBody>
-          <a:bodyPr wrap="square" rtlCol="0" anchor="t"/>
-          <a:lstStyle/>
-          <a:p>
-            <a:pPr indent="0" marL="0">
-              <a:buNone/>
-            </a:pPr>
-            <a:r>
-              <a:rPr lang="en-US" sz="1200" b="1" dirty="0">
-                <a:solidFill>
-                  <a:srgbClr val="111111"/>
-                </a:solidFill>
-                <a:latin typeface="Calibri" pitchFamily="34" charset="0"/>
-                <a:ea typeface="Calibri" pitchFamily="34" charset="-122"/>
-                <a:cs typeface="Calibri" pitchFamily="34" charset="-120"/>
-              </a:rPr>
-              <a:t>How we consolidate —</a:t>
-            </a:r>
-            <a:endParaRPr lang="en-US" sz="1200" dirty="0"/>
-          </a:p>
-          <a:p>
-            <a:pPr indent="0" marL="0">
-              <a:buNone/>
-            </a:pPr>
-            <a:r>
-              <a:rPr lang="en-US" sz="1200" b="1" dirty="0">
-                <a:solidFill>
-                  <a:srgbClr val="111111"/>
-                </a:solidFill>
-                <a:latin typeface="Calibri" pitchFamily="34" charset="0"/>
-                <a:ea typeface="Calibri" pitchFamily="34" charset="-122"/>
-                <a:cs typeface="Calibri" pitchFamily="34" charset="-120"/>
-              </a:rPr>
-              <a:t>and what it delivers</a:t>
-            </a:r>
-            <a:endParaRPr lang="en-US" sz="1200" dirty="0"/>
-          </a:p>
-        </p:txBody>
-      </p:sp>
-      <p:sp>
-        <p:nvSpPr>
-          <p:cNvPr id="57" name="Text 55"/>
-          <p:cNvSpPr/>
-          <p:nvPr/>
-        </p:nvSpPr>
-        <p:spPr>
-          <a:xfrm>
-            <a:off x="8308848" y="4261104"/>
-            <a:ext cx="3331464" cy="566928"/>
-          </a:xfrm>
-          <a:prstGeom prst="rect">
-            <a:avLst/>
-          </a:prstGeom>
-          <a:noFill/>
-          <a:ln/>
-        </p:spPr>
-        <p:txBody>
-          <a:bodyPr wrap="square" rtlCol="0" anchor="t"/>
-          <a:lstStyle/>
-          <a:p>
-            <a:pPr indent="0" marL="0">
-              <a:buNone/>
-            </a:pPr>
-            <a:r>
-              <a:rPr lang="en-US" sz="900" dirty="0">
-                <a:solidFill>
-                  <a:srgbClr val="555555"/>
-                </a:solidFill>
-                <a:latin typeface="Calibri" pitchFamily="34" charset="0"/>
-                <a:ea typeface="Calibri" pitchFamily="34" charset="-122"/>
-                <a:cs typeface="Calibri" pitchFamily="34" charset="-120"/>
-              </a:rPr>
-              <a:t>A 4-phase ERP consolidation moves every program into D365 F&amp;O. Phase 1 is done and already proving the model.</a:t>
-            </a:r>
-            <a:endParaRPr lang="en-US" sz="900" dirty="0"/>
-          </a:p>
-        </p:txBody>
-      </p:sp>
-      <p:sp>
-        <p:nvSpPr>
-          <p:cNvPr id="58" name="Shape 56"/>
-          <p:cNvSpPr/>
-          <p:nvPr/>
-        </p:nvSpPr>
-        <p:spPr>
-          <a:xfrm>
-            <a:off x="8308848" y="4983480"/>
-            <a:ext cx="73152" cy="73152"/>
-          </a:xfrm>
-          <a:prstGeom prst="ellipse">
-            <a:avLst/>
-          </a:prstGeom>
-          <a:solidFill>
-            <a:srgbClr val="5B2C8D"/>
-          </a:solidFill>
-          <a:ln w="12700">
-            <a:solidFill>
-              <a:srgbClr val="5B2C8D"/>
-            </a:solidFill>
-            <a:prstDash val="solid"/>
-          </a:ln>
-        </p:spPr>
-      </p:sp>
-      <p:sp>
-        <p:nvSpPr>
-          <p:cNvPr id="59" name="Text 57"/>
-          <p:cNvSpPr/>
-          <p:nvPr/>
-        </p:nvSpPr>
-        <p:spPr>
-          <a:xfrm>
-            <a:off x="8455152" y="4901184"/>
-            <a:ext cx="3185160" cy="329184"/>
-          </a:xfrm>
-          <a:prstGeom prst="rect">
-            <a:avLst/>
-          </a:prstGeom>
-          <a:noFill/>
-          <a:ln/>
-        </p:spPr>
-        <p:txBody>
-          <a:bodyPr wrap="square" rtlCol="0" anchor="ctr"/>
-          <a:lstStyle/>
-          <a:p>
-            <a:pPr indent="0" marL="0">
-              <a:buNone/>
-            </a:pPr>
-            <a:r>
-              <a:rPr lang="en-US" sz="900" dirty="0">
-                <a:solidFill>
-                  <a:srgbClr val="333333"/>
-                </a:solidFill>
-                <a:latin typeface="Calibri" pitchFamily="34" charset="0"/>
-                <a:ea typeface="Calibri" pitchFamily="34" charset="-122"/>
-                <a:cs typeface="Calibri" pitchFamily="34" charset="-120"/>
-              </a:rPr>
-              <a:t>Phase 1 (2024–25): DES / NDES / ISP — complete</a:t>
-            </a:r>
-            <a:endParaRPr lang="en-US" sz="900" dirty="0"/>
-          </a:p>
-        </p:txBody>
-      </p:sp>
-      <p:sp>
-        <p:nvSpPr>
-          <p:cNvPr id="60" name="Shape 58"/>
-          <p:cNvSpPr/>
-          <p:nvPr/>
-        </p:nvSpPr>
-        <p:spPr>
-          <a:xfrm>
-            <a:off x="8308848" y="5349240"/>
-            <a:ext cx="73152" cy="73152"/>
-          </a:xfrm>
-          <a:prstGeom prst="ellipse">
-            <a:avLst/>
-          </a:prstGeom>
-          <a:solidFill>
-            <a:srgbClr val="5B2C8D"/>
-          </a:solidFill>
-          <a:ln w="12700">
-            <a:solidFill>
-              <a:srgbClr val="5B2C8D"/>
-            </a:solidFill>
-            <a:prstDash val="solid"/>
-          </a:ln>
-        </p:spPr>
-      </p:sp>
-      <p:sp>
-        <p:nvSpPr>
-          <p:cNvPr id="61" name="Text 59"/>
-          <p:cNvSpPr/>
-          <p:nvPr/>
-        </p:nvSpPr>
-        <p:spPr>
-          <a:xfrm>
-            <a:off x="8455152" y="5266944"/>
-            <a:ext cx="3185160" cy="329184"/>
-          </a:xfrm>
-          <a:prstGeom prst="rect">
-            <a:avLst/>
-          </a:prstGeom>
-          <a:noFill/>
-          <a:ln/>
-        </p:spPr>
-        <p:txBody>
-          <a:bodyPr wrap="square" rtlCol="0" anchor="ctr"/>
-          <a:lstStyle/>
-          <a:p>
-            <a:pPr indent="0" marL="0">
-              <a:buNone/>
-            </a:pPr>
-            <a:r>
-              <a:rPr lang="en-US" sz="900" dirty="0">
-                <a:solidFill>
-                  <a:srgbClr val="333333"/>
-                </a:solidFill>
-                <a:latin typeface="Calibri" pitchFamily="34" charset="0"/>
-                <a:ea typeface="Calibri" pitchFamily="34" charset="-122"/>
-                <a:cs typeface="Calibri" pitchFamily="34" charset="-120"/>
-              </a:rPr>
-              <a:t>Phases 2–3 (2026): UBIF Portal + SUR — in progress</a:t>
-            </a:r>
-            <a:endParaRPr lang="en-US" sz="900" dirty="0"/>
-          </a:p>
-        </p:txBody>
-      </p:sp>
-      <p:sp>
-        <p:nvSpPr>
-          <p:cNvPr id="62" name="Shape 60"/>
-          <p:cNvSpPr/>
-          <p:nvPr/>
-        </p:nvSpPr>
-        <p:spPr>
-          <a:xfrm>
-            <a:off x="8308848" y="5715000"/>
-            <a:ext cx="73152" cy="73152"/>
-          </a:xfrm>
-          <a:prstGeom prst="ellipse">
-            <a:avLst/>
-          </a:prstGeom>
-          <a:solidFill>
-            <a:srgbClr val="5B2C8D"/>
-          </a:solidFill>
-          <a:ln w="12700">
-            <a:solidFill>
-              <a:srgbClr val="5B2C8D"/>
-            </a:solidFill>
-            <a:prstDash val="solid"/>
-          </a:ln>
-        </p:spPr>
-      </p:sp>
-      <p:sp>
-        <p:nvSpPr>
-          <p:cNvPr id="63" name="Text 61"/>
-          <p:cNvSpPr/>
-          <p:nvPr/>
-        </p:nvSpPr>
-        <p:spPr>
-          <a:xfrm>
-            <a:off x="8455152" y="5632704"/>
-            <a:ext cx="3185160" cy="329184"/>
-          </a:xfrm>
-          <a:prstGeom prst="rect">
-            <a:avLst/>
-          </a:prstGeom>
-          <a:noFill/>
-          <a:ln/>
-        </p:spPr>
-        <p:txBody>
-          <a:bodyPr wrap="square" rtlCol="0" anchor="ctr"/>
-          <a:lstStyle/>
-          <a:p>
-            <a:pPr indent="0" marL="0">
-              <a:buNone/>
-            </a:pPr>
-            <a:r>
-              <a:rPr lang="en-US" sz="900" dirty="0">
-                <a:solidFill>
-                  <a:srgbClr val="333333"/>
-                </a:solidFill>
-                <a:latin typeface="Calibri" pitchFamily="34" charset="0"/>
-                <a:ea typeface="Calibri" pitchFamily="34" charset="-122"/>
-                <a:cs typeface="Calibri" pitchFamily="34" charset="-120"/>
-              </a:rPr>
-              <a:t>Phase 4 (2027): Distro → 100% of inventory in one ERP</a:t>
-            </a:r>
-            <a:endParaRPr lang="en-US" sz="900" dirty="0"/>
-          </a:p>
-        </p:txBody>
-      </p:sp>
-      <p:sp>
-        <p:nvSpPr>
-          <p:cNvPr id="64" name="Shape 62"/>
-          <p:cNvSpPr/>
-          <p:nvPr/>
-        </p:nvSpPr>
-        <p:spPr>
-          <a:xfrm>
-            <a:off x="8308848" y="5797296"/>
-            <a:ext cx="3331464" cy="237744"/>
-          </a:xfrm>
-          <a:prstGeom prst="roundRect">
-            <a:avLst>
-              <a:gd name="adj" fmla="val 15385"/>
-            </a:avLst>
-          </a:prstGeom>
-          <a:solidFill>
-            <a:srgbClr val="F5F4F8"/>
-          </a:solidFill>
-          <a:ln w="6350">
-            <a:solidFill>
-              <a:srgbClr val="DDDDDD"/>
-            </a:solidFill>
-            <a:prstDash val="solid"/>
-          </a:ln>
-        </p:spPr>
-      </p:sp>
-      <p:sp>
-        <p:nvSpPr>
-          <p:cNvPr id="65" name="Text 63"/>
-          <p:cNvSpPr/>
-          <p:nvPr/>
-        </p:nvSpPr>
-        <p:spPr>
-          <a:xfrm>
-            <a:off x="8308848" y="5797296"/>
-            <a:ext cx="3331464" cy="237744"/>
-          </a:xfrm>
-          <a:prstGeom prst="rect">
-            <a:avLst/>
-          </a:prstGeom>
-          <a:noFill/>
-          <a:ln/>
-        </p:spPr>
-        <p:txBody>
-          <a:bodyPr wrap="square" rtlCol="0" anchor="ctr"/>
-          <a:lstStyle/>
-          <a:p>
-            <a:pPr algn="ctr" indent="0" marL="0">
-              <a:buNone/>
-            </a:pPr>
-            <a:r>
-              <a:rPr lang="en-US" sz="800" dirty="0">
-                <a:solidFill>
-                  <a:srgbClr val="888888"/>
-                </a:solidFill>
-                <a:latin typeface="Calibri" pitchFamily="34" charset="0"/>
-                <a:ea typeface="Calibri" pitchFamily="34" charset="-122"/>
-                <a:cs typeface="Calibri" pitchFamily="34" charset="-120"/>
-              </a:rPr>
-              <a:t>Slides 06 – 07</a:t>
-            </a:r>
-            <a:endParaRPr lang="en-US" sz="800" dirty="0"/>
-          </a:p>
-        </p:txBody>
-      </p:sp>
-      <p:sp>
-        <p:nvSpPr>
-          <p:cNvPr id="66" name="Text 64"/>
-          <p:cNvSpPr/>
-          <p:nvPr/>
-        </p:nvSpPr>
-        <p:spPr>
-          <a:xfrm>
-            <a:off x="4081272" y="3959352"/>
-            <a:ext cx="292608" cy="329184"/>
-          </a:xfrm>
-          <a:prstGeom prst="rect">
-            <a:avLst/>
-          </a:prstGeom>
-          <a:noFill/>
-          <a:ln/>
-        </p:spPr>
-        <p:txBody>
-          <a:bodyPr wrap="square" rtlCol="0" anchor="ctr"/>
-          <a:lstStyle/>
-          <a:p>
-            <a:pPr algn="ctr" indent="0" marL="0">
-              <a:buNone/>
-            </a:pPr>
-            <a:r>
-              <a:rPr lang="en-US" sz="1600" b="1" dirty="0">
-                <a:solidFill>
-                  <a:srgbClr val="C4AEED"/>
-                </a:solidFill>
-                <a:latin typeface="Calibri" pitchFamily="34" charset="0"/>
-                <a:ea typeface="Calibri" pitchFamily="34" charset="-122"/>
-                <a:cs typeface="Calibri" pitchFamily="34" charset="-120"/>
-              </a:rPr>
-              <a:t>→</a:t>
-            </a:r>
-            <a:endParaRPr lang="en-US" sz="1600" dirty="0"/>
-          </a:p>
-        </p:txBody>
-      </p:sp>
-      <p:sp>
-        <p:nvSpPr>
-          <p:cNvPr id="67" name="Text 65"/>
-          <p:cNvSpPr/>
-          <p:nvPr/>
-        </p:nvSpPr>
-        <p:spPr>
-          <a:xfrm>
-            <a:off x="7961376" y="3959352"/>
-            <a:ext cx="292608" cy="329184"/>
-          </a:xfrm>
-          <a:prstGeom prst="rect">
-            <a:avLst/>
-          </a:prstGeom>
-          <a:noFill/>
-          <a:ln/>
-        </p:spPr>
-        <p:txBody>
-          <a:bodyPr wrap="square" rtlCol="0" anchor="ctr"/>
-          <a:lstStyle/>
-          <a:p>
-            <a:pPr algn="ctr" indent="0" marL="0">
-              <a:buNone/>
-            </a:pPr>
-            <a:r>
-              <a:rPr lang="en-US" sz="1600" b="1" dirty="0">
-                <a:solidFill>
-                  <a:srgbClr val="C4AEED"/>
-                </a:solidFill>
-                <a:latin typeface="Calibri" pitchFamily="34" charset="0"/>
-                <a:ea typeface="Calibri" pitchFamily="34" charset="-122"/>
-                <a:cs typeface="Calibri" pitchFamily="34" charset="-120"/>
-              </a:rPr>
-              <a:t>→</a:t>
-            </a:r>
-            <a:endParaRPr lang="en-US" sz="1600" dirty="0"/>
-          </a:p>
-        </p:txBody>
-      </p:sp>
-      <p:sp>
-        <p:nvSpPr>
-          <p:cNvPr id="68" name="Shape 66"/>
-          <p:cNvSpPr/>
-          <p:nvPr/>
-        </p:nvSpPr>
-        <p:spPr>
-          <a:xfrm>
-            <a:off x="0" y="6473952"/>
-            <a:ext cx="12188952" cy="0"/>
-          </a:xfrm>
-          <a:prstGeom prst="line">
-            <a:avLst/>
-          </a:prstGeom>
-          <a:noFill/>
-          <a:ln w="6350">
-            <a:solidFill>
-              <a:srgbClr val="DDDDDD"/>
-            </a:solidFill>
-            <a:prstDash val="solid"/>
-          </a:ln>
-        </p:spPr>
-      </p:sp>
-      <p:sp>
-        <p:nvSpPr>
-          <p:cNvPr id="69" name="Text 67"/>
+          <p:cNvPr id="42" name="Text 40"/>
           <p:cNvSpPr/>
           <p:nvPr/>
         </p:nvSpPr>
@@ -4458,7 +3588,7 @@
       </p:sp>
       <p:sp>
         <p:nvSpPr>
-          <p:cNvPr id="70" name="Text 68"/>
+          <p:cNvPr id="43" name="Text 41"/>
           <p:cNvSpPr/>
           <p:nvPr/>
         </p:nvSpPr>
@@ -4497,7 +3627,7 @@
       </p:sp>
       <p:sp>
         <p:nvSpPr>
-          <p:cNvPr id="71" name="Text 69"/>
+          <p:cNvPr id="44" name="Text 42"/>
           <p:cNvSpPr/>
           <p:nvPr/>
         </p:nvSpPr>

</xml_diff>

<commit_message>
Reframe agenda hero statement to set stage, not reveal conclusion
Removes the $207M legacy system risk callout from the opening line.
New framing establishes inventory's scale and signals what the review
will examine, without giving away the findings before context is built.

https://claude.ai/code/session_01KWybSEC2vfMTAERCxx1Z2W
</commit_message>
<xml_diff>
--- a/public/Inventory-at-Asurion.pptx
+++ b/public/Inventory-at-Asurion.pptx
@@ -2249,7 +2249,7 @@
                 <a:ea typeface="Calibri" pitchFamily="34" charset="-122"/>
                 <a:cs typeface="Calibri" pitchFamily="34" charset="-120"/>
               </a:rPr>
-              <a:t>Asurion manages approximately </a:t>
+              <a:t>Inventory is a </a:t>
             </a:r>
             <a:pPr indent="0" marL="0">
               <a:buNone/>
@@ -2263,7 +2263,7 @@
                 <a:ea typeface="Calibri" pitchFamily="34" charset="-122"/>
                 <a:cs typeface="Calibri" pitchFamily="34" charset="-120"/>
               </a:rPr>
-              <a:t>~$609M in inventory</a:t>
+              <a:t>~$609M asset</a:t>
             </a:r>
             <a:pPr indent="0" marL="0">
               <a:buNone/>
@@ -2277,7 +2277,7 @@
                 <a:ea typeface="Calibri" pitchFamily="34" charset="-122"/>
                 <a:cs typeface="Calibri" pitchFamily="34" charset="-120"/>
               </a:rPr>
-              <a:t> across </a:t>
+              <a:t> moving across </a:t>
             </a:r>
             <a:pPr indent="0" marL="0">
               <a:buNone/>
@@ -2305,35 +2305,7 @@
                 <a:ea typeface="Calibri" pitchFamily="34" charset="-122"/>
                 <a:cs typeface="Calibri" pitchFamily="34" charset="-120"/>
               </a:rPr>
-              <a:t> spanning every fulfillment program. Of that, </a:t>
-            </a:r>
-            <a:pPr indent="0" marL="0">
-              <a:buNone/>
-            </a:pPr>
-            <a:r>
-              <a:rPr lang="en-US" sz="1100" b="1" dirty="0">
-                <a:solidFill>
-                  <a:srgbClr val="5B2C8D"/>
-                </a:solidFill>
-                <a:latin typeface="Calibri" pitchFamily="34" charset="0"/>
-                <a:ea typeface="Calibri" pitchFamily="34" charset="-122"/>
-                <a:cs typeface="Calibri" pitchFamily="34" charset="-120"/>
-              </a:rPr>
-              <a:t>$207M remains on legacy systems outside D365 F&amp;O</a:t>
-            </a:r>
-            <a:pPr indent="0" marL="0">
-              <a:buNone/>
-            </a:pPr>
-            <a:r>
-              <a:rPr lang="en-US" sz="1100" dirty="0">
-                <a:solidFill>
-                  <a:srgbClr val="333333"/>
-                </a:solidFill>
-                <a:latin typeface="Calibri" pitchFamily="34" charset="0"/>
-                <a:ea typeface="Calibri" pitchFamily="34" charset="-122"/>
-                <a:cs typeface="Calibri" pitchFamily="34" charset="-120"/>
-              </a:rPr>
-              <a:t> — introducing financial exposure, reconciliation gaps, and limited operational visibility. This review outlines the current state, the systemic risk, and the consolidation path to a single source of truth.</a:t>
+              <a:t> every day — powering every service motion Asurion runs. This review examines how it is managed, where complexity lives, and what it will take to operate it with full visibility and control.</a:t>
             </a:r>
             <a:endParaRPr lang="en-US" sz="1100" dirty="0"/>
           </a:p>

</xml_diff>

<commit_message>
Add review goal statement to agenda slide
Purple bar below the three story boxes states what leadership
should walk away understanding — inventory as strategic capability,
not just an ops function.

https://claude.ai/code/session_01KWybSEC2vfMTAERCxx1Z2W
</commit_message>
<xml_diff>
--- a/public/Inventory-at-Asurion.pptx
+++ b/public/Inventory-at-Asurion.pptx
@@ -2319,12 +2319,12 @@
         </p:nvSpPr>
         <p:spPr>
           <a:xfrm>
-            <a:off x="365760" y="2103120"/>
-            <a:ext cx="3697224" cy="3566160"/>
+            <a:off x="365760" y="2011680"/>
+            <a:ext cx="3697224" cy="3291840"/>
           </a:xfrm>
           <a:prstGeom prst="roundRect">
             <a:avLst>
-              <a:gd name="adj" fmla="val 1795"/>
+              <a:gd name="adj" fmla="val 1944"/>
             </a:avLst>
           </a:prstGeom>
           <a:solidFill>
@@ -2346,7 +2346,7 @@
         </p:nvSpPr>
         <p:spPr>
           <a:xfrm>
-            <a:off x="365760" y="2103120"/>
+            <a:off x="365760" y="2011680"/>
             <a:ext cx="3697224" cy="658368"/>
           </a:xfrm>
           <a:prstGeom prst="roundRect">
@@ -2373,7 +2373,7 @@
         </p:nvSpPr>
         <p:spPr>
           <a:xfrm>
-            <a:off x="365760" y="2578608"/>
+            <a:off x="365760" y="2487168"/>
             <a:ext cx="3697224" cy="182880"/>
           </a:xfrm>
           <a:prstGeom prst="rect">
@@ -2398,7 +2398,7 @@
         </p:nvSpPr>
         <p:spPr>
           <a:xfrm>
-            <a:off x="548640" y="2194560"/>
+            <a:off x="548640" y="2103120"/>
             <a:ext cx="384048" cy="384048"/>
           </a:xfrm>
           <a:prstGeom prst="ellipse">
@@ -2423,7 +2423,7 @@
         </p:nvSpPr>
         <p:spPr>
           <a:xfrm>
-            <a:off x="548640" y="2194560"/>
+            <a:off x="548640" y="2103120"/>
             <a:ext cx="384048" cy="384048"/>
           </a:xfrm>
           <a:prstGeom prst="rect">
@@ -2462,7 +2462,7 @@
         </p:nvSpPr>
         <p:spPr>
           <a:xfrm>
-            <a:off x="1060704" y="2267712"/>
+            <a:off x="1060704" y="2176272"/>
             <a:ext cx="2874264" cy="237744"/>
           </a:xfrm>
           <a:prstGeom prst="rect">
@@ -2501,7 +2501,7 @@
         </p:nvSpPr>
         <p:spPr>
           <a:xfrm>
-            <a:off x="548640" y="2761488"/>
+            <a:off x="548640" y="2670048"/>
             <a:ext cx="3331464" cy="0"/>
           </a:xfrm>
           <a:prstGeom prst="line">
@@ -2524,7 +2524,7 @@
         </p:nvSpPr>
         <p:spPr>
           <a:xfrm>
-            <a:off x="548640" y="2852928"/>
+            <a:off x="548640" y="2761488"/>
             <a:ext cx="3331464" cy="658368"/>
           </a:xfrm>
           <a:prstGeom prst="rect">
@@ -2580,7 +2580,7 @@
         </p:nvSpPr>
         <p:spPr>
           <a:xfrm>
-            <a:off x="548640" y="3602736"/>
+            <a:off x="548640" y="3511296"/>
             <a:ext cx="3331464" cy="2194560"/>
           </a:xfrm>
           <a:prstGeom prst="rect">
@@ -2622,7 +2622,7 @@
         </p:nvSpPr>
         <p:spPr>
           <a:xfrm>
-            <a:off x="548640" y="5321808"/>
+            <a:off x="548640" y="4956048"/>
             <a:ext cx="3331464" cy="237744"/>
           </a:xfrm>
           <a:prstGeom prst="roundRect">
@@ -2649,7 +2649,7 @@
         </p:nvSpPr>
         <p:spPr>
           <a:xfrm>
-            <a:off x="548640" y="5321808"/>
+            <a:off x="548640" y="4956048"/>
             <a:ext cx="3331464" cy="237744"/>
           </a:xfrm>
           <a:prstGeom prst="rect">
@@ -2688,12 +2688,12 @@
         </p:nvSpPr>
         <p:spPr>
           <a:xfrm>
-            <a:off x="4245864" y="2103120"/>
-            <a:ext cx="3697224" cy="3566160"/>
+            <a:off x="4245864" y="2011680"/>
+            <a:ext cx="3697224" cy="3291840"/>
           </a:xfrm>
           <a:prstGeom prst="roundRect">
             <a:avLst>
-              <a:gd name="adj" fmla="val 1795"/>
+              <a:gd name="adj" fmla="val 1944"/>
             </a:avLst>
           </a:prstGeom>
           <a:solidFill>
@@ -2715,7 +2715,7 @@
         </p:nvSpPr>
         <p:spPr>
           <a:xfrm>
-            <a:off x="4245864" y="2103120"/>
+            <a:off x="4245864" y="2011680"/>
             <a:ext cx="3697224" cy="658368"/>
           </a:xfrm>
           <a:prstGeom prst="roundRect">
@@ -2742,7 +2742,7 @@
         </p:nvSpPr>
         <p:spPr>
           <a:xfrm>
-            <a:off x="4245864" y="2578608"/>
+            <a:off x="4245864" y="2487168"/>
             <a:ext cx="3697224" cy="182880"/>
           </a:xfrm>
           <a:prstGeom prst="rect">
@@ -2767,7 +2767,7 @@
         </p:nvSpPr>
         <p:spPr>
           <a:xfrm>
-            <a:off x="4428744" y="2194560"/>
+            <a:off x="4428744" y="2103120"/>
             <a:ext cx="384048" cy="384048"/>
           </a:xfrm>
           <a:prstGeom prst="ellipse">
@@ -2792,7 +2792,7 @@
         </p:nvSpPr>
         <p:spPr>
           <a:xfrm>
-            <a:off x="4428744" y="2194560"/>
+            <a:off x="4428744" y="2103120"/>
             <a:ext cx="384048" cy="384048"/>
           </a:xfrm>
           <a:prstGeom prst="rect">
@@ -2831,7 +2831,7 @@
         </p:nvSpPr>
         <p:spPr>
           <a:xfrm>
-            <a:off x="4940808" y="2267712"/>
+            <a:off x="4940808" y="2176272"/>
             <a:ext cx="2874264" cy="237744"/>
           </a:xfrm>
           <a:prstGeom prst="rect">
@@ -2870,7 +2870,7 @@
         </p:nvSpPr>
         <p:spPr>
           <a:xfrm>
-            <a:off x="4428744" y="2761488"/>
+            <a:off x="4428744" y="2670048"/>
             <a:ext cx="3331464" cy="0"/>
           </a:xfrm>
           <a:prstGeom prst="line">
@@ -2893,7 +2893,7 @@
         </p:nvSpPr>
         <p:spPr>
           <a:xfrm>
-            <a:off x="4428744" y="2852928"/>
+            <a:off x="4428744" y="2761488"/>
             <a:ext cx="3331464" cy="658368"/>
           </a:xfrm>
           <a:prstGeom prst="rect">
@@ -2949,7 +2949,7 @@
         </p:nvSpPr>
         <p:spPr>
           <a:xfrm>
-            <a:off x="4428744" y="3602736"/>
+            <a:off x="4428744" y="3511296"/>
             <a:ext cx="3331464" cy="2194560"/>
           </a:xfrm>
           <a:prstGeom prst="rect">
@@ -2991,7 +2991,7 @@
         </p:nvSpPr>
         <p:spPr>
           <a:xfrm>
-            <a:off x="4428744" y="5321808"/>
+            <a:off x="4428744" y="4956048"/>
             <a:ext cx="3331464" cy="237744"/>
           </a:xfrm>
           <a:prstGeom prst="roundRect">
@@ -3018,7 +3018,7 @@
         </p:nvSpPr>
         <p:spPr>
           <a:xfrm>
-            <a:off x="4428744" y="5321808"/>
+            <a:off x="4428744" y="4956048"/>
             <a:ext cx="3331464" cy="237744"/>
           </a:xfrm>
           <a:prstGeom prst="rect">
@@ -3057,12 +3057,12 @@
         </p:nvSpPr>
         <p:spPr>
           <a:xfrm>
-            <a:off x="8125968" y="2103120"/>
-            <a:ext cx="3697224" cy="3566160"/>
+            <a:off x="8125968" y="2011680"/>
+            <a:ext cx="3697224" cy="3291840"/>
           </a:xfrm>
           <a:prstGeom prst="roundRect">
             <a:avLst>
-              <a:gd name="adj" fmla="val 1795"/>
+              <a:gd name="adj" fmla="val 1944"/>
             </a:avLst>
           </a:prstGeom>
           <a:solidFill>
@@ -3084,7 +3084,7 @@
         </p:nvSpPr>
         <p:spPr>
           <a:xfrm>
-            <a:off x="8125968" y="2103120"/>
+            <a:off x="8125968" y="2011680"/>
             <a:ext cx="3697224" cy="658368"/>
           </a:xfrm>
           <a:prstGeom prst="roundRect">
@@ -3111,7 +3111,7 @@
         </p:nvSpPr>
         <p:spPr>
           <a:xfrm>
-            <a:off x="8125968" y="2578608"/>
+            <a:off x="8125968" y="2487168"/>
             <a:ext cx="3697224" cy="182880"/>
           </a:xfrm>
           <a:prstGeom prst="rect">
@@ -3136,7 +3136,7 @@
         </p:nvSpPr>
         <p:spPr>
           <a:xfrm>
-            <a:off x="8308848" y="2194560"/>
+            <a:off x="8308848" y="2103120"/>
             <a:ext cx="384048" cy="384048"/>
           </a:xfrm>
           <a:prstGeom prst="ellipse">
@@ -3161,7 +3161,7 @@
         </p:nvSpPr>
         <p:spPr>
           <a:xfrm>
-            <a:off x="8308848" y="2194560"/>
+            <a:off x="8308848" y="2103120"/>
             <a:ext cx="384048" cy="384048"/>
           </a:xfrm>
           <a:prstGeom prst="rect">
@@ -3200,7 +3200,7 @@
         </p:nvSpPr>
         <p:spPr>
           <a:xfrm>
-            <a:off x="8820912" y="2267712"/>
+            <a:off x="8820912" y="2176272"/>
             <a:ext cx="2874264" cy="237744"/>
           </a:xfrm>
           <a:prstGeom prst="rect">
@@ -3239,7 +3239,7 @@
         </p:nvSpPr>
         <p:spPr>
           <a:xfrm>
-            <a:off x="8308848" y="2761488"/>
+            <a:off x="8308848" y="2670048"/>
             <a:ext cx="3331464" cy="0"/>
           </a:xfrm>
           <a:prstGeom prst="line">
@@ -3262,7 +3262,7 @@
         </p:nvSpPr>
         <p:spPr>
           <a:xfrm>
-            <a:off x="8308848" y="2852928"/>
+            <a:off x="8308848" y="2761488"/>
             <a:ext cx="3331464" cy="658368"/>
           </a:xfrm>
           <a:prstGeom prst="rect">
@@ -3318,7 +3318,7 @@
         </p:nvSpPr>
         <p:spPr>
           <a:xfrm>
-            <a:off x="8308848" y="3602736"/>
+            <a:off x="8308848" y="3511296"/>
             <a:ext cx="3331464" cy="2194560"/>
           </a:xfrm>
           <a:prstGeom prst="rect">
@@ -3360,7 +3360,7 @@
         </p:nvSpPr>
         <p:spPr>
           <a:xfrm>
-            <a:off x="8308848" y="5321808"/>
+            <a:off x="8308848" y="4956048"/>
             <a:ext cx="3331464" cy="237744"/>
           </a:xfrm>
           <a:prstGeom prst="roundRect">
@@ -3387,7 +3387,7 @@
         </p:nvSpPr>
         <p:spPr>
           <a:xfrm>
-            <a:off x="8308848" y="5321808"/>
+            <a:off x="8308848" y="4956048"/>
             <a:ext cx="3331464" cy="237744"/>
           </a:xfrm>
           <a:prstGeom prst="rect">
@@ -3426,7 +3426,7 @@
         </p:nvSpPr>
         <p:spPr>
           <a:xfrm>
-            <a:off x="4081272" y="3721608"/>
+            <a:off x="4081272" y="3493008"/>
             <a:ext cx="292608" cy="329184"/>
           </a:xfrm>
           <a:prstGeom prst="rect">
@@ -3465,7 +3465,7 @@
         </p:nvSpPr>
         <p:spPr>
           <a:xfrm>
-            <a:off x="7961376" y="3721608"/>
+            <a:off x="7961376" y="3493008"/>
             <a:ext cx="292608" cy="329184"/>
           </a:xfrm>
           <a:prstGeom prst="rect">
@@ -3499,6 +3499,114 @@
       <p:sp>
         <p:nvSpPr>
           <p:cNvPr id="41" name="Shape 39"/>
+          <p:cNvSpPr/>
+          <p:nvPr/>
+        </p:nvSpPr>
+        <p:spPr>
+          <a:xfrm>
+            <a:off x="365760" y="5468112"/>
+            <a:ext cx="11457432" cy="475488"/>
+          </a:xfrm>
+          <a:prstGeom prst="roundRect">
+            <a:avLst>
+              <a:gd name="adj" fmla="val 11538"/>
+            </a:avLst>
+          </a:prstGeom>
+          <a:solidFill>
+            <a:srgbClr val="5B2C8D"/>
+          </a:solidFill>
+          <a:ln w="12700">
+            <a:solidFill>
+              <a:srgbClr val="5B2C8D"/>
+            </a:solidFill>
+            <a:prstDash val="solid"/>
+          </a:ln>
+        </p:spPr>
+      </p:sp>
+      <p:sp>
+        <p:nvSpPr>
+          <p:cNvPr id="42" name="Text 40"/>
+          <p:cNvSpPr/>
+          <p:nvPr/>
+        </p:nvSpPr>
+        <p:spPr>
+          <a:xfrm>
+            <a:off x="621792" y="5477256"/>
+            <a:ext cx="10945368" cy="457200"/>
+          </a:xfrm>
+          <a:prstGeom prst="rect">
+            <a:avLst/>
+          </a:prstGeom>
+          <a:noFill/>
+          <a:ln/>
+        </p:spPr>
+        <p:txBody>
+          <a:bodyPr wrap="square" rtlCol="0" anchor="ctr"/>
+          <a:lstStyle/>
+          <a:p>
+            <a:pPr indent="0" marL="0">
+              <a:buNone/>
+            </a:pPr>
+            <a:r>
+              <a:rPr lang="en-US" sz="950" i="1" dirty="0">
+                <a:solidFill>
+                  <a:srgbClr val="C4AEED"/>
+                </a:solidFill>
+                <a:latin typeface="Calibri" pitchFamily="34" charset="0"/>
+                <a:ea typeface="Calibri" pitchFamily="34" charset="-122"/>
+                <a:cs typeface="Calibri" pitchFamily="34" charset="-120"/>
+              </a:rPr>
+              <a:t>At the end of this review, I hope that </a:t>
+            </a:r>
+            <a:pPr indent="0" marL="0">
+              <a:buNone/>
+            </a:pPr>
+            <a:r>
+              <a:rPr lang="en-US" sz="950" i="1" dirty="0">
+                <a:solidFill>
+                  <a:srgbClr val="FFFFFF"/>
+                </a:solidFill>
+                <a:latin typeface="Calibri" pitchFamily="34" charset="0"/>
+                <a:ea typeface="Calibri" pitchFamily="34" charset="-122"/>
+                <a:cs typeface="Calibri" pitchFamily="34" charset="-120"/>
+              </a:rPr>
+              <a:t>you leave with a clear understanding of the role inventory plays across every service program we run</a:t>
+            </a:r>
+            <a:pPr indent="0" marL="0">
+              <a:buNone/>
+            </a:pPr>
+            <a:r>
+              <a:rPr lang="en-US" sz="950" i="1" dirty="0">
+                <a:solidFill>
+                  <a:srgbClr val="C4AEED"/>
+                </a:solidFill>
+                <a:latin typeface="Calibri" pitchFamily="34" charset="0"/>
+                <a:ea typeface="Calibri" pitchFamily="34" charset="-122"/>
+                <a:cs typeface="Calibri" pitchFamily="34" charset="-120"/>
+              </a:rPr>
+              <a:t> — and why managing it with a single source of truth is not just an operational improvement, but a </a:t>
+            </a:r>
+            <a:pPr indent="0" marL="0">
+              <a:buNone/>
+            </a:pPr>
+            <a:r>
+              <a:rPr lang="en-US" sz="950" i="1" dirty="0">
+                <a:solidFill>
+                  <a:srgbClr val="FFFFFF"/>
+                </a:solidFill>
+                <a:latin typeface="Calibri" pitchFamily="34" charset="0"/>
+                <a:ea typeface="Calibri" pitchFamily="34" charset="-122"/>
+                <a:cs typeface="Calibri" pitchFamily="34" charset="-120"/>
+              </a:rPr>
+              <a:t>strategic capability that enables Asurion to move faster, reduce financial risk, and scale with confidence.</a:t>
+            </a:r>
+            <a:endParaRPr lang="en-US" sz="950" dirty="0"/>
+          </a:p>
+        </p:txBody>
+      </p:sp>
+      <p:sp>
+        <p:nvSpPr>
+          <p:cNvPr id="43" name="Shape 41"/>
           <p:cNvSpPr/>
           <p:nvPr/>
         </p:nvSpPr>
@@ -3521,7 +3629,7 @@
       </p:sp>
       <p:sp>
         <p:nvSpPr>
-          <p:cNvPr id="42" name="Text 40"/>
+          <p:cNvPr id="44" name="Text 42"/>
           <p:cNvSpPr/>
           <p:nvPr/>
         </p:nvSpPr>
@@ -3560,7 +3668,7 @@
       </p:sp>
       <p:sp>
         <p:nvSpPr>
-          <p:cNvPr id="43" name="Text 41"/>
+          <p:cNvPr id="45" name="Text 43"/>
           <p:cNvSpPr/>
           <p:nvPr/>
         </p:nvSpPr>
@@ -3599,7 +3707,7 @@
       </p:sp>
       <p:sp>
         <p:nvSpPr>
-          <p:cNvPr id="44" name="Text 42"/>
+          <p:cNvPr id="46" name="Text 44"/>
           <p:cNvSpPr/>
           <p:nvPr/>
         </p:nvSpPr>

</xml_diff>

<commit_message>
Tighten agenda box narratives and increase font size to 12pt
Reduced each narrative to 2 punchy sentences. Bumped font from 10pt
to 12pt so text is readable without leaning in.

https://claude.ai/code/session_01KWybSEC2vfMTAERCxx1Z2W
</commit_message>
<xml_diff>
--- a/public/Inventory-at-Asurion.pptx
+++ b/public/Inventory-at-Asurion.pptx
@@ -2600,7 +2600,7 @@
               <a:buNone/>
             </a:pPr>
             <a:r>
-              <a:rPr lang="en-US" sz="1000" dirty="0">
+              <a:rPr lang="en-US" sz="1200" dirty="0">
                 <a:solidFill>
                   <a:srgbClr val="555555"/>
                 </a:solidFill>
@@ -2608,9 +2608,9 @@
                 <a:ea typeface="Calibri" pitchFamily="34" charset="-122"/>
                 <a:cs typeface="Calibri" pitchFamily="34" charset="-120"/>
               </a:rPr>
-              <a:t>From advance exchange to same-unit repair to reverse logistics, inventory is present at every step. Understanding its scale — where it lives, how it moves, and what programs it supports — is the foundation for everything else in this review.</a:t>
-            </a:r>
-            <a:endParaRPr lang="en-US" sz="1000" dirty="0"/>
+              <a:t>A ~$609M asset across ~890 locations, present at every step — from advance exchange to reverse logistics. Scale and complexity demand a system built to match.</a:t>
+            </a:r>
+            <a:endParaRPr lang="en-US" sz="1200" dirty="0"/>
           </a:p>
         </p:txBody>
       </p:sp>
@@ -2969,7 +2969,7 @@
               <a:buNone/>
             </a:pPr>
             <a:r>
-              <a:rPr lang="en-US" sz="1000" dirty="0">
+              <a:rPr lang="en-US" sz="1200" dirty="0">
                 <a:solidFill>
                   <a:srgbClr val="555555"/>
                 </a:solidFill>
@@ -2977,9 +2977,9 @@
                 <a:ea typeface="Calibri" pitchFamily="34" charset="-122"/>
                 <a:cs typeface="Calibri" pitchFamily="34" charset="-120"/>
               </a:rPr>
-              <a:t>A significant portion of our inventory is managed across legacy platforms that are disconnected from our ERP. This fragmentation makes it difficult to trace units, close financial records accurately, and respond to issues before they compound into larger losses.</a:t>
-            </a:r>
-            <a:endParaRPr lang="en-US" sz="1000" dirty="0"/>
+              <a:t>Legacy platforms outside our ERP make it difficult to trace units, reconcile financials, and catch issues early. The gap compounds over time.</a:t>
+            </a:r>
+            <a:endParaRPr lang="en-US" sz="1200" dirty="0"/>
           </a:p>
         </p:txBody>
       </p:sp>
@@ -3338,7 +3338,7 @@
               <a:buNone/>
             </a:pPr>
             <a:r>
-              <a:rPr lang="en-US" sz="1000" dirty="0">
+              <a:rPr lang="en-US" sz="1200" dirty="0">
                 <a:solidFill>
                   <a:srgbClr val="555555"/>
                 </a:solidFill>
@@ -3346,9 +3346,9 @@
                 <a:ea typeface="Calibri" pitchFamily="34" charset="-122"/>
                 <a:cs typeface="Calibri" pitchFamily="34" charset="-120"/>
               </a:rPr>
-              <a:t>We have a tested, phased approach to consolidating every inventory program into a single source of truth. The model is already working — and this review outlines what remains, why it matters, and what full consolidation makes possible.</a:t>
-            </a:r>
-            <a:endParaRPr lang="en-US" sz="1000" dirty="0"/>
+              <a:t>We have a tested, phased approach to a single source of truth. The model is working — this review outlines what remains and what full consolidation makes possible.</a:t>
+            </a:r>
+            <a:endParaRPr lang="en-US" sz="1200" dirty="0"/>
           </a:p>
         </p:txBody>
       </p:sp>

</xml_diff>

<commit_message>
Fix agenda slide flow, font sizes, and hero statement
- Hero bar: simplified to scale statement only, font 11->13pt
- Added 'In this review, we will take a look at:' lead-in before boxes
- Goal bar: font bumped to 11.5pt so it's readable
- Adjusted box Y position to fit new layout

https://claude.ai/code/session_01KWybSEC2vfMTAERCxx1Z2W
</commit_message>
<xml_diff>
--- a/public/Inventory-at-Asurion.pptx
+++ b/public/Inventory-at-Asurion.pptx
@@ -2197,12 +2197,12 @@
         </p:nvSpPr>
         <p:spPr>
           <a:xfrm>
-            <a:off x="365760" y="1261872"/>
-            <a:ext cx="11457432" cy="658368"/>
+            <a:off x="365760" y="1207008"/>
+            <a:ext cx="11457432" cy="566928"/>
           </a:xfrm>
           <a:prstGeom prst="roundRect">
             <a:avLst>
-              <a:gd name="adj" fmla="val 8333"/>
+              <a:gd name="adj" fmla="val 9677"/>
             </a:avLst>
           </a:prstGeom>
           <a:solidFill>
@@ -2224,24 +2224,24 @@
         </p:nvSpPr>
         <p:spPr>
           <a:xfrm>
-            <a:off x="640080" y="1316736"/>
-            <a:ext cx="10908792" cy="548640"/>
-          </a:xfrm>
-          <a:prstGeom prst="rect">
-            <a:avLst/>
-          </a:prstGeom>
-          <a:noFill/>
-          <a:ln/>
-        </p:spPr>
-        <p:txBody>
-          <a:bodyPr wrap="square" rtlCol="0" anchor="ctr"/>
-          <a:lstStyle/>
-          <a:p>
-            <a:pPr indent="0" marL="0">
-              <a:buNone/>
-            </a:pPr>
-            <a:r>
-              <a:rPr lang="en-US" sz="1100" dirty="0">
+            <a:off x="640080" y="1225296"/>
+            <a:ext cx="10908792" cy="493776"/>
+          </a:xfrm>
+          <a:prstGeom prst="rect">
+            <a:avLst/>
+          </a:prstGeom>
+          <a:noFill/>
+          <a:ln/>
+        </p:spPr>
+        <p:txBody>
+          <a:bodyPr wrap="square" rtlCol="0" anchor="ctr"/>
+          <a:lstStyle/>
+          <a:p>
+            <a:pPr indent="0" marL="0">
+              <a:buNone/>
+            </a:pPr>
+            <a:r>
+              <a:rPr lang="en-US" sz="1300" dirty="0">
                 <a:solidFill>
                   <a:srgbClr val="333333"/>
                 </a:solidFill>
@@ -2255,7 +2255,7 @@
               <a:buNone/>
             </a:pPr>
             <a:r>
-              <a:rPr lang="en-US" sz="1100" b="1" dirty="0">
+              <a:rPr lang="en-US" sz="1300" b="1" dirty="0">
                 <a:solidFill>
                   <a:srgbClr val="5B2C8D"/>
                 </a:solidFill>
@@ -2269,7 +2269,7 @@
               <a:buNone/>
             </a:pPr>
             <a:r>
-              <a:rPr lang="en-US" sz="1100" dirty="0">
+              <a:rPr lang="en-US" sz="1300" dirty="0">
                 <a:solidFill>
                   <a:srgbClr val="333333"/>
                 </a:solidFill>
@@ -2283,7 +2283,7 @@
               <a:buNone/>
             </a:pPr>
             <a:r>
-              <a:rPr lang="en-US" sz="1100" b="1" dirty="0">
+              <a:rPr lang="en-US" sz="1300" b="1" dirty="0">
                 <a:solidFill>
                   <a:srgbClr val="5B2C8D"/>
                 </a:solidFill>
@@ -2297,7 +2297,7 @@
               <a:buNone/>
             </a:pPr>
             <a:r>
-              <a:rPr lang="en-US" sz="1100" dirty="0">
+              <a:rPr lang="en-US" sz="1300" dirty="0">
                 <a:solidFill>
                   <a:srgbClr val="333333"/>
                 </a:solidFill>
@@ -2305,7 +2305,46 @@
                 <a:ea typeface="Calibri" pitchFamily="34" charset="-122"/>
                 <a:cs typeface="Calibri" pitchFamily="34" charset="-120"/>
               </a:rPr>
-              <a:t> every day — powering every service motion Asurion runs. This review examines how it is managed, where complexity lives, and what it will take to operate it with full visibility and control.</a:t>
+              <a:t> every day — powering every service motion Asurion runs.</a:t>
+            </a:r>
+            <a:endParaRPr lang="en-US" sz="1300" dirty="0"/>
+          </a:p>
+        </p:txBody>
+      </p:sp>
+      <p:sp>
+        <p:nvSpPr>
+          <p:cNvPr id="6" name="Text 4"/>
+          <p:cNvSpPr/>
+          <p:nvPr/>
+        </p:nvSpPr>
+        <p:spPr>
+          <a:xfrm>
+            <a:off x="365760" y="1883664"/>
+            <a:ext cx="11457432" cy="274320"/>
+          </a:xfrm>
+          <a:prstGeom prst="rect">
+            <a:avLst/>
+          </a:prstGeom>
+          <a:noFill/>
+          <a:ln/>
+        </p:spPr>
+        <p:txBody>
+          <a:bodyPr wrap="square" rtlCol="0" anchor="ctr"/>
+          <a:lstStyle/>
+          <a:p>
+            <a:pPr indent="0" marL="0">
+              <a:buNone/>
+            </a:pPr>
+            <a:r>
+              <a:rPr lang="en-US" sz="1100" i="1" dirty="0">
+                <a:solidFill>
+                  <a:srgbClr val="888888"/>
+                </a:solidFill>
+                <a:latin typeface="Calibri" pitchFamily="34" charset="0"/>
+                <a:ea typeface="Calibri" pitchFamily="34" charset="-122"/>
+                <a:cs typeface="Calibri" pitchFamily="34" charset="-120"/>
+              </a:rPr>
+              <a:t>In this review, we will take a look at:</a:t>
             </a:r>
             <a:endParaRPr lang="en-US" sz="1100" dirty="0"/>
           </a:p>
@@ -2313,18 +2352,18 @@
       </p:sp>
       <p:sp>
         <p:nvSpPr>
-          <p:cNvPr id="6" name="Shape 4"/>
-          <p:cNvSpPr/>
-          <p:nvPr/>
-        </p:nvSpPr>
-        <p:spPr>
-          <a:xfrm>
-            <a:off x="365760" y="2011680"/>
-            <a:ext cx="3697224" cy="3291840"/>
+          <p:cNvPr id="7" name="Shape 5"/>
+          <p:cNvSpPr/>
+          <p:nvPr/>
+        </p:nvSpPr>
+        <p:spPr>
+          <a:xfrm>
+            <a:off x="365760" y="2231136"/>
+            <a:ext cx="3697224" cy="3108960"/>
           </a:xfrm>
           <a:prstGeom prst="roundRect">
             <a:avLst>
-              <a:gd name="adj" fmla="val 1944"/>
+              <a:gd name="adj" fmla="val 2059"/>
             </a:avLst>
           </a:prstGeom>
           <a:solidFill>
@@ -2340,13 +2379,13 @@
       </p:sp>
       <p:sp>
         <p:nvSpPr>
-          <p:cNvPr id="7" name="Shape 5"/>
-          <p:cNvSpPr/>
-          <p:nvPr/>
-        </p:nvSpPr>
-        <p:spPr>
-          <a:xfrm>
-            <a:off x="365760" y="2011680"/>
+          <p:cNvPr id="8" name="Shape 6"/>
+          <p:cNvSpPr/>
+          <p:nvPr/>
+        </p:nvSpPr>
+        <p:spPr>
+          <a:xfrm>
+            <a:off x="365760" y="2231136"/>
             <a:ext cx="3697224" cy="658368"/>
           </a:xfrm>
           <a:prstGeom prst="roundRect">
@@ -2367,13 +2406,13 @@
       </p:sp>
       <p:sp>
         <p:nvSpPr>
-          <p:cNvPr id="8" name="Shape 6"/>
-          <p:cNvSpPr/>
-          <p:nvPr/>
-        </p:nvSpPr>
-        <p:spPr>
-          <a:xfrm>
-            <a:off x="365760" y="2487168"/>
+          <p:cNvPr id="9" name="Shape 7"/>
+          <p:cNvSpPr/>
+          <p:nvPr/>
+        </p:nvSpPr>
+        <p:spPr>
+          <a:xfrm>
+            <a:off x="365760" y="2706624"/>
             <a:ext cx="3697224" cy="182880"/>
           </a:xfrm>
           <a:prstGeom prst="rect">
@@ -2392,13 +2431,13 @@
       </p:sp>
       <p:sp>
         <p:nvSpPr>
-          <p:cNvPr id="9" name="Shape 7"/>
-          <p:cNvSpPr/>
-          <p:nvPr/>
-        </p:nvSpPr>
-        <p:spPr>
-          <a:xfrm>
-            <a:off x="548640" y="2103120"/>
+          <p:cNvPr id="10" name="Shape 8"/>
+          <p:cNvSpPr/>
+          <p:nvPr/>
+        </p:nvSpPr>
+        <p:spPr>
+          <a:xfrm>
+            <a:off x="548640" y="2322576"/>
             <a:ext cx="384048" cy="384048"/>
           </a:xfrm>
           <a:prstGeom prst="ellipse">
@@ -2417,13 +2456,13 @@
       </p:sp>
       <p:sp>
         <p:nvSpPr>
-          <p:cNvPr id="10" name="Text 8"/>
-          <p:cNvSpPr/>
-          <p:nvPr/>
-        </p:nvSpPr>
-        <p:spPr>
-          <a:xfrm>
-            <a:off x="548640" y="2103120"/>
+          <p:cNvPr id="11" name="Text 9"/>
+          <p:cNvSpPr/>
+          <p:nvPr/>
+        </p:nvSpPr>
+        <p:spPr>
+          <a:xfrm>
+            <a:off x="548640" y="2322576"/>
             <a:ext cx="384048" cy="384048"/>
           </a:xfrm>
           <a:prstGeom prst="rect">
@@ -2456,13 +2495,13 @@
       </p:sp>
       <p:sp>
         <p:nvSpPr>
-          <p:cNvPr id="11" name="Text 9"/>
-          <p:cNvSpPr/>
-          <p:nvPr/>
-        </p:nvSpPr>
-        <p:spPr>
-          <a:xfrm>
-            <a:off x="1060704" y="2176272"/>
+          <p:cNvPr id="12" name="Text 10"/>
+          <p:cNvSpPr/>
+          <p:nvPr/>
+        </p:nvSpPr>
+        <p:spPr>
+          <a:xfrm>
+            <a:off x="1060704" y="2395728"/>
             <a:ext cx="2874264" cy="237744"/>
           </a:xfrm>
           <a:prstGeom prst="rect">
@@ -2495,13 +2534,13 @@
       </p:sp>
       <p:sp>
         <p:nvSpPr>
-          <p:cNvPr id="12" name="Shape 10"/>
-          <p:cNvSpPr/>
-          <p:nvPr/>
-        </p:nvSpPr>
-        <p:spPr>
-          <a:xfrm>
-            <a:off x="548640" y="2670048"/>
+          <p:cNvPr id="13" name="Shape 11"/>
+          <p:cNvSpPr/>
+          <p:nvPr/>
+        </p:nvSpPr>
+        <p:spPr>
+          <a:xfrm>
+            <a:off x="548640" y="2889504"/>
             <a:ext cx="3331464" cy="0"/>
           </a:xfrm>
           <a:prstGeom prst="line">
@@ -2518,13 +2557,13 @@
       </p:sp>
       <p:sp>
         <p:nvSpPr>
-          <p:cNvPr id="13" name="Text 11"/>
-          <p:cNvSpPr/>
-          <p:nvPr/>
-        </p:nvSpPr>
-        <p:spPr>
-          <a:xfrm>
-            <a:off x="548640" y="2761488"/>
+          <p:cNvPr id="14" name="Text 12"/>
+          <p:cNvSpPr/>
+          <p:nvPr/>
+        </p:nvSpPr>
+        <p:spPr>
+          <a:xfrm>
+            <a:off x="548640" y="2980944"/>
             <a:ext cx="3331464" cy="658368"/>
           </a:xfrm>
           <a:prstGeom prst="rect">
@@ -2574,13 +2613,13 @@
       </p:sp>
       <p:sp>
         <p:nvSpPr>
-          <p:cNvPr id="14" name="Text 12"/>
-          <p:cNvSpPr/>
-          <p:nvPr/>
-        </p:nvSpPr>
-        <p:spPr>
-          <a:xfrm>
-            <a:off x="548640" y="3511296"/>
+          <p:cNvPr id="15" name="Text 13"/>
+          <p:cNvSpPr/>
+          <p:nvPr/>
+        </p:nvSpPr>
+        <p:spPr>
+          <a:xfrm>
+            <a:off x="548640" y="3730752"/>
             <a:ext cx="3331464" cy="2194560"/>
           </a:xfrm>
           <a:prstGeom prst="rect">
@@ -2616,13 +2655,13 @@
       </p:sp>
       <p:sp>
         <p:nvSpPr>
-          <p:cNvPr id="15" name="Shape 13"/>
-          <p:cNvSpPr/>
-          <p:nvPr/>
-        </p:nvSpPr>
-        <p:spPr>
-          <a:xfrm>
-            <a:off x="548640" y="4956048"/>
+          <p:cNvPr id="16" name="Shape 14"/>
+          <p:cNvSpPr/>
+          <p:nvPr/>
+        </p:nvSpPr>
+        <p:spPr>
+          <a:xfrm>
+            <a:off x="548640" y="4992624"/>
             <a:ext cx="3331464" cy="237744"/>
           </a:xfrm>
           <a:prstGeom prst="roundRect">
@@ -2643,13 +2682,13 @@
       </p:sp>
       <p:sp>
         <p:nvSpPr>
-          <p:cNvPr id="16" name="Text 14"/>
-          <p:cNvSpPr/>
-          <p:nvPr/>
-        </p:nvSpPr>
-        <p:spPr>
-          <a:xfrm>
-            <a:off x="548640" y="4956048"/>
+          <p:cNvPr id="17" name="Text 15"/>
+          <p:cNvSpPr/>
+          <p:nvPr/>
+        </p:nvSpPr>
+        <p:spPr>
+          <a:xfrm>
+            <a:off x="548640" y="4992624"/>
             <a:ext cx="3331464" cy="237744"/>
           </a:xfrm>
           <a:prstGeom prst="rect">
@@ -2682,18 +2721,18 @@
       </p:sp>
       <p:sp>
         <p:nvSpPr>
-          <p:cNvPr id="17" name="Shape 15"/>
-          <p:cNvSpPr/>
-          <p:nvPr/>
-        </p:nvSpPr>
-        <p:spPr>
-          <a:xfrm>
-            <a:off x="4245864" y="2011680"/>
-            <a:ext cx="3697224" cy="3291840"/>
+          <p:cNvPr id="18" name="Shape 16"/>
+          <p:cNvSpPr/>
+          <p:nvPr/>
+        </p:nvSpPr>
+        <p:spPr>
+          <a:xfrm>
+            <a:off x="4245864" y="2231136"/>
+            <a:ext cx="3697224" cy="3108960"/>
           </a:xfrm>
           <a:prstGeom prst="roundRect">
             <a:avLst>
-              <a:gd name="adj" fmla="val 1944"/>
+              <a:gd name="adj" fmla="val 2059"/>
             </a:avLst>
           </a:prstGeom>
           <a:solidFill>
@@ -2709,13 +2748,13 @@
       </p:sp>
       <p:sp>
         <p:nvSpPr>
-          <p:cNvPr id="18" name="Shape 16"/>
-          <p:cNvSpPr/>
-          <p:nvPr/>
-        </p:nvSpPr>
-        <p:spPr>
-          <a:xfrm>
-            <a:off x="4245864" y="2011680"/>
+          <p:cNvPr id="19" name="Shape 17"/>
+          <p:cNvSpPr/>
+          <p:nvPr/>
+        </p:nvSpPr>
+        <p:spPr>
+          <a:xfrm>
+            <a:off x="4245864" y="2231136"/>
             <a:ext cx="3697224" cy="658368"/>
           </a:xfrm>
           <a:prstGeom prst="roundRect">
@@ -2736,13 +2775,13 @@
       </p:sp>
       <p:sp>
         <p:nvSpPr>
-          <p:cNvPr id="19" name="Shape 17"/>
-          <p:cNvSpPr/>
-          <p:nvPr/>
-        </p:nvSpPr>
-        <p:spPr>
-          <a:xfrm>
-            <a:off x="4245864" y="2487168"/>
+          <p:cNvPr id="20" name="Shape 18"/>
+          <p:cNvSpPr/>
+          <p:nvPr/>
+        </p:nvSpPr>
+        <p:spPr>
+          <a:xfrm>
+            <a:off x="4245864" y="2706624"/>
             <a:ext cx="3697224" cy="182880"/>
           </a:xfrm>
           <a:prstGeom prst="rect">
@@ -2761,13 +2800,13 @@
       </p:sp>
       <p:sp>
         <p:nvSpPr>
-          <p:cNvPr id="20" name="Shape 18"/>
-          <p:cNvSpPr/>
-          <p:nvPr/>
-        </p:nvSpPr>
-        <p:spPr>
-          <a:xfrm>
-            <a:off x="4428744" y="2103120"/>
+          <p:cNvPr id="21" name="Shape 19"/>
+          <p:cNvSpPr/>
+          <p:nvPr/>
+        </p:nvSpPr>
+        <p:spPr>
+          <a:xfrm>
+            <a:off x="4428744" y="2322576"/>
             <a:ext cx="384048" cy="384048"/>
           </a:xfrm>
           <a:prstGeom prst="ellipse">
@@ -2786,13 +2825,13 @@
       </p:sp>
       <p:sp>
         <p:nvSpPr>
-          <p:cNvPr id="21" name="Text 19"/>
-          <p:cNvSpPr/>
-          <p:nvPr/>
-        </p:nvSpPr>
-        <p:spPr>
-          <a:xfrm>
-            <a:off x="4428744" y="2103120"/>
+          <p:cNvPr id="22" name="Text 20"/>
+          <p:cNvSpPr/>
+          <p:nvPr/>
+        </p:nvSpPr>
+        <p:spPr>
+          <a:xfrm>
+            <a:off x="4428744" y="2322576"/>
             <a:ext cx="384048" cy="384048"/>
           </a:xfrm>
           <a:prstGeom prst="rect">
@@ -2825,13 +2864,13 @@
       </p:sp>
       <p:sp>
         <p:nvSpPr>
-          <p:cNvPr id="22" name="Text 20"/>
-          <p:cNvSpPr/>
-          <p:nvPr/>
-        </p:nvSpPr>
-        <p:spPr>
-          <a:xfrm>
-            <a:off x="4940808" y="2176272"/>
+          <p:cNvPr id="23" name="Text 21"/>
+          <p:cNvSpPr/>
+          <p:nvPr/>
+        </p:nvSpPr>
+        <p:spPr>
+          <a:xfrm>
+            <a:off x="4940808" y="2395728"/>
             <a:ext cx="2874264" cy="237744"/>
           </a:xfrm>
           <a:prstGeom prst="rect">
@@ -2864,13 +2903,13 @@
       </p:sp>
       <p:sp>
         <p:nvSpPr>
-          <p:cNvPr id="23" name="Shape 21"/>
-          <p:cNvSpPr/>
-          <p:nvPr/>
-        </p:nvSpPr>
-        <p:spPr>
-          <a:xfrm>
-            <a:off x="4428744" y="2670048"/>
+          <p:cNvPr id="24" name="Shape 22"/>
+          <p:cNvSpPr/>
+          <p:nvPr/>
+        </p:nvSpPr>
+        <p:spPr>
+          <a:xfrm>
+            <a:off x="4428744" y="2889504"/>
             <a:ext cx="3331464" cy="0"/>
           </a:xfrm>
           <a:prstGeom prst="line">
@@ -2887,13 +2926,13 @@
       </p:sp>
       <p:sp>
         <p:nvSpPr>
-          <p:cNvPr id="24" name="Text 22"/>
-          <p:cNvSpPr/>
-          <p:nvPr/>
-        </p:nvSpPr>
-        <p:spPr>
-          <a:xfrm>
-            <a:off x="4428744" y="2761488"/>
+          <p:cNvPr id="25" name="Text 23"/>
+          <p:cNvSpPr/>
+          <p:nvPr/>
+        </p:nvSpPr>
+        <p:spPr>
+          <a:xfrm>
+            <a:off x="4428744" y="2980944"/>
             <a:ext cx="3331464" cy="658368"/>
           </a:xfrm>
           <a:prstGeom prst="rect">
@@ -2943,13 +2982,13 @@
       </p:sp>
       <p:sp>
         <p:nvSpPr>
-          <p:cNvPr id="25" name="Text 23"/>
-          <p:cNvSpPr/>
-          <p:nvPr/>
-        </p:nvSpPr>
-        <p:spPr>
-          <a:xfrm>
-            <a:off x="4428744" y="3511296"/>
+          <p:cNvPr id="26" name="Text 24"/>
+          <p:cNvSpPr/>
+          <p:nvPr/>
+        </p:nvSpPr>
+        <p:spPr>
+          <a:xfrm>
+            <a:off x="4428744" y="3730752"/>
             <a:ext cx="3331464" cy="2194560"/>
           </a:xfrm>
           <a:prstGeom prst="rect">
@@ -2985,13 +3024,13 @@
       </p:sp>
       <p:sp>
         <p:nvSpPr>
-          <p:cNvPr id="26" name="Shape 24"/>
-          <p:cNvSpPr/>
-          <p:nvPr/>
-        </p:nvSpPr>
-        <p:spPr>
-          <a:xfrm>
-            <a:off x="4428744" y="4956048"/>
+          <p:cNvPr id="27" name="Shape 25"/>
+          <p:cNvSpPr/>
+          <p:nvPr/>
+        </p:nvSpPr>
+        <p:spPr>
+          <a:xfrm>
+            <a:off x="4428744" y="4992624"/>
             <a:ext cx="3331464" cy="237744"/>
           </a:xfrm>
           <a:prstGeom prst="roundRect">
@@ -3012,13 +3051,13 @@
       </p:sp>
       <p:sp>
         <p:nvSpPr>
-          <p:cNvPr id="27" name="Text 25"/>
-          <p:cNvSpPr/>
-          <p:nvPr/>
-        </p:nvSpPr>
-        <p:spPr>
-          <a:xfrm>
-            <a:off x="4428744" y="4956048"/>
+          <p:cNvPr id="28" name="Text 26"/>
+          <p:cNvSpPr/>
+          <p:nvPr/>
+        </p:nvSpPr>
+        <p:spPr>
+          <a:xfrm>
+            <a:off x="4428744" y="4992624"/>
             <a:ext cx="3331464" cy="237744"/>
           </a:xfrm>
           <a:prstGeom prst="rect">
@@ -3051,18 +3090,18 @@
       </p:sp>
       <p:sp>
         <p:nvSpPr>
-          <p:cNvPr id="28" name="Shape 26"/>
-          <p:cNvSpPr/>
-          <p:nvPr/>
-        </p:nvSpPr>
-        <p:spPr>
-          <a:xfrm>
-            <a:off x="8125968" y="2011680"/>
-            <a:ext cx="3697224" cy="3291840"/>
+          <p:cNvPr id="29" name="Shape 27"/>
+          <p:cNvSpPr/>
+          <p:nvPr/>
+        </p:nvSpPr>
+        <p:spPr>
+          <a:xfrm>
+            <a:off x="8125968" y="2231136"/>
+            <a:ext cx="3697224" cy="3108960"/>
           </a:xfrm>
           <a:prstGeom prst="roundRect">
             <a:avLst>
-              <a:gd name="adj" fmla="val 1944"/>
+              <a:gd name="adj" fmla="val 2059"/>
             </a:avLst>
           </a:prstGeom>
           <a:solidFill>
@@ -3078,13 +3117,13 @@
       </p:sp>
       <p:sp>
         <p:nvSpPr>
-          <p:cNvPr id="29" name="Shape 27"/>
-          <p:cNvSpPr/>
-          <p:nvPr/>
-        </p:nvSpPr>
-        <p:spPr>
-          <a:xfrm>
-            <a:off x="8125968" y="2011680"/>
+          <p:cNvPr id="30" name="Shape 28"/>
+          <p:cNvSpPr/>
+          <p:nvPr/>
+        </p:nvSpPr>
+        <p:spPr>
+          <a:xfrm>
+            <a:off x="8125968" y="2231136"/>
             <a:ext cx="3697224" cy="658368"/>
           </a:xfrm>
           <a:prstGeom prst="roundRect">
@@ -3105,13 +3144,13 @@
       </p:sp>
       <p:sp>
         <p:nvSpPr>
-          <p:cNvPr id="30" name="Shape 28"/>
-          <p:cNvSpPr/>
-          <p:nvPr/>
-        </p:nvSpPr>
-        <p:spPr>
-          <a:xfrm>
-            <a:off x="8125968" y="2487168"/>
+          <p:cNvPr id="31" name="Shape 29"/>
+          <p:cNvSpPr/>
+          <p:nvPr/>
+        </p:nvSpPr>
+        <p:spPr>
+          <a:xfrm>
+            <a:off x="8125968" y="2706624"/>
             <a:ext cx="3697224" cy="182880"/>
           </a:xfrm>
           <a:prstGeom prst="rect">
@@ -3130,13 +3169,13 @@
       </p:sp>
       <p:sp>
         <p:nvSpPr>
-          <p:cNvPr id="31" name="Shape 29"/>
-          <p:cNvSpPr/>
-          <p:nvPr/>
-        </p:nvSpPr>
-        <p:spPr>
-          <a:xfrm>
-            <a:off x="8308848" y="2103120"/>
+          <p:cNvPr id="32" name="Shape 30"/>
+          <p:cNvSpPr/>
+          <p:nvPr/>
+        </p:nvSpPr>
+        <p:spPr>
+          <a:xfrm>
+            <a:off x="8308848" y="2322576"/>
             <a:ext cx="384048" cy="384048"/>
           </a:xfrm>
           <a:prstGeom prst="ellipse">
@@ -3155,13 +3194,13 @@
       </p:sp>
       <p:sp>
         <p:nvSpPr>
-          <p:cNvPr id="32" name="Text 30"/>
-          <p:cNvSpPr/>
-          <p:nvPr/>
-        </p:nvSpPr>
-        <p:spPr>
-          <a:xfrm>
-            <a:off x="8308848" y="2103120"/>
+          <p:cNvPr id="33" name="Text 31"/>
+          <p:cNvSpPr/>
+          <p:nvPr/>
+        </p:nvSpPr>
+        <p:spPr>
+          <a:xfrm>
+            <a:off x="8308848" y="2322576"/>
             <a:ext cx="384048" cy="384048"/>
           </a:xfrm>
           <a:prstGeom prst="rect">
@@ -3194,13 +3233,13 @@
       </p:sp>
       <p:sp>
         <p:nvSpPr>
-          <p:cNvPr id="33" name="Text 31"/>
-          <p:cNvSpPr/>
-          <p:nvPr/>
-        </p:nvSpPr>
-        <p:spPr>
-          <a:xfrm>
-            <a:off x="8820912" y="2176272"/>
+          <p:cNvPr id="34" name="Text 32"/>
+          <p:cNvSpPr/>
+          <p:nvPr/>
+        </p:nvSpPr>
+        <p:spPr>
+          <a:xfrm>
+            <a:off x="8820912" y="2395728"/>
             <a:ext cx="2874264" cy="237744"/>
           </a:xfrm>
           <a:prstGeom prst="rect">
@@ -3233,13 +3272,13 @@
       </p:sp>
       <p:sp>
         <p:nvSpPr>
-          <p:cNvPr id="34" name="Shape 32"/>
-          <p:cNvSpPr/>
-          <p:nvPr/>
-        </p:nvSpPr>
-        <p:spPr>
-          <a:xfrm>
-            <a:off x="8308848" y="2670048"/>
+          <p:cNvPr id="35" name="Shape 33"/>
+          <p:cNvSpPr/>
+          <p:nvPr/>
+        </p:nvSpPr>
+        <p:spPr>
+          <a:xfrm>
+            <a:off x="8308848" y="2889504"/>
             <a:ext cx="3331464" cy="0"/>
           </a:xfrm>
           <a:prstGeom prst="line">
@@ -3256,13 +3295,13 @@
       </p:sp>
       <p:sp>
         <p:nvSpPr>
-          <p:cNvPr id="35" name="Text 33"/>
-          <p:cNvSpPr/>
-          <p:nvPr/>
-        </p:nvSpPr>
-        <p:spPr>
-          <a:xfrm>
-            <a:off x="8308848" y="2761488"/>
+          <p:cNvPr id="36" name="Text 34"/>
+          <p:cNvSpPr/>
+          <p:nvPr/>
+        </p:nvSpPr>
+        <p:spPr>
+          <a:xfrm>
+            <a:off x="8308848" y="2980944"/>
             <a:ext cx="3331464" cy="658368"/>
           </a:xfrm>
           <a:prstGeom prst="rect">
@@ -3312,13 +3351,13 @@
       </p:sp>
       <p:sp>
         <p:nvSpPr>
-          <p:cNvPr id="36" name="Text 34"/>
-          <p:cNvSpPr/>
-          <p:nvPr/>
-        </p:nvSpPr>
-        <p:spPr>
-          <a:xfrm>
-            <a:off x="8308848" y="3511296"/>
+          <p:cNvPr id="37" name="Text 35"/>
+          <p:cNvSpPr/>
+          <p:nvPr/>
+        </p:nvSpPr>
+        <p:spPr>
+          <a:xfrm>
+            <a:off x="8308848" y="3730752"/>
             <a:ext cx="3331464" cy="2194560"/>
           </a:xfrm>
           <a:prstGeom prst="rect">
@@ -3354,13 +3393,13 @@
       </p:sp>
       <p:sp>
         <p:nvSpPr>
-          <p:cNvPr id="37" name="Shape 35"/>
-          <p:cNvSpPr/>
-          <p:nvPr/>
-        </p:nvSpPr>
-        <p:spPr>
-          <a:xfrm>
-            <a:off x="8308848" y="4956048"/>
+          <p:cNvPr id="38" name="Shape 36"/>
+          <p:cNvSpPr/>
+          <p:nvPr/>
+        </p:nvSpPr>
+        <p:spPr>
+          <a:xfrm>
+            <a:off x="8308848" y="4992624"/>
             <a:ext cx="3331464" cy="237744"/>
           </a:xfrm>
           <a:prstGeom prst="roundRect">
@@ -3381,13 +3420,13 @@
       </p:sp>
       <p:sp>
         <p:nvSpPr>
-          <p:cNvPr id="38" name="Text 36"/>
-          <p:cNvSpPr/>
-          <p:nvPr/>
-        </p:nvSpPr>
-        <p:spPr>
-          <a:xfrm>
-            <a:off x="8308848" y="4956048"/>
+          <p:cNvPr id="39" name="Text 37"/>
+          <p:cNvSpPr/>
+          <p:nvPr/>
+        </p:nvSpPr>
+        <p:spPr>
+          <a:xfrm>
+            <a:off x="8308848" y="4992624"/>
             <a:ext cx="3331464" cy="237744"/>
           </a:xfrm>
           <a:prstGeom prst="rect">
@@ -3420,13 +3459,13 @@
       </p:sp>
       <p:sp>
         <p:nvSpPr>
-          <p:cNvPr id="39" name="Text 37"/>
-          <p:cNvSpPr/>
-          <p:nvPr/>
-        </p:nvSpPr>
-        <p:spPr>
-          <a:xfrm>
-            <a:off x="4081272" y="3493008"/>
+          <p:cNvPr id="40" name="Text 38"/>
+          <p:cNvSpPr/>
+          <p:nvPr/>
+        </p:nvSpPr>
+        <p:spPr>
+          <a:xfrm>
+            <a:off x="4081272" y="3621024"/>
             <a:ext cx="292608" cy="329184"/>
           </a:xfrm>
           <a:prstGeom prst="rect">
@@ -3459,13 +3498,13 @@
       </p:sp>
       <p:sp>
         <p:nvSpPr>
-          <p:cNvPr id="40" name="Text 38"/>
-          <p:cNvSpPr/>
-          <p:nvPr/>
-        </p:nvSpPr>
-        <p:spPr>
-          <a:xfrm>
-            <a:off x="7961376" y="3493008"/>
+          <p:cNvPr id="41" name="Text 39"/>
+          <p:cNvSpPr/>
+          <p:nvPr/>
+        </p:nvSpPr>
+        <p:spPr>
+          <a:xfrm>
+            <a:off x="7961376" y="3621024"/>
             <a:ext cx="292608" cy="329184"/>
           </a:xfrm>
           <a:prstGeom prst="rect">
@@ -3498,13 +3537,13 @@
       </p:sp>
       <p:sp>
         <p:nvSpPr>
-          <p:cNvPr id="41" name="Shape 39"/>
-          <p:cNvSpPr/>
-          <p:nvPr/>
-        </p:nvSpPr>
-        <p:spPr>
-          <a:xfrm>
-            <a:off x="365760" y="5468112"/>
+          <p:cNvPr id="42" name="Shape 40"/>
+          <p:cNvSpPr/>
+          <p:nvPr/>
+        </p:nvSpPr>
+        <p:spPr>
+          <a:xfrm>
+            <a:off x="365760" y="5504688"/>
             <a:ext cx="11457432" cy="475488"/>
           </a:xfrm>
           <a:prstGeom prst="roundRect">
@@ -3525,30 +3564,30 @@
       </p:sp>
       <p:sp>
         <p:nvSpPr>
-          <p:cNvPr id="42" name="Text 40"/>
-          <p:cNvSpPr/>
-          <p:nvPr/>
-        </p:nvSpPr>
-        <p:spPr>
-          <a:xfrm>
-            <a:off x="621792" y="5477256"/>
-            <a:ext cx="10945368" cy="457200"/>
-          </a:xfrm>
-          <a:prstGeom prst="rect">
-            <a:avLst/>
-          </a:prstGeom>
-          <a:noFill/>
-          <a:ln/>
-        </p:spPr>
-        <p:txBody>
-          <a:bodyPr wrap="square" rtlCol="0" anchor="ctr"/>
-          <a:lstStyle/>
-          <a:p>
-            <a:pPr indent="0" marL="0">
-              <a:buNone/>
-            </a:pPr>
-            <a:r>
-              <a:rPr lang="en-US" sz="950" i="1" dirty="0">
+          <p:cNvPr id="43" name="Text 41"/>
+          <p:cNvSpPr/>
+          <p:nvPr/>
+        </p:nvSpPr>
+        <p:spPr>
+          <a:xfrm>
+            <a:off x="621792" y="5522976"/>
+            <a:ext cx="10945368" cy="438912"/>
+          </a:xfrm>
+          <a:prstGeom prst="rect">
+            <a:avLst/>
+          </a:prstGeom>
+          <a:noFill/>
+          <a:ln/>
+        </p:spPr>
+        <p:txBody>
+          <a:bodyPr wrap="square" rtlCol="0" anchor="ctr"/>
+          <a:lstStyle/>
+          <a:p>
+            <a:pPr indent="0" marL="0">
+              <a:buNone/>
+            </a:pPr>
+            <a:r>
+              <a:rPr lang="en-US" sz="1150" i="1" dirty="0">
                 <a:solidFill>
                   <a:srgbClr val="C4AEED"/>
                 </a:solidFill>
@@ -3562,7 +3601,7 @@
               <a:buNone/>
             </a:pPr>
             <a:r>
-              <a:rPr lang="en-US" sz="950" i="1" dirty="0">
+              <a:rPr lang="en-US" sz="1150" i="1" dirty="0">
                 <a:solidFill>
                   <a:srgbClr val="FFFFFF"/>
                 </a:solidFill>
@@ -3576,7 +3615,7 @@
               <a:buNone/>
             </a:pPr>
             <a:r>
-              <a:rPr lang="en-US" sz="950" i="1" dirty="0">
+              <a:rPr lang="en-US" sz="1150" i="1" dirty="0">
                 <a:solidFill>
                   <a:srgbClr val="C4AEED"/>
                 </a:solidFill>
@@ -3590,7 +3629,7 @@
               <a:buNone/>
             </a:pPr>
             <a:r>
-              <a:rPr lang="en-US" sz="950" i="1" dirty="0">
+              <a:rPr lang="en-US" sz="1150" i="1" dirty="0">
                 <a:solidFill>
                   <a:srgbClr val="FFFFFF"/>
                 </a:solidFill>
@@ -3600,13 +3639,13 @@
               </a:rPr>
               <a:t>strategic capability that enables Asurion to move faster, reduce financial risk, and scale with confidence.</a:t>
             </a:r>
-            <a:endParaRPr lang="en-US" sz="950" dirty="0"/>
-          </a:p>
-        </p:txBody>
-      </p:sp>
-      <p:sp>
-        <p:nvSpPr>
-          <p:cNvPr id="43" name="Shape 41"/>
+            <a:endParaRPr lang="en-US" sz="1150" dirty="0"/>
+          </a:p>
+        </p:txBody>
+      </p:sp>
+      <p:sp>
+        <p:nvSpPr>
+          <p:cNvPr id="44" name="Shape 42"/>
           <p:cNvSpPr/>
           <p:nvPr/>
         </p:nvSpPr>
@@ -3629,7 +3668,7 @@
       </p:sp>
       <p:sp>
         <p:nvSpPr>
-          <p:cNvPr id="44" name="Text 42"/>
+          <p:cNvPr id="45" name="Text 43"/>
           <p:cNvSpPr/>
           <p:nvPr/>
         </p:nvSpPr>
@@ -3668,7 +3707,7 @@
       </p:sp>
       <p:sp>
         <p:nvSpPr>
-          <p:cNvPr id="45" name="Text 43"/>
+          <p:cNvPr id="46" name="Text 44"/>
           <p:cNvSpPr/>
           <p:nvPr/>
         </p:nvSpPr>
@@ -3707,7 +3746,7 @@
       </p:sp>
       <p:sp>
         <p:nvSpPr>
-          <p:cNvPr id="46" name="Text 44"/>
+          <p:cNvPr id="47" name="Text 45"/>
           <p:cNvSpPr/>
           <p:nvPr/>
         </p:nvSpPr>

</xml_diff>

<commit_message>
Replace hero bar with resonant statement, no numbers
Customer-facing framing: inventory runs unseen but customers feel
it when something goes wrong. Sets up the review emotionally before
the data and boxes arrive.

https://claude.ai/code/session_01KWybSEC2vfMTAERCxx1Z2W
</commit_message>
<xml_diff>
--- a/public/Inventory-at-Asurion.pptx
+++ b/public/Inventory-at-Asurion.pptx
@@ -2198,11 +2198,11 @@
         <p:spPr>
           <a:xfrm>
             <a:off x="365760" y="1207008"/>
-            <a:ext cx="11457432" cy="566928"/>
+            <a:ext cx="11457432" cy="694944"/>
           </a:xfrm>
           <a:prstGeom prst="roundRect">
             <a:avLst>
-              <a:gd name="adj" fmla="val 9677"/>
+              <a:gd name="adj" fmla="val 7895"/>
             </a:avLst>
           </a:prstGeom>
           <a:solidFill>
@@ -2225,7 +2225,7 @@
         <p:spPr>
           <a:xfrm>
             <a:off x="640080" y="1225296"/>
-            <a:ext cx="10908792" cy="493776"/>
+            <a:ext cx="10908792" cy="621792"/>
           </a:xfrm>
           <a:prstGeom prst="rect">
             <a:avLst/>
@@ -2249,63 +2249,7 @@
                 <a:ea typeface="Calibri" pitchFamily="34" charset="-122"/>
                 <a:cs typeface="Calibri" pitchFamily="34" charset="-120"/>
               </a:rPr>
-              <a:t>Inventory is a </a:t>
-            </a:r>
-            <a:pPr indent="0" marL="0">
-              <a:buNone/>
-            </a:pPr>
-            <a:r>
-              <a:rPr lang="en-US" sz="1300" b="1" dirty="0">
-                <a:solidFill>
-                  <a:srgbClr val="5B2C8D"/>
-                </a:solidFill>
-                <a:latin typeface="Calibri" pitchFamily="34" charset="0"/>
-                <a:ea typeface="Calibri" pitchFamily="34" charset="-122"/>
-                <a:cs typeface="Calibri" pitchFamily="34" charset="-120"/>
-              </a:rPr>
-              <a:t>~$609M asset</a:t>
-            </a:r>
-            <a:pPr indent="0" marL="0">
-              <a:buNone/>
-            </a:pPr>
-            <a:r>
-              <a:rPr lang="en-US" sz="1300" dirty="0">
-                <a:solidFill>
-                  <a:srgbClr val="333333"/>
-                </a:solidFill>
-                <a:latin typeface="Calibri" pitchFamily="34" charset="0"/>
-                <a:ea typeface="Calibri" pitchFamily="34" charset="-122"/>
-                <a:cs typeface="Calibri" pitchFamily="34" charset="-120"/>
-              </a:rPr>
-              <a:t> moving across </a:t>
-            </a:r>
-            <a:pPr indent="0" marL="0">
-              <a:buNone/>
-            </a:pPr>
-            <a:r>
-              <a:rPr lang="en-US" sz="1300" b="1" dirty="0">
-                <a:solidFill>
-                  <a:srgbClr val="5B2C8D"/>
-                </a:solidFill>
-                <a:latin typeface="Calibri" pitchFamily="34" charset="0"/>
-                <a:ea typeface="Calibri" pitchFamily="34" charset="-122"/>
-                <a:cs typeface="Calibri" pitchFamily="34" charset="-120"/>
-              </a:rPr>
-              <a:t>~890 locations</a:t>
-            </a:r>
-            <a:pPr indent="0" marL="0">
-              <a:buNone/>
-            </a:pPr>
-            <a:r>
-              <a:rPr lang="en-US" sz="1300" dirty="0">
-                <a:solidFill>
-                  <a:srgbClr val="333333"/>
-                </a:solidFill>
-                <a:latin typeface="Calibri" pitchFamily="34" charset="0"/>
-                <a:ea typeface="Calibri" pitchFamily="34" charset="-122"/>
-                <a:cs typeface="Calibri" pitchFamily="34" charset="-120"/>
-              </a:rPr>
-              <a:t> every day — powering every service motion Asurion runs.</a:t>
+              <a:t>Inventory is the foundation every service program runs on. It runs behind the scenes, unseen — but customers always feel it when something goes wrong. Inventory makes the service promise possible. This review is about making sure we can always keep it.</a:t>
             </a:r>
             <a:endParaRPr lang="en-US" sz="1300" dirty="0"/>
           </a:p>
@@ -2319,7 +2263,7 @@
         </p:nvSpPr>
         <p:spPr>
           <a:xfrm>
-            <a:off x="365760" y="1883664"/>
+            <a:off x="365760" y="2011680"/>
             <a:ext cx="11457432" cy="274320"/>
           </a:xfrm>
           <a:prstGeom prst="rect">
@@ -2358,7 +2302,7 @@
         </p:nvSpPr>
         <p:spPr>
           <a:xfrm>
-            <a:off x="365760" y="2231136"/>
+            <a:off x="365760" y="2359152"/>
             <a:ext cx="3697224" cy="3108960"/>
           </a:xfrm>
           <a:prstGeom prst="roundRect">
@@ -2385,7 +2329,7 @@
         </p:nvSpPr>
         <p:spPr>
           <a:xfrm>
-            <a:off x="365760" y="2231136"/>
+            <a:off x="365760" y="2359152"/>
             <a:ext cx="3697224" cy="658368"/>
           </a:xfrm>
           <a:prstGeom prst="roundRect">
@@ -2412,7 +2356,7 @@
         </p:nvSpPr>
         <p:spPr>
           <a:xfrm>
-            <a:off x="365760" y="2706624"/>
+            <a:off x="365760" y="2834640"/>
             <a:ext cx="3697224" cy="182880"/>
           </a:xfrm>
           <a:prstGeom prst="rect">
@@ -2437,7 +2381,7 @@
         </p:nvSpPr>
         <p:spPr>
           <a:xfrm>
-            <a:off x="548640" y="2322576"/>
+            <a:off x="548640" y="2450592"/>
             <a:ext cx="384048" cy="384048"/>
           </a:xfrm>
           <a:prstGeom prst="ellipse">
@@ -2462,7 +2406,7 @@
         </p:nvSpPr>
         <p:spPr>
           <a:xfrm>
-            <a:off x="548640" y="2322576"/>
+            <a:off x="548640" y="2450592"/>
             <a:ext cx="384048" cy="384048"/>
           </a:xfrm>
           <a:prstGeom prst="rect">
@@ -2501,7 +2445,7 @@
         </p:nvSpPr>
         <p:spPr>
           <a:xfrm>
-            <a:off x="1060704" y="2395728"/>
+            <a:off x="1060704" y="2523744"/>
             <a:ext cx="2874264" cy="237744"/>
           </a:xfrm>
           <a:prstGeom prst="rect">
@@ -2540,7 +2484,7 @@
         </p:nvSpPr>
         <p:spPr>
           <a:xfrm>
-            <a:off x="548640" y="2889504"/>
+            <a:off x="548640" y="3017520"/>
             <a:ext cx="3331464" cy="0"/>
           </a:xfrm>
           <a:prstGeom prst="line">
@@ -2563,7 +2507,7 @@
         </p:nvSpPr>
         <p:spPr>
           <a:xfrm>
-            <a:off x="548640" y="2980944"/>
+            <a:off x="548640" y="3108960"/>
             <a:ext cx="3331464" cy="658368"/>
           </a:xfrm>
           <a:prstGeom prst="rect">
@@ -2619,7 +2563,7 @@
         </p:nvSpPr>
         <p:spPr>
           <a:xfrm>
-            <a:off x="548640" y="3730752"/>
+            <a:off x="548640" y="3858768"/>
             <a:ext cx="3331464" cy="2194560"/>
           </a:xfrm>
           <a:prstGeom prst="rect">
@@ -2661,7 +2605,7 @@
         </p:nvSpPr>
         <p:spPr>
           <a:xfrm>
-            <a:off x="548640" y="4992624"/>
+            <a:off x="548640" y="5120640"/>
             <a:ext cx="3331464" cy="237744"/>
           </a:xfrm>
           <a:prstGeom prst="roundRect">
@@ -2688,7 +2632,7 @@
         </p:nvSpPr>
         <p:spPr>
           <a:xfrm>
-            <a:off x="548640" y="4992624"/>
+            <a:off x="548640" y="5120640"/>
             <a:ext cx="3331464" cy="237744"/>
           </a:xfrm>
           <a:prstGeom prst="rect">
@@ -2727,7 +2671,7 @@
         </p:nvSpPr>
         <p:spPr>
           <a:xfrm>
-            <a:off x="4245864" y="2231136"/>
+            <a:off x="4245864" y="2359152"/>
             <a:ext cx="3697224" cy="3108960"/>
           </a:xfrm>
           <a:prstGeom prst="roundRect">
@@ -2754,7 +2698,7 @@
         </p:nvSpPr>
         <p:spPr>
           <a:xfrm>
-            <a:off x="4245864" y="2231136"/>
+            <a:off x="4245864" y="2359152"/>
             <a:ext cx="3697224" cy="658368"/>
           </a:xfrm>
           <a:prstGeom prst="roundRect">
@@ -2781,7 +2725,7 @@
         </p:nvSpPr>
         <p:spPr>
           <a:xfrm>
-            <a:off x="4245864" y="2706624"/>
+            <a:off x="4245864" y="2834640"/>
             <a:ext cx="3697224" cy="182880"/>
           </a:xfrm>
           <a:prstGeom prst="rect">
@@ -2806,7 +2750,7 @@
         </p:nvSpPr>
         <p:spPr>
           <a:xfrm>
-            <a:off x="4428744" y="2322576"/>
+            <a:off x="4428744" y="2450592"/>
             <a:ext cx="384048" cy="384048"/>
           </a:xfrm>
           <a:prstGeom prst="ellipse">
@@ -2831,7 +2775,7 @@
         </p:nvSpPr>
         <p:spPr>
           <a:xfrm>
-            <a:off x="4428744" y="2322576"/>
+            <a:off x="4428744" y="2450592"/>
             <a:ext cx="384048" cy="384048"/>
           </a:xfrm>
           <a:prstGeom prst="rect">
@@ -2870,7 +2814,7 @@
         </p:nvSpPr>
         <p:spPr>
           <a:xfrm>
-            <a:off x="4940808" y="2395728"/>
+            <a:off x="4940808" y="2523744"/>
             <a:ext cx="2874264" cy="237744"/>
           </a:xfrm>
           <a:prstGeom prst="rect">
@@ -2909,7 +2853,7 @@
         </p:nvSpPr>
         <p:spPr>
           <a:xfrm>
-            <a:off x="4428744" y="2889504"/>
+            <a:off x="4428744" y="3017520"/>
             <a:ext cx="3331464" cy="0"/>
           </a:xfrm>
           <a:prstGeom prst="line">
@@ -2932,7 +2876,7 @@
         </p:nvSpPr>
         <p:spPr>
           <a:xfrm>
-            <a:off x="4428744" y="2980944"/>
+            <a:off x="4428744" y="3108960"/>
             <a:ext cx="3331464" cy="658368"/>
           </a:xfrm>
           <a:prstGeom prst="rect">
@@ -2988,7 +2932,7 @@
         </p:nvSpPr>
         <p:spPr>
           <a:xfrm>
-            <a:off x="4428744" y="3730752"/>
+            <a:off x="4428744" y="3858768"/>
             <a:ext cx="3331464" cy="2194560"/>
           </a:xfrm>
           <a:prstGeom prst="rect">
@@ -3030,7 +2974,7 @@
         </p:nvSpPr>
         <p:spPr>
           <a:xfrm>
-            <a:off x="4428744" y="4992624"/>
+            <a:off x="4428744" y="5120640"/>
             <a:ext cx="3331464" cy="237744"/>
           </a:xfrm>
           <a:prstGeom prst="roundRect">
@@ -3057,7 +3001,7 @@
         </p:nvSpPr>
         <p:spPr>
           <a:xfrm>
-            <a:off x="4428744" y="4992624"/>
+            <a:off x="4428744" y="5120640"/>
             <a:ext cx="3331464" cy="237744"/>
           </a:xfrm>
           <a:prstGeom prst="rect">
@@ -3096,7 +3040,7 @@
         </p:nvSpPr>
         <p:spPr>
           <a:xfrm>
-            <a:off x="8125968" y="2231136"/>
+            <a:off x="8125968" y="2359152"/>
             <a:ext cx="3697224" cy="3108960"/>
           </a:xfrm>
           <a:prstGeom prst="roundRect">
@@ -3123,7 +3067,7 @@
         </p:nvSpPr>
         <p:spPr>
           <a:xfrm>
-            <a:off x="8125968" y="2231136"/>
+            <a:off x="8125968" y="2359152"/>
             <a:ext cx="3697224" cy="658368"/>
           </a:xfrm>
           <a:prstGeom prst="roundRect">
@@ -3150,7 +3094,7 @@
         </p:nvSpPr>
         <p:spPr>
           <a:xfrm>
-            <a:off x="8125968" y="2706624"/>
+            <a:off x="8125968" y="2834640"/>
             <a:ext cx="3697224" cy="182880"/>
           </a:xfrm>
           <a:prstGeom prst="rect">
@@ -3175,7 +3119,7 @@
         </p:nvSpPr>
         <p:spPr>
           <a:xfrm>
-            <a:off x="8308848" y="2322576"/>
+            <a:off x="8308848" y="2450592"/>
             <a:ext cx="384048" cy="384048"/>
           </a:xfrm>
           <a:prstGeom prst="ellipse">
@@ -3200,7 +3144,7 @@
         </p:nvSpPr>
         <p:spPr>
           <a:xfrm>
-            <a:off x="8308848" y="2322576"/>
+            <a:off x="8308848" y="2450592"/>
             <a:ext cx="384048" cy="384048"/>
           </a:xfrm>
           <a:prstGeom prst="rect">
@@ -3239,7 +3183,7 @@
         </p:nvSpPr>
         <p:spPr>
           <a:xfrm>
-            <a:off x="8820912" y="2395728"/>
+            <a:off x="8820912" y="2523744"/>
             <a:ext cx="2874264" cy="237744"/>
           </a:xfrm>
           <a:prstGeom prst="rect">
@@ -3278,7 +3222,7 @@
         </p:nvSpPr>
         <p:spPr>
           <a:xfrm>
-            <a:off x="8308848" y="2889504"/>
+            <a:off x="8308848" y="3017520"/>
             <a:ext cx="3331464" cy="0"/>
           </a:xfrm>
           <a:prstGeom prst="line">
@@ -3301,7 +3245,7 @@
         </p:nvSpPr>
         <p:spPr>
           <a:xfrm>
-            <a:off x="8308848" y="2980944"/>
+            <a:off x="8308848" y="3108960"/>
             <a:ext cx="3331464" cy="658368"/>
           </a:xfrm>
           <a:prstGeom prst="rect">
@@ -3357,7 +3301,7 @@
         </p:nvSpPr>
         <p:spPr>
           <a:xfrm>
-            <a:off x="8308848" y="3730752"/>
+            <a:off x="8308848" y="3858768"/>
             <a:ext cx="3331464" cy="2194560"/>
           </a:xfrm>
           <a:prstGeom prst="rect">
@@ -3399,7 +3343,7 @@
         </p:nvSpPr>
         <p:spPr>
           <a:xfrm>
-            <a:off x="8308848" y="4992624"/>
+            <a:off x="8308848" y="5120640"/>
             <a:ext cx="3331464" cy="237744"/>
           </a:xfrm>
           <a:prstGeom prst="roundRect">
@@ -3426,7 +3370,7 @@
         </p:nvSpPr>
         <p:spPr>
           <a:xfrm>
-            <a:off x="8308848" y="4992624"/>
+            <a:off x="8308848" y="5120640"/>
             <a:ext cx="3331464" cy="237744"/>
           </a:xfrm>
           <a:prstGeom prst="rect">
@@ -3465,7 +3409,7 @@
         </p:nvSpPr>
         <p:spPr>
           <a:xfrm>
-            <a:off x="4081272" y="3621024"/>
+            <a:off x="4081272" y="3749040"/>
             <a:ext cx="292608" cy="329184"/>
           </a:xfrm>
           <a:prstGeom prst="rect">
@@ -3504,7 +3448,7 @@
         </p:nvSpPr>
         <p:spPr>
           <a:xfrm>
-            <a:off x="7961376" y="3621024"/>
+            <a:off x="7961376" y="3749040"/>
             <a:ext cx="292608" cy="329184"/>
           </a:xfrm>
           <a:prstGeom prst="rect">
@@ -3543,7 +3487,7 @@
         </p:nvSpPr>
         <p:spPr>
           <a:xfrm>
-            <a:off x="365760" y="5504688"/>
+            <a:off x="365760" y="5632704"/>
             <a:ext cx="11457432" cy="475488"/>
           </a:xfrm>
           <a:prstGeom prst="roundRect">
@@ -3570,7 +3514,7 @@
         </p:nvSpPr>
         <p:spPr>
           <a:xfrm>
-            <a:off x="621792" y="5522976"/>
+            <a:off x="621792" y="5650992"/>
             <a:ext cx="10945368" cy="438912"/>
           </a:xfrm>
           <a:prstGeom prst="rect">

</xml_diff>

<commit_message>
Break hero statement into 4 talking-point lines
Each sentence stands alone with a purple dash prefix — easier
for a presenter to walk through and more digestible for leadership.

https://claude.ai/code/session_01KWybSEC2vfMTAERCxx1Z2W
</commit_message>
<xml_diff>
--- a/public/Inventory-at-Asurion.pptx
+++ b/public/Inventory-at-Asurion.pptx
@@ -2198,11 +2198,11 @@
         <p:spPr>
           <a:xfrm>
             <a:off x="365760" y="1207008"/>
-            <a:ext cx="11457432" cy="694944"/>
+            <a:ext cx="11457432" cy="1005840"/>
           </a:xfrm>
           <a:prstGeom prst="roundRect">
             <a:avLst>
-              <a:gd name="adj" fmla="val 7895"/>
+              <a:gd name="adj" fmla="val 5455"/>
             </a:avLst>
           </a:prstGeom>
           <a:solidFill>
@@ -2224,24 +2224,44 @@
         </p:nvSpPr>
         <p:spPr>
           <a:xfrm>
-            <a:off x="640080" y="1225296"/>
-            <a:ext cx="10908792" cy="621792"/>
-          </a:xfrm>
-          <a:prstGeom prst="rect">
-            <a:avLst/>
-          </a:prstGeom>
-          <a:noFill/>
-          <a:ln/>
-        </p:spPr>
-        <p:txBody>
-          <a:bodyPr wrap="square" rtlCol="0" anchor="ctr"/>
-          <a:lstStyle/>
-          <a:p>
-            <a:pPr indent="0" marL="0">
-              <a:buNone/>
-            </a:pPr>
-            <a:r>
-              <a:rPr lang="en-US" sz="1300" dirty="0">
+            <a:off x="640080" y="1243584"/>
+            <a:ext cx="10908792" cy="914400"/>
+          </a:xfrm>
+          <a:prstGeom prst="rect">
+            <a:avLst/>
+          </a:prstGeom>
+          <a:noFill/>
+          <a:ln/>
+        </p:spPr>
+        <p:txBody>
+          <a:bodyPr wrap="square" rtlCol="0" anchor="ctr"/>
+          <a:lstStyle/>
+          <a:p>
+            <a:pPr indent="0" marL="0">
+              <a:spcAft>
+                <a:spcPts val="400"/>
+              </a:spcAft>
+              <a:buNone/>
+            </a:pPr>
+            <a:r>
+              <a:rPr lang="en-US" sz="1150" b="1" dirty="0">
+                <a:solidFill>
+                  <a:srgbClr val="5B2C8D"/>
+                </a:solidFill>
+                <a:latin typeface="Calibri" pitchFamily="34" charset="0"/>
+                <a:ea typeface="Calibri" pitchFamily="34" charset="-122"/>
+                <a:cs typeface="Calibri" pitchFamily="34" charset="-120"/>
+              </a:rPr>
+              <a:t>—</a:t>
+            </a:r>
+            <a:pPr indent="0" marL="0">
+              <a:spcAft>
+                <a:spcPts val="400"/>
+              </a:spcAft>
+              <a:buNone/>
+            </a:pPr>
+            <a:r>
+              <a:rPr lang="en-US" sz="1150" dirty="0">
                 <a:solidFill>
                   <a:srgbClr val="333333"/>
                 </a:solidFill>
@@ -2249,9 +2269,114 @@
                 <a:ea typeface="Calibri" pitchFamily="34" charset="-122"/>
                 <a:cs typeface="Calibri" pitchFamily="34" charset="-120"/>
               </a:rPr>
-              <a:t>Inventory is the foundation every service program runs on. It runs behind the scenes, unseen — but customers always feel it when something goes wrong. Inventory makes the service promise possible. This review is about making sure we can always keep it.</a:t>
-            </a:r>
-            <a:endParaRPr lang="en-US" sz="1300" dirty="0"/>
+              <a:t>  Inventory is the foundation every service program runs on.
+</a:t>
+            </a:r>
+            <a:pPr indent="0" marL="0">
+              <a:spcAft>
+                <a:spcPts val="400"/>
+              </a:spcAft>
+              <a:buNone/>
+            </a:pPr>
+            <a:r>
+              <a:rPr lang="en-US" sz="1150" b="1" dirty="0">
+                <a:solidFill>
+                  <a:srgbClr val="5B2C8D"/>
+                </a:solidFill>
+                <a:latin typeface="Calibri" pitchFamily="34" charset="0"/>
+                <a:ea typeface="Calibri" pitchFamily="34" charset="-122"/>
+                <a:cs typeface="Calibri" pitchFamily="34" charset="-120"/>
+              </a:rPr>
+              <a:t>—</a:t>
+            </a:r>
+            <a:pPr indent="0" marL="0">
+              <a:spcAft>
+                <a:spcPts val="400"/>
+              </a:spcAft>
+              <a:buNone/>
+            </a:pPr>
+            <a:r>
+              <a:rPr lang="en-US" sz="1150" dirty="0">
+                <a:solidFill>
+                  <a:srgbClr val="333333"/>
+                </a:solidFill>
+                <a:latin typeface="Calibri" pitchFamily="34" charset="0"/>
+                <a:ea typeface="Calibri" pitchFamily="34" charset="-122"/>
+                <a:cs typeface="Calibri" pitchFamily="34" charset="-120"/>
+              </a:rPr>
+              <a:t>  It runs behind the scenes, unseen — but customers always feel it when something goes wrong.
+</a:t>
+            </a:r>
+            <a:pPr indent="0" marL="0">
+              <a:spcAft>
+                <a:spcPts val="400"/>
+              </a:spcAft>
+              <a:buNone/>
+            </a:pPr>
+            <a:r>
+              <a:rPr lang="en-US" sz="1150" b="1" dirty="0">
+                <a:solidFill>
+                  <a:srgbClr val="5B2C8D"/>
+                </a:solidFill>
+                <a:latin typeface="Calibri" pitchFamily="34" charset="0"/>
+                <a:ea typeface="Calibri" pitchFamily="34" charset="-122"/>
+                <a:cs typeface="Calibri" pitchFamily="34" charset="-120"/>
+              </a:rPr>
+              <a:t>—</a:t>
+            </a:r>
+            <a:pPr indent="0" marL="0">
+              <a:spcAft>
+                <a:spcPts val="400"/>
+              </a:spcAft>
+              <a:buNone/>
+            </a:pPr>
+            <a:r>
+              <a:rPr lang="en-US" sz="1150" dirty="0">
+                <a:solidFill>
+                  <a:srgbClr val="333333"/>
+                </a:solidFill>
+                <a:latin typeface="Calibri" pitchFamily="34" charset="0"/>
+                <a:ea typeface="Calibri" pitchFamily="34" charset="-122"/>
+                <a:cs typeface="Calibri" pitchFamily="34" charset="-120"/>
+              </a:rPr>
+              <a:t>  Inventory makes the service promise possible.
+</a:t>
+            </a:r>
+            <a:pPr indent="0" marL="0">
+              <a:spcAft>
+                <a:spcPts val="400"/>
+              </a:spcAft>
+              <a:buNone/>
+            </a:pPr>
+            <a:r>
+              <a:rPr lang="en-US" sz="1150" b="1" dirty="0">
+                <a:solidFill>
+                  <a:srgbClr val="5B2C8D"/>
+                </a:solidFill>
+                <a:latin typeface="Calibri" pitchFamily="34" charset="0"/>
+                <a:ea typeface="Calibri" pitchFamily="34" charset="-122"/>
+                <a:cs typeface="Calibri" pitchFamily="34" charset="-120"/>
+              </a:rPr>
+              <a:t>—</a:t>
+            </a:r>
+            <a:pPr indent="0" marL="0">
+              <a:spcAft>
+                <a:spcPts val="400"/>
+              </a:spcAft>
+              <a:buNone/>
+            </a:pPr>
+            <a:r>
+              <a:rPr lang="en-US" sz="1150" dirty="0">
+                <a:solidFill>
+                  <a:srgbClr val="333333"/>
+                </a:solidFill>
+                <a:latin typeface="Calibri" pitchFamily="34" charset="0"/>
+                <a:ea typeface="Calibri" pitchFamily="34" charset="-122"/>
+                <a:cs typeface="Calibri" pitchFamily="34" charset="-120"/>
+              </a:rPr>
+              <a:t>  This review is about making sure we can always keep it.</a:t>
+            </a:r>
+            <a:endParaRPr lang="en-US" sz="1150" dirty="0"/>
           </a:p>
         </p:txBody>
       </p:sp>
@@ -2263,7 +2388,7 @@
         </p:nvSpPr>
         <p:spPr>
           <a:xfrm>
-            <a:off x="365760" y="2011680"/>
+            <a:off x="365760" y="2322576"/>
             <a:ext cx="11457432" cy="274320"/>
           </a:xfrm>
           <a:prstGeom prst="rect">
@@ -2302,12 +2427,12 @@
         </p:nvSpPr>
         <p:spPr>
           <a:xfrm>
-            <a:off x="365760" y="2359152"/>
-            <a:ext cx="3697224" cy="3108960"/>
+            <a:off x="365760" y="2670048"/>
+            <a:ext cx="3697224" cy="2743200"/>
           </a:xfrm>
           <a:prstGeom prst="roundRect">
             <a:avLst>
-              <a:gd name="adj" fmla="val 2059"/>
+              <a:gd name="adj" fmla="val 2333"/>
             </a:avLst>
           </a:prstGeom>
           <a:solidFill>
@@ -2329,7 +2454,7 @@
         </p:nvSpPr>
         <p:spPr>
           <a:xfrm>
-            <a:off x="365760" y="2359152"/>
+            <a:off x="365760" y="2670048"/>
             <a:ext cx="3697224" cy="658368"/>
           </a:xfrm>
           <a:prstGeom prst="roundRect">
@@ -2356,7 +2481,7 @@
         </p:nvSpPr>
         <p:spPr>
           <a:xfrm>
-            <a:off x="365760" y="2834640"/>
+            <a:off x="365760" y="3145536"/>
             <a:ext cx="3697224" cy="182880"/>
           </a:xfrm>
           <a:prstGeom prst="rect">
@@ -2381,7 +2506,7 @@
         </p:nvSpPr>
         <p:spPr>
           <a:xfrm>
-            <a:off x="548640" y="2450592"/>
+            <a:off x="548640" y="2761488"/>
             <a:ext cx="384048" cy="384048"/>
           </a:xfrm>
           <a:prstGeom prst="ellipse">
@@ -2406,7 +2531,7 @@
         </p:nvSpPr>
         <p:spPr>
           <a:xfrm>
-            <a:off x="548640" y="2450592"/>
+            <a:off x="548640" y="2761488"/>
             <a:ext cx="384048" cy="384048"/>
           </a:xfrm>
           <a:prstGeom prst="rect">
@@ -2445,7 +2570,7 @@
         </p:nvSpPr>
         <p:spPr>
           <a:xfrm>
-            <a:off x="1060704" y="2523744"/>
+            <a:off x="1060704" y="2834640"/>
             <a:ext cx="2874264" cy="237744"/>
           </a:xfrm>
           <a:prstGeom prst="rect">
@@ -2484,7 +2609,7 @@
         </p:nvSpPr>
         <p:spPr>
           <a:xfrm>
-            <a:off x="548640" y="3017520"/>
+            <a:off x="548640" y="3328416"/>
             <a:ext cx="3331464" cy="0"/>
           </a:xfrm>
           <a:prstGeom prst="line">
@@ -2507,7 +2632,7 @@
         </p:nvSpPr>
         <p:spPr>
           <a:xfrm>
-            <a:off x="548640" y="3108960"/>
+            <a:off x="548640" y="3419856"/>
             <a:ext cx="3331464" cy="658368"/>
           </a:xfrm>
           <a:prstGeom prst="rect">
@@ -2563,7 +2688,7 @@
         </p:nvSpPr>
         <p:spPr>
           <a:xfrm>
-            <a:off x="548640" y="3858768"/>
+            <a:off x="548640" y="4169664"/>
             <a:ext cx="3331464" cy="2194560"/>
           </a:xfrm>
           <a:prstGeom prst="rect">
@@ -2605,7 +2730,7 @@
         </p:nvSpPr>
         <p:spPr>
           <a:xfrm>
-            <a:off x="548640" y="5120640"/>
+            <a:off x="548640" y="5065776"/>
             <a:ext cx="3331464" cy="237744"/>
           </a:xfrm>
           <a:prstGeom prst="roundRect">
@@ -2632,7 +2757,7 @@
         </p:nvSpPr>
         <p:spPr>
           <a:xfrm>
-            <a:off x="548640" y="5120640"/>
+            <a:off x="548640" y="5065776"/>
             <a:ext cx="3331464" cy="237744"/>
           </a:xfrm>
           <a:prstGeom prst="rect">
@@ -2671,12 +2796,12 @@
         </p:nvSpPr>
         <p:spPr>
           <a:xfrm>
-            <a:off x="4245864" y="2359152"/>
-            <a:ext cx="3697224" cy="3108960"/>
+            <a:off x="4245864" y="2670048"/>
+            <a:ext cx="3697224" cy="2743200"/>
           </a:xfrm>
           <a:prstGeom prst="roundRect">
             <a:avLst>
-              <a:gd name="adj" fmla="val 2059"/>
+              <a:gd name="adj" fmla="val 2333"/>
             </a:avLst>
           </a:prstGeom>
           <a:solidFill>
@@ -2698,7 +2823,7 @@
         </p:nvSpPr>
         <p:spPr>
           <a:xfrm>
-            <a:off x="4245864" y="2359152"/>
+            <a:off x="4245864" y="2670048"/>
             <a:ext cx="3697224" cy="658368"/>
           </a:xfrm>
           <a:prstGeom prst="roundRect">
@@ -2725,7 +2850,7 @@
         </p:nvSpPr>
         <p:spPr>
           <a:xfrm>
-            <a:off x="4245864" y="2834640"/>
+            <a:off x="4245864" y="3145536"/>
             <a:ext cx="3697224" cy="182880"/>
           </a:xfrm>
           <a:prstGeom prst="rect">
@@ -2750,7 +2875,7 @@
         </p:nvSpPr>
         <p:spPr>
           <a:xfrm>
-            <a:off x="4428744" y="2450592"/>
+            <a:off x="4428744" y="2761488"/>
             <a:ext cx="384048" cy="384048"/>
           </a:xfrm>
           <a:prstGeom prst="ellipse">
@@ -2775,7 +2900,7 @@
         </p:nvSpPr>
         <p:spPr>
           <a:xfrm>
-            <a:off x="4428744" y="2450592"/>
+            <a:off x="4428744" y="2761488"/>
             <a:ext cx="384048" cy="384048"/>
           </a:xfrm>
           <a:prstGeom prst="rect">
@@ -2814,7 +2939,7 @@
         </p:nvSpPr>
         <p:spPr>
           <a:xfrm>
-            <a:off x="4940808" y="2523744"/>
+            <a:off x="4940808" y="2834640"/>
             <a:ext cx="2874264" cy="237744"/>
           </a:xfrm>
           <a:prstGeom prst="rect">
@@ -2853,7 +2978,7 @@
         </p:nvSpPr>
         <p:spPr>
           <a:xfrm>
-            <a:off x="4428744" y="3017520"/>
+            <a:off x="4428744" y="3328416"/>
             <a:ext cx="3331464" cy="0"/>
           </a:xfrm>
           <a:prstGeom prst="line">
@@ -2876,7 +3001,7 @@
         </p:nvSpPr>
         <p:spPr>
           <a:xfrm>
-            <a:off x="4428744" y="3108960"/>
+            <a:off x="4428744" y="3419856"/>
             <a:ext cx="3331464" cy="658368"/>
           </a:xfrm>
           <a:prstGeom prst="rect">
@@ -2932,7 +3057,7 @@
         </p:nvSpPr>
         <p:spPr>
           <a:xfrm>
-            <a:off x="4428744" y="3858768"/>
+            <a:off x="4428744" y="4169664"/>
             <a:ext cx="3331464" cy="2194560"/>
           </a:xfrm>
           <a:prstGeom prst="rect">
@@ -2974,7 +3099,7 @@
         </p:nvSpPr>
         <p:spPr>
           <a:xfrm>
-            <a:off x="4428744" y="5120640"/>
+            <a:off x="4428744" y="5065776"/>
             <a:ext cx="3331464" cy="237744"/>
           </a:xfrm>
           <a:prstGeom prst="roundRect">
@@ -3001,7 +3126,7 @@
         </p:nvSpPr>
         <p:spPr>
           <a:xfrm>
-            <a:off x="4428744" y="5120640"/>
+            <a:off x="4428744" y="5065776"/>
             <a:ext cx="3331464" cy="237744"/>
           </a:xfrm>
           <a:prstGeom prst="rect">
@@ -3040,12 +3165,12 @@
         </p:nvSpPr>
         <p:spPr>
           <a:xfrm>
-            <a:off x="8125968" y="2359152"/>
-            <a:ext cx="3697224" cy="3108960"/>
+            <a:off x="8125968" y="2670048"/>
+            <a:ext cx="3697224" cy="2743200"/>
           </a:xfrm>
           <a:prstGeom prst="roundRect">
             <a:avLst>
-              <a:gd name="adj" fmla="val 2059"/>
+              <a:gd name="adj" fmla="val 2333"/>
             </a:avLst>
           </a:prstGeom>
           <a:solidFill>
@@ -3067,7 +3192,7 @@
         </p:nvSpPr>
         <p:spPr>
           <a:xfrm>
-            <a:off x="8125968" y="2359152"/>
+            <a:off x="8125968" y="2670048"/>
             <a:ext cx="3697224" cy="658368"/>
           </a:xfrm>
           <a:prstGeom prst="roundRect">
@@ -3094,7 +3219,7 @@
         </p:nvSpPr>
         <p:spPr>
           <a:xfrm>
-            <a:off x="8125968" y="2834640"/>
+            <a:off x="8125968" y="3145536"/>
             <a:ext cx="3697224" cy="182880"/>
           </a:xfrm>
           <a:prstGeom prst="rect">
@@ -3119,7 +3244,7 @@
         </p:nvSpPr>
         <p:spPr>
           <a:xfrm>
-            <a:off x="8308848" y="2450592"/>
+            <a:off x="8308848" y="2761488"/>
             <a:ext cx="384048" cy="384048"/>
           </a:xfrm>
           <a:prstGeom prst="ellipse">
@@ -3144,7 +3269,7 @@
         </p:nvSpPr>
         <p:spPr>
           <a:xfrm>
-            <a:off x="8308848" y="2450592"/>
+            <a:off x="8308848" y="2761488"/>
             <a:ext cx="384048" cy="384048"/>
           </a:xfrm>
           <a:prstGeom prst="rect">
@@ -3183,7 +3308,7 @@
         </p:nvSpPr>
         <p:spPr>
           <a:xfrm>
-            <a:off x="8820912" y="2523744"/>
+            <a:off x="8820912" y="2834640"/>
             <a:ext cx="2874264" cy="237744"/>
           </a:xfrm>
           <a:prstGeom prst="rect">
@@ -3222,7 +3347,7 @@
         </p:nvSpPr>
         <p:spPr>
           <a:xfrm>
-            <a:off x="8308848" y="3017520"/>
+            <a:off x="8308848" y="3328416"/>
             <a:ext cx="3331464" cy="0"/>
           </a:xfrm>
           <a:prstGeom prst="line">
@@ -3245,7 +3370,7 @@
         </p:nvSpPr>
         <p:spPr>
           <a:xfrm>
-            <a:off x="8308848" y="3108960"/>
+            <a:off x="8308848" y="3419856"/>
             <a:ext cx="3331464" cy="658368"/>
           </a:xfrm>
           <a:prstGeom prst="rect">
@@ -3301,7 +3426,7 @@
         </p:nvSpPr>
         <p:spPr>
           <a:xfrm>
-            <a:off x="8308848" y="3858768"/>
+            <a:off x="8308848" y="4169664"/>
             <a:ext cx="3331464" cy="2194560"/>
           </a:xfrm>
           <a:prstGeom prst="rect">
@@ -3343,7 +3468,7 @@
         </p:nvSpPr>
         <p:spPr>
           <a:xfrm>
-            <a:off x="8308848" y="5120640"/>
+            <a:off x="8308848" y="5065776"/>
             <a:ext cx="3331464" cy="237744"/>
           </a:xfrm>
           <a:prstGeom prst="roundRect">
@@ -3370,7 +3495,7 @@
         </p:nvSpPr>
         <p:spPr>
           <a:xfrm>
-            <a:off x="8308848" y="5120640"/>
+            <a:off x="8308848" y="5065776"/>
             <a:ext cx="3331464" cy="237744"/>
           </a:xfrm>
           <a:prstGeom prst="rect">
@@ -3409,7 +3534,7 @@
         </p:nvSpPr>
         <p:spPr>
           <a:xfrm>
-            <a:off x="4081272" y="3749040"/>
+            <a:off x="4081272" y="3877056"/>
             <a:ext cx="292608" cy="329184"/>
           </a:xfrm>
           <a:prstGeom prst="rect">
@@ -3448,7 +3573,7 @@
         </p:nvSpPr>
         <p:spPr>
           <a:xfrm>
-            <a:off x="7961376" y="3749040"/>
+            <a:off x="7961376" y="3877056"/>
             <a:ext cx="292608" cy="329184"/>
           </a:xfrm>
           <a:prstGeom prst="rect">
@@ -3487,7 +3612,7 @@
         </p:nvSpPr>
         <p:spPr>
           <a:xfrm>
-            <a:off x="365760" y="5632704"/>
+            <a:off x="365760" y="5577840"/>
             <a:ext cx="11457432" cy="475488"/>
           </a:xfrm>
           <a:prstGeom prst="roundRect">
@@ -3514,7 +3639,7 @@
         </p:nvSpPr>
         <p:spPr>
           <a:xfrm>
-            <a:off x="621792" y="5650992"/>
+            <a:off x="621792" y="5596128"/>
             <a:ext cx="10945368" cy="438912"/>
           </a:xfrm>
           <a:prstGeom prst="rect">

</xml_diff>

<commit_message>
Update goal bar to final wording
https://claude.ai/code/session_01KWybSEC2vfMTAERCxx1Z2W
</commit_message>
<xml_diff>
--- a/public/Inventory-at-Asurion.pptx
+++ b/public/Inventory-at-Asurion.pptx
@@ -3664,7 +3664,7 @@
                 <a:ea typeface="Calibri" pitchFamily="34" charset="-122"/>
                 <a:cs typeface="Calibri" pitchFamily="34" charset="-120"/>
               </a:rPr>
-              <a:t>At the end of this review, I hope that </a:t>
+              <a:t>At the end of this review, I hope you leave with a clear picture of </a:t>
             </a:r>
             <a:pPr indent="0" marL="0">
               <a:buNone/>
@@ -3678,7 +3678,7 @@
                 <a:ea typeface="Calibri" pitchFamily="34" charset="-122"/>
                 <a:cs typeface="Calibri" pitchFamily="34" charset="-120"/>
               </a:rPr>
-              <a:t>you leave with a clear understanding of the role inventory plays across every service program we run</a:t>
+              <a:t>how inventory moves across Asurion</a:t>
             </a:r>
             <a:pPr indent="0" marL="0">
               <a:buNone/>
@@ -3692,7 +3692,7 @@
                 <a:ea typeface="Calibri" pitchFamily="34" charset="-122"/>
                 <a:cs typeface="Calibri" pitchFamily="34" charset="-120"/>
               </a:rPr>
-              <a:t> — and why managing it with a single source of truth is not just an operational improvement, but a </a:t>
+              <a:t>, the scale it operates at, </a:t>
             </a:r>
             <a:pPr indent="0" marL="0">
               <a:buNone/>
@@ -3706,7 +3706,35 @@
                 <a:ea typeface="Calibri" pitchFamily="34" charset="-122"/>
                 <a:cs typeface="Calibri" pitchFamily="34" charset="-120"/>
               </a:rPr>
-              <a:t>strategic capability that enables Asurion to move faster, reduce financial risk, and scale with confidence.</a:t>
+              <a:t>where fragmentation creates real risk</a:t>
+            </a:r>
+            <a:pPr indent="0" marL="0">
+              <a:buNone/>
+            </a:pPr>
+            <a:r>
+              <a:rPr lang="en-US" sz="1150" i="1" dirty="0">
+                <a:solidFill>
+                  <a:srgbClr val="C4AEED"/>
+                </a:solidFill>
+                <a:latin typeface="Calibri" pitchFamily="34" charset="0"/>
+                <a:ea typeface="Calibri" pitchFamily="34" charset="-122"/>
+                <a:cs typeface="Calibri" pitchFamily="34" charset="-120"/>
+              </a:rPr>
+              <a:t>, and why </a:t>
+            </a:r>
+            <a:pPr indent="0" marL="0">
+              <a:buNone/>
+            </a:pPr>
+            <a:r>
+              <a:rPr lang="en-US" sz="1150" i="1" dirty="0">
+                <a:solidFill>
+                  <a:srgbClr val="FFFFFF"/>
+                </a:solidFill>
+                <a:latin typeface="Calibri" pitchFamily="34" charset="0"/>
+                <a:ea typeface="Calibri" pitchFamily="34" charset="-122"/>
+                <a:cs typeface="Calibri" pitchFamily="34" charset="-120"/>
+              </a:rPr>
+              <a:t>a single source of truth for inventory management matters.</a:t>
             </a:r>
             <a:endParaRPr lang="en-US" sz="1150" dirty="0"/>
           </a:p>

</xml_diff>

<commit_message>
Shorten goal bar wording
https://claude.ai/code/session_01KWybSEC2vfMTAERCxx1Z2W
</commit_message>
<xml_diff>
--- a/public/Inventory-at-Asurion.pptx
+++ b/public/Inventory-at-Asurion.pptx
@@ -3664,7 +3664,7 @@
                 <a:ea typeface="Calibri" pitchFamily="34" charset="-122"/>
                 <a:cs typeface="Calibri" pitchFamily="34" charset="-120"/>
               </a:rPr>
-              <a:t>At the end of this review, I hope you leave with a clear picture of </a:t>
+              <a:t>At the end of this review, I hope you leave understanding </a:t>
             </a:r>
             <a:pPr indent="0" marL="0">
               <a:buNone/>
@@ -3678,7 +3678,7 @@
                 <a:ea typeface="Calibri" pitchFamily="34" charset="-122"/>
                 <a:cs typeface="Calibri" pitchFamily="34" charset="-120"/>
               </a:rPr>
-              <a:t>how inventory moves across Asurion</a:t>
+              <a:t>the role inventory plays across Fulfillment</a:t>
             </a:r>
             <a:pPr indent="0" marL="0">
               <a:buNone/>
@@ -3692,7 +3692,7 @@
                 <a:ea typeface="Calibri" pitchFamily="34" charset="-122"/>
                 <a:cs typeface="Calibri" pitchFamily="34" charset="-120"/>
               </a:rPr>
-              <a:t>, the scale it operates at, </a:t>
+              <a:t>, where we are in the SSOT journey, and why it's a </a:t>
             </a:r>
             <a:pPr indent="0" marL="0">
               <a:buNone/>
@@ -3706,35 +3706,7 @@
                 <a:ea typeface="Calibri" pitchFamily="34" charset="-122"/>
                 <a:cs typeface="Calibri" pitchFamily="34" charset="-120"/>
               </a:rPr>
-              <a:t>where fragmentation creates real risk</a:t>
-            </a:r>
-            <a:pPr indent="0" marL="0">
-              <a:buNone/>
-            </a:pPr>
-            <a:r>
-              <a:rPr lang="en-US" sz="1150" i="1" dirty="0">
-                <a:solidFill>
-                  <a:srgbClr val="C4AEED"/>
-                </a:solidFill>
-                <a:latin typeface="Calibri" pitchFamily="34" charset="0"/>
-                <a:ea typeface="Calibri" pitchFamily="34" charset="-122"/>
-                <a:cs typeface="Calibri" pitchFamily="34" charset="-120"/>
-              </a:rPr>
-              <a:t>, and why </a:t>
-            </a:r>
-            <a:pPr indent="0" marL="0">
-              <a:buNone/>
-            </a:pPr>
-            <a:r>
-              <a:rPr lang="en-US" sz="1150" i="1" dirty="0">
-                <a:solidFill>
-                  <a:srgbClr val="FFFFFF"/>
-                </a:solidFill>
-                <a:latin typeface="Calibri" pitchFamily="34" charset="0"/>
-                <a:ea typeface="Calibri" pitchFamily="34" charset="-122"/>
-                <a:cs typeface="Calibri" pitchFamily="34" charset="-120"/>
-              </a:rPr>
-              <a:t>a single source of truth for inventory management matters.</a:t>
+              <a:t>strategic capability — not just an operational fix.</a:t>
             </a:r>
             <a:endParaRPr lang="en-US" sz="1150" dirty="0"/>
           </a:p>

</xml_diff>

<commit_message>
Finalize goal bar statement
https://claude.ai/code/session_01KWybSEC2vfMTAERCxx1Z2W
</commit_message>
<xml_diff>
--- a/public/Inventory-at-Asurion.pptx
+++ b/public/Inventory-at-Asurion.pptx
@@ -3692,7 +3692,7 @@
                 <a:ea typeface="Calibri" pitchFamily="34" charset="-122"/>
                 <a:cs typeface="Calibri" pitchFamily="34" charset="-120"/>
               </a:rPr>
-              <a:t>, where we are in the SSOT journey, and why it's a </a:t>
+              <a:t>, where we are in our single-source-of-truth journey, and its </a:t>
             </a:r>
             <a:pPr indent="0" marL="0">
               <a:buNone/>
@@ -3706,7 +3706,7 @@
                 <a:ea typeface="Calibri" pitchFamily="34" charset="-122"/>
                 <a:cs typeface="Calibri" pitchFamily="34" charset="-120"/>
               </a:rPr>
-              <a:t>strategic capability — not just an operational fix.</a:t>
+              <a:t>strategic value to the way we serve customers and run the business.</a:t>
             </a:r>
             <a:endParaRPr lang="en-US" sz="1150" dirty="0"/>
           </a:p>

</xml_diff>